<commit_message>
some pptx stuff more
</commit_message>
<xml_diff>
--- a/_posts/2026-07-13-contributing-enzyme-ifx-2025-3_assets/proposal/EuroAD_2029_ICON_Enzyme.pptx
+++ b/_posts/2026-07-13-contributing-enzyme-ifx-2025-3_assets/proposal/EuroAD_2029_ICON_Enzyme.pptx
@@ -21,7 +21,7 @@
   <p:sldIdLst>
     <p:sldId id="256" r:id="rId15"/>
   </p:sldIdLst>
-  <p:sldSz cx="41405175" cy="30275213"/>
+  <p:sldSz cx="42803763" cy="30275213"/>
   <p:notesSz cx="9928225" cy="6797675"/>
 </p:presentation>
 </file>
@@ -350,7 +350,7 @@
             <a:pPr indent="0" algn="r">
               <a:buNone/>
             </a:pPr>
-            <a:fld id="{4DAEF787-3C9C-45B2-A9F7-E94038A44E47}" type="slidenum">
+            <a:fld id="{1D1B2138-BE93-4C53-A871-92BF604E23E8}" type="slidenum">
               <a:rPr b="0" lang="en-US" sz="1400" spc="-1" strike="noStrike">
                 <a:solidFill>
                   <a:srgbClr val="000000"/>
@@ -393,7 +393,7 @@
       </p:grpSpPr>
       <p:sp>
         <p:nvSpPr>
-          <p:cNvPr id="79" name="PlaceHolder 1"/>
+          <p:cNvPr id="97" name="PlaceHolder 1"/>
           <p:cNvSpPr>
             <a:spLocks noGrp="1"/>
           </p:cNvSpPr>
@@ -404,7 +404,7 @@
         <p:spPr>
           <a:xfrm>
             <a:off x="5622480" y="6456240"/>
-            <a:ext cx="4303440" cy="339480"/>
+            <a:ext cx="4303800" cy="339840"/>
           </a:xfrm>
           <a:prstGeom prst="rect">
             <a:avLst/>
@@ -445,7 +445,7 @@
                 <a:tab algn="l" pos="0"/>
               </a:tabLst>
             </a:pPr>
-            <a:fld id="{EA4E193E-2754-47AC-BB74-B8C0E606DCA8}" type="slidenum">
+            <a:fld id="{9A6AC1F8-67F7-43BF-849C-48F3E490E2C6}" type="slidenum">
               <a:rPr b="0" lang="de-DE" sz="1200" spc="-1" strike="noStrike">
                 <a:solidFill>
                   <a:srgbClr val="000000"/>
@@ -465,7 +465,7 @@
       </p:sp>
       <p:sp>
         <p:nvSpPr>
-          <p:cNvPr id="80" name="PlaceHolder 2"/>
+          <p:cNvPr id="98" name="PlaceHolder 2"/>
           <p:cNvSpPr>
             <a:spLocks noGrp="1"/>
           </p:cNvSpPr>
@@ -475,8 +475,8 @@
         </p:nvSpPr>
         <p:spPr>
           <a:xfrm>
-            <a:off x="3224160" y="509760"/>
-            <a:ext cx="3483360" cy="2547000"/>
+            <a:off x="3165480" y="509760"/>
+            <a:ext cx="3601440" cy="2547360"/>
           </a:xfrm>
           <a:prstGeom prst="rect">
             <a:avLst/>
@@ -488,7 +488,7 @@
       </p:sp>
       <p:sp>
         <p:nvSpPr>
-          <p:cNvPr id="81" name="PlaceHolder 3"/>
+          <p:cNvPr id="99" name="PlaceHolder 3"/>
           <p:cNvSpPr>
             <a:spLocks noGrp="1"/>
           </p:cNvSpPr>
@@ -499,7 +499,7 @@
         <p:spPr>
           <a:xfrm>
             <a:off x="992520" y="3229200"/>
-            <a:ext cx="7941960" cy="3057120"/>
+            <a:ext cx="7942320" cy="3057480"/>
           </a:xfrm>
           <a:prstGeom prst="rect">
             <a:avLst/>
@@ -560,8 +560,8 @@
         </p:nvSpPr>
         <p:spPr>
           <a:xfrm>
-            <a:off x="2070000" y="1207800"/>
-            <a:ext cx="37263960" cy="5055480"/>
+            <a:off x="2139840" y="1207800"/>
+            <a:ext cx="38522880" cy="5055480"/>
           </a:xfrm>
           <a:prstGeom prst="rect">
             <a:avLst/>
@@ -600,8 +600,8 @@
         </p:nvSpPr>
         <p:spPr>
           <a:xfrm>
-            <a:off x="2070000" y="7084080"/>
-            <a:ext cx="37263960" cy="17559000"/>
+            <a:off x="2139840" y="7084080"/>
+            <a:ext cx="38522880" cy="17559000"/>
           </a:xfrm>
           <a:prstGeom prst="rect">
             <a:avLst/>
@@ -662,7 +662,7 @@
         <p:txBody>
           <a:bodyPr/>
           <a:p>
-            <a:fld id="{9DCD1E11-C2BC-4F0D-B668-9197F768DCBE}" type="slidenum">
+            <a:fld id="{917ECA90-F4AE-4816-ACD8-D7290ECD25D9}" type="slidenum">
               <a:t>&lt;#&gt;</a:t>
             </a:fld>
           </a:p>
@@ -745,7 +745,7 @@
         <p:txBody>
           <a:bodyPr/>
           <a:p>
-            <a:fld id="{46750227-EA85-43FE-8893-3C182DD69F00}" type="slidenum">
+            <a:fld id="{96B5E8B4-DE0D-4FF0-B6F8-B213CD37A155}" type="slidenum">
               <a:t>&lt;#&gt;</a:t>
             </a:fld>
           </a:p>
@@ -828,7 +828,7 @@
         <p:txBody>
           <a:bodyPr/>
           <a:p>
-            <a:fld id="{8CB04820-7709-43D6-AF85-3593A6D24801}" type="slidenum">
+            <a:fld id="{899A3018-A9DE-4A4D-8B99-F7F660D537D3}" type="slidenum">
               <a:t>&lt;#&gt;</a:t>
             </a:fld>
           </a:p>
@@ -911,7 +911,7 @@
         <p:txBody>
           <a:bodyPr/>
           <a:p>
-            <a:fld id="{67F810A1-D797-40B3-90F5-62B118349A5F}" type="slidenum">
+            <a:fld id="{812A2F23-AD48-41EA-A203-395089124514}" type="slidenum">
               <a:t>&lt;#&gt;</a:t>
             </a:fld>
           </a:p>
@@ -994,7 +994,7 @@
         <p:txBody>
           <a:bodyPr/>
           <a:p>
-            <a:fld id="{196875DB-EED1-40B5-986D-78A467D17E8A}" type="slidenum">
+            <a:fld id="{C012B6FC-B050-4D41-AAB2-41A9857346D7}" type="slidenum">
               <a:t>&lt;#&gt;</a:t>
             </a:fld>
           </a:p>
@@ -1077,7 +1077,7 @@
         <p:txBody>
           <a:bodyPr/>
           <a:p>
-            <a:fld id="{768003E6-2A50-46E9-8BB8-CFEFA9003A6F}" type="slidenum">
+            <a:fld id="{A562A331-42C4-40B7-833F-0D9131743A18}" type="slidenum">
               <a:t>&lt;#&gt;</a:t>
             </a:fld>
           </a:p>
@@ -1160,7 +1160,7 @@
         <p:txBody>
           <a:bodyPr/>
           <a:p>
-            <a:fld id="{1947F63B-AB90-4600-B4EE-D8B22CDC053C}" type="slidenum">
+            <a:fld id="{8765B25C-BFB7-46D6-A7A3-5A61D7D047C6}" type="slidenum">
               <a:t>&lt;#&gt;</a:t>
             </a:fld>
           </a:p>
@@ -1221,8 +1221,8 @@
         </p:nvSpPr>
         <p:spPr>
           <a:xfrm>
-            <a:off x="2070000" y="1207800"/>
-            <a:ext cx="37263960" cy="5055480"/>
+            <a:off x="2139840" y="1207800"/>
+            <a:ext cx="38522880" cy="5055480"/>
           </a:xfrm>
           <a:prstGeom prst="rect">
             <a:avLst/>
@@ -1261,8 +1261,8 @@
         </p:nvSpPr>
         <p:spPr>
           <a:xfrm>
-            <a:off x="2070000" y="7084080"/>
-            <a:ext cx="37263960" cy="17559000"/>
+            <a:off x="2139840" y="7084080"/>
+            <a:ext cx="38522880" cy="17559000"/>
           </a:xfrm>
           <a:prstGeom prst="rect">
             <a:avLst/>
@@ -1326,7 +1326,7 @@
         <p:txBody>
           <a:bodyPr/>
           <a:p>
-            <a:fld id="{EE3B3CB4-9207-4B74-9331-BDC0EA1A5A96}" type="slidenum">
+            <a:fld id="{F7DB4900-A1BF-4ACB-9644-2116966334B4}" type="slidenum">
               <a:t>&lt;#&gt;</a:t>
             </a:fld>
           </a:p>
@@ -1409,7 +1409,7 @@
         <p:txBody>
           <a:bodyPr/>
           <a:p>
-            <a:fld id="{048C1530-2B5F-47A6-89D5-9606C7E484FA}" type="slidenum">
+            <a:fld id="{6C46FC77-4133-43EB-B75A-3F5BC67984D4}" type="slidenum">
               <a:t>&lt;#&gt;</a:t>
             </a:fld>
           </a:p>
@@ -1470,8 +1470,8 @@
         </p:nvSpPr>
         <p:spPr>
           <a:xfrm>
-            <a:off x="2070000" y="1207800"/>
-            <a:ext cx="37263960" cy="5055480"/>
+            <a:off x="2139840" y="1207800"/>
+            <a:ext cx="38522880" cy="5055480"/>
           </a:xfrm>
           <a:prstGeom prst="rect">
             <a:avLst/>
@@ -1510,8 +1510,8 @@
         </p:nvSpPr>
         <p:spPr>
           <a:xfrm>
-            <a:off x="2070000" y="7084080"/>
-            <a:ext cx="18184680" cy="17559000"/>
+            <a:off x="2139840" y="7084080"/>
+            <a:ext cx="18798840" cy="17559000"/>
           </a:xfrm>
           <a:prstGeom prst="rect">
             <a:avLst/>
@@ -1553,8 +1553,8 @@
         </p:nvSpPr>
         <p:spPr>
           <a:xfrm>
-            <a:off x="21164400" y="7084080"/>
-            <a:ext cx="18184680" cy="17559000"/>
+            <a:off x="21879000" y="7084080"/>
+            <a:ext cx="18798840" cy="17559000"/>
           </a:xfrm>
           <a:prstGeom prst="rect">
             <a:avLst/>
@@ -1618,7 +1618,7 @@
         <p:txBody>
           <a:bodyPr/>
           <a:p>
-            <a:fld id="{325660E9-E1BB-4C7A-A4A1-904790677642}" type="slidenum">
+            <a:fld id="{910ED2E5-1566-4C56-AD8F-726CD86B4C65}" type="slidenum">
               <a:t>&lt;#&gt;</a:t>
             </a:fld>
           </a:p>
@@ -1701,7 +1701,7 @@
         <p:txBody>
           <a:bodyPr/>
           <a:p>
-            <a:fld id="{13BAE644-5E3A-4E59-956F-535CED8208DF}" type="slidenum">
+            <a:fld id="{A75A3A9F-DE60-44AB-ABFF-4DC9E1F50514}" type="slidenum">
               <a:t>&lt;#&gt;</a:t>
             </a:fld>
           </a:p>
@@ -1762,8 +1762,8 @@
         </p:nvSpPr>
         <p:spPr>
           <a:xfrm>
-            <a:off x="2070000" y="1207800"/>
-            <a:ext cx="37263960" cy="5055480"/>
+            <a:off x="2139840" y="1207800"/>
+            <a:ext cx="38522880" cy="5055480"/>
           </a:xfrm>
           <a:prstGeom prst="rect">
             <a:avLst/>
@@ -1824,7 +1824,7 @@
         <p:txBody>
           <a:bodyPr/>
           <a:p>
-            <a:fld id="{FF7B79C4-F2F3-4B4A-BA96-7738802BC8EC}" type="slidenum">
+            <a:fld id="{719FB457-88D8-4323-8926-ACF3DEDFAEA4}" type="slidenum">
               <a:t>&lt;#&gt;</a:t>
             </a:fld>
           </a:p>
@@ -1892,8 +1892,8 @@
         </p:nvSpPr>
         <p:spPr>
           <a:xfrm>
-            <a:off x="2070000" y="1207800"/>
-            <a:ext cx="37263600" cy="5055120"/>
+            <a:off x="2139840" y="1207800"/>
+            <a:ext cx="38522520" cy="5055120"/>
           </a:xfrm>
           <a:prstGeom prst="rect">
             <a:avLst/>
@@ -1918,7 +1918,313 @@
                 </a:solidFill>
                 <a:latin typeface="Arial"/>
               </a:rPr>
-              <a:t>Click to edit the title text format</a:t>
+              <a:t>C</a:t>
+            </a:r>
+            <a:r>
+              <a:rPr b="0" lang="en-US" sz="1800" spc="-1" strike="noStrike">
+                <a:solidFill>
+                  <a:srgbClr val="000000"/>
+                </a:solidFill>
+                <a:latin typeface="Arial"/>
+              </a:rPr>
+              <a:t>l</a:t>
+            </a:r>
+            <a:r>
+              <a:rPr b="0" lang="en-US" sz="1800" spc="-1" strike="noStrike">
+                <a:solidFill>
+                  <a:srgbClr val="000000"/>
+                </a:solidFill>
+                <a:latin typeface="Arial"/>
+              </a:rPr>
+              <a:t>i</a:t>
+            </a:r>
+            <a:r>
+              <a:rPr b="0" lang="en-US" sz="1800" spc="-1" strike="noStrike">
+                <a:solidFill>
+                  <a:srgbClr val="000000"/>
+                </a:solidFill>
+                <a:latin typeface="Arial"/>
+              </a:rPr>
+              <a:t>c</a:t>
+            </a:r>
+            <a:r>
+              <a:rPr b="0" lang="en-US" sz="1800" spc="-1" strike="noStrike">
+                <a:solidFill>
+                  <a:srgbClr val="000000"/>
+                </a:solidFill>
+                <a:latin typeface="Arial"/>
+              </a:rPr>
+              <a:t>k</a:t>
+            </a:r>
+            <a:r>
+              <a:rPr b="0" lang="en-US" sz="1800" spc="-1" strike="noStrike">
+                <a:solidFill>
+                  <a:srgbClr val="000000"/>
+                </a:solidFill>
+                <a:latin typeface="Arial"/>
+              </a:rPr>
+              <a:t> </a:t>
+            </a:r>
+            <a:r>
+              <a:rPr b="0" lang="en-US" sz="1800" spc="-1" strike="noStrike">
+                <a:solidFill>
+                  <a:srgbClr val="000000"/>
+                </a:solidFill>
+                <a:latin typeface="Arial"/>
+              </a:rPr>
+              <a:t>t</a:t>
+            </a:r>
+            <a:r>
+              <a:rPr b="0" lang="en-US" sz="1800" spc="-1" strike="noStrike">
+                <a:solidFill>
+                  <a:srgbClr val="000000"/>
+                </a:solidFill>
+                <a:latin typeface="Arial"/>
+              </a:rPr>
+              <a:t>o</a:t>
+            </a:r>
+            <a:r>
+              <a:rPr b="0" lang="en-US" sz="1800" spc="-1" strike="noStrike">
+                <a:solidFill>
+                  <a:srgbClr val="000000"/>
+                </a:solidFill>
+                <a:latin typeface="Arial"/>
+              </a:rPr>
+              <a:t> </a:t>
+            </a:r>
+            <a:r>
+              <a:rPr b="0" lang="en-US" sz="1800" spc="-1" strike="noStrike">
+                <a:solidFill>
+                  <a:srgbClr val="000000"/>
+                </a:solidFill>
+                <a:latin typeface="Arial"/>
+              </a:rPr>
+              <a:t>e</a:t>
+            </a:r>
+            <a:r>
+              <a:rPr b="0" lang="en-US" sz="1800" spc="-1" strike="noStrike">
+                <a:solidFill>
+                  <a:srgbClr val="000000"/>
+                </a:solidFill>
+                <a:latin typeface="Arial"/>
+              </a:rPr>
+              <a:t>d</a:t>
+            </a:r>
+            <a:r>
+              <a:rPr b="0" lang="en-US" sz="1800" spc="-1" strike="noStrike">
+                <a:solidFill>
+                  <a:srgbClr val="000000"/>
+                </a:solidFill>
+                <a:latin typeface="Arial"/>
+              </a:rPr>
+              <a:t>i</a:t>
+            </a:r>
+            <a:r>
+              <a:rPr b="0" lang="en-US" sz="1800" spc="-1" strike="noStrike">
+                <a:solidFill>
+                  <a:srgbClr val="000000"/>
+                </a:solidFill>
+                <a:latin typeface="Arial"/>
+              </a:rPr>
+              <a:t>t</a:t>
+            </a:r>
+            <a:r>
+              <a:rPr b="0" lang="en-US" sz="1800" spc="-1" strike="noStrike">
+                <a:solidFill>
+                  <a:srgbClr val="000000"/>
+                </a:solidFill>
+                <a:latin typeface="Arial"/>
+              </a:rPr>
+              <a:t> </a:t>
+            </a:r>
+            <a:r>
+              <a:rPr b="0" lang="en-US" sz="1800" spc="-1" strike="noStrike">
+                <a:solidFill>
+                  <a:srgbClr val="000000"/>
+                </a:solidFill>
+                <a:latin typeface="Arial"/>
+              </a:rPr>
+              <a:t>t</a:t>
+            </a:r>
+            <a:r>
+              <a:rPr b="0" lang="en-US" sz="1800" spc="-1" strike="noStrike">
+                <a:solidFill>
+                  <a:srgbClr val="000000"/>
+                </a:solidFill>
+                <a:latin typeface="Arial"/>
+              </a:rPr>
+              <a:t>h</a:t>
+            </a:r>
+            <a:r>
+              <a:rPr b="0" lang="en-US" sz="1800" spc="-1" strike="noStrike">
+                <a:solidFill>
+                  <a:srgbClr val="000000"/>
+                </a:solidFill>
+                <a:latin typeface="Arial"/>
+              </a:rPr>
+              <a:t>e</a:t>
+            </a:r>
+            <a:r>
+              <a:rPr b="0" lang="en-US" sz="1800" spc="-1" strike="noStrike">
+                <a:solidFill>
+                  <a:srgbClr val="000000"/>
+                </a:solidFill>
+                <a:latin typeface="Arial"/>
+              </a:rPr>
+              <a:t> </a:t>
+            </a:r>
+            <a:r>
+              <a:rPr b="0" lang="en-US" sz="1800" spc="-1" strike="noStrike">
+                <a:solidFill>
+                  <a:srgbClr val="000000"/>
+                </a:solidFill>
+                <a:latin typeface="Arial"/>
+              </a:rPr>
+              <a:t>t</a:t>
+            </a:r>
+            <a:r>
+              <a:rPr b="0" lang="en-US" sz="1800" spc="-1" strike="noStrike">
+                <a:solidFill>
+                  <a:srgbClr val="000000"/>
+                </a:solidFill>
+                <a:latin typeface="Arial"/>
+              </a:rPr>
+              <a:t>i</a:t>
+            </a:r>
+            <a:r>
+              <a:rPr b="0" lang="en-US" sz="1800" spc="-1" strike="noStrike">
+                <a:solidFill>
+                  <a:srgbClr val="000000"/>
+                </a:solidFill>
+                <a:latin typeface="Arial"/>
+              </a:rPr>
+              <a:t>t</a:t>
+            </a:r>
+            <a:r>
+              <a:rPr b="0" lang="en-US" sz="1800" spc="-1" strike="noStrike">
+                <a:solidFill>
+                  <a:srgbClr val="000000"/>
+                </a:solidFill>
+                <a:latin typeface="Arial"/>
+              </a:rPr>
+              <a:t>l</a:t>
+            </a:r>
+            <a:r>
+              <a:rPr b="0" lang="en-US" sz="1800" spc="-1" strike="noStrike">
+                <a:solidFill>
+                  <a:srgbClr val="000000"/>
+                </a:solidFill>
+                <a:latin typeface="Arial"/>
+              </a:rPr>
+              <a:t>e</a:t>
+            </a:r>
+            <a:r>
+              <a:rPr b="0" lang="en-US" sz="1800" spc="-1" strike="noStrike">
+                <a:solidFill>
+                  <a:srgbClr val="000000"/>
+                </a:solidFill>
+                <a:latin typeface="Arial"/>
+              </a:rPr>
+              <a:t> </a:t>
+            </a:r>
+            <a:r>
+              <a:rPr b="0" lang="en-US" sz="1800" spc="-1" strike="noStrike">
+                <a:solidFill>
+                  <a:srgbClr val="000000"/>
+                </a:solidFill>
+                <a:latin typeface="Arial"/>
+              </a:rPr>
+              <a:t>t</a:t>
+            </a:r>
+            <a:r>
+              <a:rPr b="0" lang="en-US" sz="1800" spc="-1" strike="noStrike">
+                <a:solidFill>
+                  <a:srgbClr val="000000"/>
+                </a:solidFill>
+                <a:latin typeface="Arial"/>
+              </a:rPr>
+              <a:t>e</a:t>
+            </a:r>
+            <a:r>
+              <a:rPr b="0" lang="en-US" sz="1800" spc="-1" strike="noStrike">
+                <a:solidFill>
+                  <a:srgbClr val="000000"/>
+                </a:solidFill>
+                <a:latin typeface="Arial"/>
+              </a:rPr>
+              <a:t>x</a:t>
+            </a:r>
+            <a:r>
+              <a:rPr b="0" lang="en-US" sz="1800" spc="-1" strike="noStrike">
+                <a:solidFill>
+                  <a:srgbClr val="000000"/>
+                </a:solidFill>
+                <a:latin typeface="Arial"/>
+              </a:rPr>
+              <a:t>t</a:t>
+            </a:r>
+            <a:r>
+              <a:rPr b="0" lang="en-US" sz="1800" spc="-1" strike="noStrike">
+                <a:solidFill>
+                  <a:srgbClr val="000000"/>
+                </a:solidFill>
+                <a:latin typeface="Arial"/>
+              </a:rPr>
+              <a:t> </a:t>
+            </a:r>
+            <a:r>
+              <a:rPr b="0" lang="en-US" sz="1800" spc="-1" strike="noStrike">
+                <a:solidFill>
+                  <a:srgbClr val="000000"/>
+                </a:solidFill>
+                <a:latin typeface="Arial"/>
+              </a:rPr>
+              <a:t>f</a:t>
+            </a:r>
+            <a:r>
+              <a:rPr b="0" lang="en-US" sz="1800" spc="-1" strike="noStrike">
+                <a:solidFill>
+                  <a:srgbClr val="000000"/>
+                </a:solidFill>
+                <a:latin typeface="Arial"/>
+              </a:rPr>
+              <a:t>o</a:t>
+            </a:r>
+            <a:r>
+              <a:rPr b="0" lang="en-US" sz="1800" spc="-1" strike="noStrike">
+                <a:solidFill>
+                  <a:srgbClr val="000000"/>
+                </a:solidFill>
+                <a:latin typeface="Arial"/>
+              </a:rPr>
+              <a:t>r</a:t>
+            </a:r>
+            <a:r>
+              <a:rPr b="0" lang="en-US" sz="1800" spc="-1" strike="noStrike">
+                <a:solidFill>
+                  <a:srgbClr val="000000"/>
+                </a:solidFill>
+                <a:latin typeface="Arial"/>
+              </a:rPr>
+              <a:t>m</a:t>
+            </a:r>
+            <a:r>
+              <a:rPr b="0" lang="en-US" sz="1800" spc="-1" strike="noStrike">
+                <a:solidFill>
+                  <a:srgbClr val="000000"/>
+                </a:solidFill>
+                <a:latin typeface="Arial"/>
+              </a:rPr>
+              <a:t>a</a:t>
+            </a:r>
+            <a:r>
+              <a:rPr b="0" lang="en-US" sz="1800" spc="-1" strike="noStrike">
+                <a:solidFill>
+                  <a:srgbClr val="000000"/>
+                </a:solidFill>
+                <a:latin typeface="Arial"/>
+              </a:rPr>
+              <a:t>t</a:t>
             </a:r>
             <a:endParaRPr b="0" lang="en-US" sz="1800" spc="-1" strike="noStrike">
               <a:solidFill>
@@ -1941,8 +2247,8 @@
         </p:nvSpPr>
         <p:spPr>
           <a:xfrm>
-            <a:off x="14146200" y="27581760"/>
-            <a:ext cx="13111560" cy="2017080"/>
+            <a:off x="14623920" y="27581760"/>
+            <a:ext cx="13555080" cy="2017440"/>
           </a:xfrm>
           <a:prstGeom prst="rect">
             <a:avLst/>
@@ -2013,8 +2319,8 @@
         </p:nvSpPr>
         <p:spPr>
           <a:xfrm>
-            <a:off x="29678400" y="27581760"/>
-            <a:ext cx="8623800" cy="2017080"/>
+            <a:off x="30680640" y="27581760"/>
+            <a:ext cx="8915400" cy="2017440"/>
           </a:xfrm>
           <a:prstGeom prst="rect">
             <a:avLst/>
@@ -2029,7 +2335,7 @@
             <a:noAutofit/>
           </a:bodyPr>
           <a:lstStyle>
-            <a:lvl1pPr indent="0" algn="r" defTabSz="3897720">
+            <a:lvl1pPr indent="0" algn="r" defTabSz="3855240">
               <a:lnSpc>
                 <a:spcPct val="100000"/>
               </a:lnSpc>
@@ -2037,7 +2343,7 @@
               <a:tabLst>
                 <a:tab algn="l" pos="0"/>
               </a:tabLst>
-              <a:defRPr b="0" lang="de-DE" sz="6130" spc="-1" strike="noStrike">
+              <a:defRPr b="0" lang="de-DE" sz="6060" spc="-1" strike="noStrike">
                 <a:solidFill>
                   <a:schemeClr val="dk1"/>
                 </a:solidFill>
@@ -2046,7 +2352,7 @@
             </a:lvl1pPr>
           </a:lstStyle>
           <a:p>
-            <a:pPr indent="0" algn="r" defTabSz="3897720">
+            <a:pPr indent="0" algn="r" defTabSz="3855240">
               <a:lnSpc>
                 <a:spcPct val="100000"/>
               </a:lnSpc>
@@ -2055,8 +2361,8 @@
                 <a:tab algn="l" pos="0"/>
               </a:tabLst>
             </a:pPr>
-            <a:fld id="{C042BE53-FAD2-41E4-9684-130BBE2A6DDD}" type="slidenum">
-              <a:rPr b="0" lang="de-DE" sz="6130" spc="-1" strike="noStrike">
+            <a:fld id="{5E5EE3D0-C738-4AE1-A7DF-30323497EB08}" type="slidenum">
+              <a:rPr b="0" lang="de-DE" sz="6060" spc="-1" strike="noStrike">
                 <a:solidFill>
                   <a:schemeClr val="dk1"/>
                 </a:solidFill>
@@ -2064,7 +2370,7 @@
               </a:rPr>
               <a:t>&lt;number&gt;</a:t>
             </a:fld>
-            <a:endParaRPr b="0" lang="en-US" sz="6130" spc="-1" strike="noStrike">
+            <a:endParaRPr b="0" lang="en-US" sz="6060" spc="-1" strike="noStrike">
               <a:solidFill>
                 <a:srgbClr val="000000"/>
               </a:solidFill>
@@ -2085,8 +2391,8 @@
         </p:nvSpPr>
         <p:spPr>
           <a:xfrm>
-            <a:off x="3102120" y="27581760"/>
-            <a:ext cx="8623800" cy="2017080"/>
+            <a:off x="3206880" y="27581760"/>
+            <a:ext cx="8915400" cy="2017440"/>
           </a:xfrm>
           <a:prstGeom prst="rect">
             <a:avLst/>
@@ -2178,8 +2484,8 @@
         </p:nvSpPr>
         <p:spPr>
           <a:xfrm>
-            <a:off x="14146200" y="27581760"/>
-            <a:ext cx="13111560" cy="2017080"/>
+            <a:off x="14623920" y="27581760"/>
+            <a:ext cx="13555080" cy="2017440"/>
           </a:xfrm>
           <a:prstGeom prst="rect">
             <a:avLst/>
@@ -2250,8 +2556,8 @@
         </p:nvSpPr>
         <p:spPr>
           <a:xfrm>
-            <a:off x="29678400" y="27581760"/>
-            <a:ext cx="8623800" cy="2017080"/>
+            <a:off x="30680640" y="27581760"/>
+            <a:ext cx="8915400" cy="2017440"/>
           </a:xfrm>
           <a:prstGeom prst="rect">
             <a:avLst/>
@@ -2266,7 +2572,7 @@
             <a:noAutofit/>
           </a:bodyPr>
           <a:lstStyle>
-            <a:lvl1pPr indent="0" algn="r" defTabSz="3897720">
+            <a:lvl1pPr indent="0" algn="r" defTabSz="3855240">
               <a:lnSpc>
                 <a:spcPct val="100000"/>
               </a:lnSpc>
@@ -2274,7 +2580,7 @@
               <a:tabLst>
                 <a:tab algn="l" pos="0"/>
               </a:tabLst>
-              <a:defRPr b="0" lang="de-DE" sz="6130" spc="-1" strike="noStrike">
+              <a:defRPr b="0" lang="de-DE" sz="6060" spc="-1" strike="noStrike">
                 <a:solidFill>
                   <a:schemeClr val="dk1"/>
                 </a:solidFill>
@@ -2283,7 +2589,7 @@
             </a:lvl1pPr>
           </a:lstStyle>
           <a:p>
-            <a:pPr indent="0" algn="r" defTabSz="3897720">
+            <a:pPr indent="0" algn="r" defTabSz="3855240">
               <a:lnSpc>
                 <a:spcPct val="100000"/>
               </a:lnSpc>
@@ -2292,8 +2598,8 @@
                 <a:tab algn="l" pos="0"/>
               </a:tabLst>
             </a:pPr>
-            <a:fld id="{8986CE05-1A2D-4692-899D-CCC882D6DDFB}" type="slidenum">
-              <a:rPr b="0" lang="de-DE" sz="6130" spc="-1" strike="noStrike">
+            <a:fld id="{7E93F8B9-3A69-445A-A8E3-B202315D1B59}" type="slidenum">
+              <a:rPr b="0" lang="de-DE" sz="6060" spc="-1" strike="noStrike">
                 <a:solidFill>
                   <a:schemeClr val="dk1"/>
                 </a:solidFill>
@@ -2301,7 +2607,7 @@
               </a:rPr>
               <a:t>&lt;number&gt;</a:t>
             </a:fld>
-            <a:endParaRPr b="0" lang="en-US" sz="6130" spc="-1" strike="noStrike">
+            <a:endParaRPr b="0" lang="en-US" sz="6060" spc="-1" strike="noStrike">
               <a:solidFill>
                 <a:srgbClr val="000000"/>
               </a:solidFill>
@@ -2322,8 +2628,8 @@
         </p:nvSpPr>
         <p:spPr>
           <a:xfrm>
-            <a:off x="3102120" y="27581760"/>
-            <a:ext cx="8623800" cy="2017080"/>
+            <a:off x="3206880" y="27581760"/>
+            <a:ext cx="8915400" cy="2017440"/>
           </a:xfrm>
           <a:prstGeom prst="rect">
             <a:avLst/>
@@ -2415,8 +2721,8 @@
         </p:nvSpPr>
         <p:spPr>
           <a:xfrm>
-            <a:off x="14146200" y="27581760"/>
-            <a:ext cx="13111560" cy="2017080"/>
+            <a:off x="14623920" y="27581760"/>
+            <a:ext cx="13555080" cy="2017440"/>
           </a:xfrm>
           <a:prstGeom prst="rect">
             <a:avLst/>
@@ -2487,8 +2793,8 @@
         </p:nvSpPr>
         <p:spPr>
           <a:xfrm>
-            <a:off x="29678400" y="27581760"/>
-            <a:ext cx="8623800" cy="2017080"/>
+            <a:off x="30680640" y="27581760"/>
+            <a:ext cx="8915400" cy="2017440"/>
           </a:xfrm>
           <a:prstGeom prst="rect">
             <a:avLst/>
@@ -2503,7 +2809,7 @@
             <a:noAutofit/>
           </a:bodyPr>
           <a:lstStyle>
-            <a:lvl1pPr indent="0" algn="r" defTabSz="3897720">
+            <a:lvl1pPr indent="0" algn="r" defTabSz="3855240">
               <a:lnSpc>
                 <a:spcPct val="100000"/>
               </a:lnSpc>
@@ -2511,7 +2817,7 @@
               <a:tabLst>
                 <a:tab algn="l" pos="0"/>
               </a:tabLst>
-              <a:defRPr b="0" lang="de-DE" sz="6130" spc="-1" strike="noStrike">
+              <a:defRPr b="0" lang="de-DE" sz="6060" spc="-1" strike="noStrike">
                 <a:solidFill>
                   <a:schemeClr val="dk1"/>
                 </a:solidFill>
@@ -2520,7 +2826,7 @@
             </a:lvl1pPr>
           </a:lstStyle>
           <a:p>
-            <a:pPr indent="0" algn="r" defTabSz="3897720">
+            <a:pPr indent="0" algn="r" defTabSz="3855240">
               <a:lnSpc>
                 <a:spcPct val="100000"/>
               </a:lnSpc>
@@ -2529,8 +2835,8 @@
                 <a:tab algn="l" pos="0"/>
               </a:tabLst>
             </a:pPr>
-            <a:fld id="{95F534E8-3570-4E53-83BB-E6EEBE149305}" type="slidenum">
-              <a:rPr b="0" lang="de-DE" sz="6130" spc="-1" strike="noStrike">
+            <a:fld id="{9EDE795B-A4C9-49B8-B83F-2006D3498DED}" type="slidenum">
+              <a:rPr b="0" lang="de-DE" sz="6060" spc="-1" strike="noStrike">
                 <a:solidFill>
                   <a:schemeClr val="dk1"/>
                 </a:solidFill>
@@ -2538,7 +2844,7 @@
               </a:rPr>
               <a:t>&lt;number&gt;</a:t>
             </a:fld>
-            <a:endParaRPr b="0" lang="en-US" sz="6130" spc="-1" strike="noStrike">
+            <a:endParaRPr b="0" lang="en-US" sz="6060" spc="-1" strike="noStrike">
               <a:solidFill>
                 <a:srgbClr val="000000"/>
               </a:solidFill>
@@ -2559,8 +2865,8 @@
         </p:nvSpPr>
         <p:spPr>
           <a:xfrm>
-            <a:off x="3102120" y="27581760"/>
-            <a:ext cx="8623800" cy="2017080"/>
+            <a:off x="3206880" y="27581760"/>
+            <a:ext cx="8915400" cy="2017440"/>
           </a:xfrm>
           <a:prstGeom prst="rect">
             <a:avLst/>
@@ -2652,8 +2958,8 @@
         </p:nvSpPr>
         <p:spPr>
           <a:xfrm>
-            <a:off x="14146200" y="27581760"/>
-            <a:ext cx="13111560" cy="2017080"/>
+            <a:off x="14623920" y="27581760"/>
+            <a:ext cx="13555080" cy="2017440"/>
           </a:xfrm>
           <a:prstGeom prst="rect">
             <a:avLst/>
@@ -2724,8 +3030,8 @@
         </p:nvSpPr>
         <p:spPr>
           <a:xfrm>
-            <a:off x="29678400" y="27581760"/>
-            <a:ext cx="8623800" cy="2017080"/>
+            <a:off x="30680640" y="27581760"/>
+            <a:ext cx="8915400" cy="2017440"/>
           </a:xfrm>
           <a:prstGeom prst="rect">
             <a:avLst/>
@@ -2740,7 +3046,7 @@
             <a:noAutofit/>
           </a:bodyPr>
           <a:lstStyle>
-            <a:lvl1pPr indent="0" algn="r" defTabSz="3897720">
+            <a:lvl1pPr indent="0" algn="r" defTabSz="3855240">
               <a:lnSpc>
                 <a:spcPct val="100000"/>
               </a:lnSpc>
@@ -2748,7 +3054,7 @@
               <a:tabLst>
                 <a:tab algn="l" pos="0"/>
               </a:tabLst>
-              <a:defRPr b="0" lang="de-DE" sz="6130" spc="-1" strike="noStrike">
+              <a:defRPr b="0" lang="de-DE" sz="6060" spc="-1" strike="noStrike">
                 <a:solidFill>
                   <a:schemeClr val="dk1"/>
                 </a:solidFill>
@@ -2757,7 +3063,7 @@
             </a:lvl1pPr>
           </a:lstStyle>
           <a:p>
-            <a:pPr indent="0" algn="r" defTabSz="3897720">
+            <a:pPr indent="0" algn="r" defTabSz="3855240">
               <a:lnSpc>
                 <a:spcPct val="100000"/>
               </a:lnSpc>
@@ -2766,8 +3072,8 @@
                 <a:tab algn="l" pos="0"/>
               </a:tabLst>
             </a:pPr>
-            <a:fld id="{F91892F2-ECD7-45C1-A56A-FF3736ED97A6}" type="slidenum">
-              <a:rPr b="0" lang="de-DE" sz="6130" spc="-1" strike="noStrike">
+            <a:fld id="{ECCF7E9E-40E0-4BAF-8A20-025FDEF0C06C}" type="slidenum">
+              <a:rPr b="0" lang="de-DE" sz="6060" spc="-1" strike="noStrike">
                 <a:solidFill>
                   <a:schemeClr val="dk1"/>
                 </a:solidFill>
@@ -2775,7 +3081,7 @@
               </a:rPr>
               <a:t>&lt;number&gt;</a:t>
             </a:fld>
-            <a:endParaRPr b="0" lang="en-US" sz="6130" spc="-1" strike="noStrike">
+            <a:endParaRPr b="0" lang="en-US" sz="6060" spc="-1" strike="noStrike">
               <a:solidFill>
                 <a:srgbClr val="000000"/>
               </a:solidFill>
@@ -2796,8 +3102,8 @@
         </p:nvSpPr>
         <p:spPr>
           <a:xfrm>
-            <a:off x="3102120" y="27581760"/>
-            <a:ext cx="8623800" cy="2017080"/>
+            <a:off x="3206880" y="27581760"/>
+            <a:ext cx="8915400" cy="2017440"/>
           </a:xfrm>
           <a:prstGeom prst="rect">
             <a:avLst/>
@@ -2889,8 +3195,8 @@
         </p:nvSpPr>
         <p:spPr>
           <a:xfrm>
-            <a:off x="14146200" y="27581760"/>
-            <a:ext cx="13111560" cy="2017080"/>
+            <a:off x="14623920" y="27581760"/>
+            <a:ext cx="13555080" cy="2017440"/>
           </a:xfrm>
           <a:prstGeom prst="rect">
             <a:avLst/>
@@ -2961,8 +3267,8 @@
         </p:nvSpPr>
         <p:spPr>
           <a:xfrm>
-            <a:off x="29678400" y="27581760"/>
-            <a:ext cx="8623800" cy="2017080"/>
+            <a:off x="30680640" y="27581760"/>
+            <a:ext cx="8915400" cy="2017440"/>
           </a:xfrm>
           <a:prstGeom prst="rect">
             <a:avLst/>
@@ -2977,7 +3283,7 @@
             <a:noAutofit/>
           </a:bodyPr>
           <a:lstStyle>
-            <a:lvl1pPr indent="0" algn="r" defTabSz="3897720">
+            <a:lvl1pPr indent="0" algn="r" defTabSz="3855240">
               <a:lnSpc>
                 <a:spcPct val="100000"/>
               </a:lnSpc>
@@ -2985,7 +3291,7 @@
               <a:tabLst>
                 <a:tab algn="l" pos="0"/>
               </a:tabLst>
-              <a:defRPr b="0" lang="de-DE" sz="6130" spc="-1" strike="noStrike">
+              <a:defRPr b="0" lang="de-DE" sz="6060" spc="-1" strike="noStrike">
                 <a:solidFill>
                   <a:schemeClr val="dk1"/>
                 </a:solidFill>
@@ -2994,7 +3300,7 @@
             </a:lvl1pPr>
           </a:lstStyle>
           <a:p>
-            <a:pPr indent="0" algn="r" defTabSz="3897720">
+            <a:pPr indent="0" algn="r" defTabSz="3855240">
               <a:lnSpc>
                 <a:spcPct val="100000"/>
               </a:lnSpc>
@@ -3003,8 +3309,8 @@
                 <a:tab algn="l" pos="0"/>
               </a:tabLst>
             </a:pPr>
-            <a:fld id="{50855C04-E04D-4E43-9195-F579EC1A20A7}" type="slidenum">
-              <a:rPr b="0" lang="de-DE" sz="6130" spc="-1" strike="noStrike">
+            <a:fld id="{AC33D985-C81B-41E8-9FC9-1F477E59FADE}" type="slidenum">
+              <a:rPr b="0" lang="de-DE" sz="6060" spc="-1" strike="noStrike">
                 <a:solidFill>
                   <a:schemeClr val="dk1"/>
                 </a:solidFill>
@@ -3012,7 +3318,7 @@
               </a:rPr>
               <a:t>&lt;number&gt;</a:t>
             </a:fld>
-            <a:endParaRPr b="0" lang="en-US" sz="6130" spc="-1" strike="noStrike">
+            <a:endParaRPr b="0" lang="en-US" sz="6060" spc="-1" strike="noStrike">
               <a:solidFill>
                 <a:srgbClr val="000000"/>
               </a:solidFill>
@@ -3033,8 +3339,8 @@
         </p:nvSpPr>
         <p:spPr>
           <a:xfrm>
-            <a:off x="3102120" y="27581760"/>
-            <a:ext cx="8623800" cy="2017080"/>
+            <a:off x="3206880" y="27581760"/>
+            <a:ext cx="8915400" cy="2017440"/>
           </a:xfrm>
           <a:prstGeom prst="rect">
             <a:avLst/>
@@ -3126,8 +3432,8 @@
         </p:nvSpPr>
         <p:spPr>
           <a:xfrm>
-            <a:off x="14146200" y="27581760"/>
-            <a:ext cx="13111560" cy="2017080"/>
+            <a:off x="14623920" y="27581760"/>
+            <a:ext cx="13555080" cy="2017440"/>
           </a:xfrm>
           <a:prstGeom prst="rect">
             <a:avLst/>
@@ -3198,8 +3504,8 @@
         </p:nvSpPr>
         <p:spPr>
           <a:xfrm>
-            <a:off x="29678400" y="27581760"/>
-            <a:ext cx="8623800" cy="2017080"/>
+            <a:off x="30680640" y="27581760"/>
+            <a:ext cx="8915400" cy="2017440"/>
           </a:xfrm>
           <a:prstGeom prst="rect">
             <a:avLst/>
@@ -3214,7 +3520,7 @@
             <a:noAutofit/>
           </a:bodyPr>
           <a:lstStyle>
-            <a:lvl1pPr indent="0" algn="r" defTabSz="3897720">
+            <a:lvl1pPr indent="0" algn="r" defTabSz="3855240">
               <a:lnSpc>
                 <a:spcPct val="100000"/>
               </a:lnSpc>
@@ -3222,7 +3528,7 @@
               <a:tabLst>
                 <a:tab algn="l" pos="0"/>
               </a:tabLst>
-              <a:defRPr b="0" lang="de-DE" sz="6130" spc="-1" strike="noStrike">
+              <a:defRPr b="0" lang="de-DE" sz="6060" spc="-1" strike="noStrike">
                 <a:solidFill>
                   <a:schemeClr val="dk1"/>
                 </a:solidFill>
@@ -3231,7 +3537,7 @@
             </a:lvl1pPr>
           </a:lstStyle>
           <a:p>
-            <a:pPr indent="0" algn="r" defTabSz="3897720">
+            <a:pPr indent="0" algn="r" defTabSz="3855240">
               <a:lnSpc>
                 <a:spcPct val="100000"/>
               </a:lnSpc>
@@ -3240,8 +3546,8 @@
                 <a:tab algn="l" pos="0"/>
               </a:tabLst>
             </a:pPr>
-            <a:fld id="{E1590601-65ED-4CB2-99F3-0044BE0FFD08}" type="slidenum">
-              <a:rPr b="0" lang="de-DE" sz="6130" spc="-1" strike="noStrike">
+            <a:fld id="{93A98A7F-8DCF-49E5-81C0-9CB4EC1821F0}" type="slidenum">
+              <a:rPr b="0" lang="de-DE" sz="6060" spc="-1" strike="noStrike">
                 <a:solidFill>
                   <a:schemeClr val="dk1"/>
                 </a:solidFill>
@@ -3249,7 +3555,7 @@
               </a:rPr>
               <a:t>&lt;number&gt;</a:t>
             </a:fld>
-            <a:endParaRPr b="0" lang="en-US" sz="6130" spc="-1" strike="noStrike">
+            <a:endParaRPr b="0" lang="en-US" sz="6060" spc="-1" strike="noStrike">
               <a:solidFill>
                 <a:srgbClr val="000000"/>
               </a:solidFill>
@@ -3270,8 +3576,8 @@
         </p:nvSpPr>
         <p:spPr>
           <a:xfrm>
-            <a:off x="3102120" y="27581760"/>
-            <a:ext cx="8623800" cy="2017080"/>
+            <a:off x="3206880" y="27581760"/>
+            <a:ext cx="8915400" cy="2017440"/>
           </a:xfrm>
           <a:prstGeom prst="rect">
             <a:avLst/>
@@ -3363,8 +3669,8 @@
         </p:nvSpPr>
         <p:spPr>
           <a:xfrm>
-            <a:off x="14146200" y="27581760"/>
-            <a:ext cx="13111560" cy="2017080"/>
+            <a:off x="14623920" y="27581760"/>
+            <a:ext cx="13555080" cy="2017440"/>
           </a:xfrm>
           <a:prstGeom prst="rect">
             <a:avLst/>
@@ -3435,8 +3741,8 @@
         </p:nvSpPr>
         <p:spPr>
           <a:xfrm>
-            <a:off x="29678400" y="27581760"/>
-            <a:ext cx="8623800" cy="2017080"/>
+            <a:off x="30680640" y="27581760"/>
+            <a:ext cx="8915400" cy="2017440"/>
           </a:xfrm>
           <a:prstGeom prst="rect">
             <a:avLst/>
@@ -3451,7 +3757,7 @@
             <a:noAutofit/>
           </a:bodyPr>
           <a:lstStyle>
-            <a:lvl1pPr indent="0" algn="r" defTabSz="3897720">
+            <a:lvl1pPr indent="0" algn="r" defTabSz="3855240">
               <a:lnSpc>
                 <a:spcPct val="100000"/>
               </a:lnSpc>
@@ -3459,7 +3765,7 @@
               <a:tabLst>
                 <a:tab algn="l" pos="0"/>
               </a:tabLst>
-              <a:defRPr b="0" lang="de-DE" sz="6130" spc="-1" strike="noStrike">
+              <a:defRPr b="0" lang="de-DE" sz="6060" spc="-1" strike="noStrike">
                 <a:solidFill>
                   <a:schemeClr val="dk1"/>
                 </a:solidFill>
@@ -3468,7 +3774,7 @@
             </a:lvl1pPr>
           </a:lstStyle>
           <a:p>
-            <a:pPr indent="0" algn="r" defTabSz="3897720">
+            <a:pPr indent="0" algn="r" defTabSz="3855240">
               <a:lnSpc>
                 <a:spcPct val="100000"/>
               </a:lnSpc>
@@ -3477,8 +3783,8 @@
                 <a:tab algn="l" pos="0"/>
               </a:tabLst>
             </a:pPr>
-            <a:fld id="{941D5654-C46B-455E-A3EE-6F4C53676B68}" type="slidenum">
-              <a:rPr b="0" lang="de-DE" sz="6130" spc="-1" strike="noStrike">
+            <a:fld id="{C88F6435-0A5C-4713-B9B9-8BDB5A8B7A5A}" type="slidenum">
+              <a:rPr b="0" lang="de-DE" sz="6060" spc="-1" strike="noStrike">
                 <a:solidFill>
                   <a:schemeClr val="dk1"/>
                 </a:solidFill>
@@ -3486,7 +3792,7 @@
               </a:rPr>
               <a:t>&lt;number&gt;</a:t>
             </a:fld>
-            <a:endParaRPr b="0" lang="en-US" sz="6130" spc="-1" strike="noStrike">
+            <a:endParaRPr b="0" lang="en-US" sz="6060" spc="-1" strike="noStrike">
               <a:solidFill>
                 <a:srgbClr val="000000"/>
               </a:solidFill>
@@ -3507,8 +3813,8 @@
         </p:nvSpPr>
         <p:spPr>
           <a:xfrm>
-            <a:off x="3102120" y="27581760"/>
-            <a:ext cx="8623800" cy="2017080"/>
+            <a:off x="3206880" y="27581760"/>
+            <a:ext cx="8915400" cy="2017440"/>
           </a:xfrm>
           <a:prstGeom prst="rect">
             <a:avLst/>
@@ -3567,8 +3873,8 @@
         </p:nvSpPr>
         <p:spPr>
           <a:xfrm>
-            <a:off x="2070000" y="1207800"/>
-            <a:ext cx="37263960" cy="5055480"/>
+            <a:off x="2139840" y="1207800"/>
+            <a:ext cx="38522880" cy="5055480"/>
           </a:xfrm>
           <a:prstGeom prst="rect">
             <a:avLst/>
@@ -3616,8 +3922,8 @@
         </p:nvSpPr>
         <p:spPr>
           <a:xfrm>
-            <a:off x="2070000" y="7084080"/>
-            <a:ext cx="37263960" cy="17559000"/>
+            <a:off x="2139840" y="7084080"/>
+            <a:ext cx="38522880" cy="17559000"/>
           </a:xfrm>
           <a:prstGeom prst="rect">
             <a:avLst/>
@@ -3874,8 +4180,8 @@
         </p:nvSpPr>
         <p:spPr>
           <a:xfrm>
-            <a:off x="2070000" y="1207800"/>
-            <a:ext cx="37263600" cy="5055120"/>
+            <a:off x="2139840" y="1207800"/>
+            <a:ext cx="38522520" cy="5055120"/>
           </a:xfrm>
           <a:prstGeom prst="rect">
             <a:avLst/>
@@ -3923,8 +4229,8 @@
         </p:nvSpPr>
         <p:spPr>
           <a:xfrm>
-            <a:off x="2070000" y="7084080"/>
-            <a:ext cx="37263600" cy="17558640"/>
+            <a:off x="3206880" y="2693160"/>
+            <a:ext cx="36389520" cy="24217200"/>
           </a:xfrm>
           <a:prstGeom prst="rect">
             <a:avLst/>
@@ -4148,8 +4454,8 @@
         </p:nvSpPr>
         <p:spPr>
           <a:xfrm>
-            <a:off x="14146200" y="27581760"/>
-            <a:ext cx="13111560" cy="2017080"/>
+            <a:off x="14623920" y="27581760"/>
+            <a:ext cx="13555080" cy="2017440"/>
           </a:xfrm>
           <a:prstGeom prst="rect">
             <a:avLst/>
@@ -4220,8 +4526,8 @@
         </p:nvSpPr>
         <p:spPr>
           <a:xfrm>
-            <a:off x="29678400" y="27581760"/>
-            <a:ext cx="8623800" cy="2017080"/>
+            <a:off x="30680640" y="27581760"/>
+            <a:ext cx="8915400" cy="2017440"/>
           </a:xfrm>
           <a:prstGeom prst="rect">
             <a:avLst/>
@@ -4236,7 +4542,7 @@
             <a:noAutofit/>
           </a:bodyPr>
           <a:lstStyle>
-            <a:lvl1pPr indent="0" algn="r" defTabSz="3897720">
+            <a:lvl1pPr indent="0" algn="r" defTabSz="3855240">
               <a:lnSpc>
                 <a:spcPct val="100000"/>
               </a:lnSpc>
@@ -4244,7 +4550,7 @@
               <a:tabLst>
                 <a:tab algn="l" pos="0"/>
               </a:tabLst>
-              <a:defRPr b="0" lang="de-DE" sz="6130" spc="-1" strike="noStrike">
+              <a:defRPr b="0" lang="de-DE" sz="6060" spc="-1" strike="noStrike">
                 <a:solidFill>
                   <a:schemeClr val="dk1"/>
                 </a:solidFill>
@@ -4253,7 +4559,7 @@
             </a:lvl1pPr>
           </a:lstStyle>
           <a:p>
-            <a:pPr indent="0" algn="r" defTabSz="3897720">
+            <a:pPr indent="0" algn="r" defTabSz="3855240">
               <a:lnSpc>
                 <a:spcPct val="100000"/>
               </a:lnSpc>
@@ -4262,8 +4568,8 @@
                 <a:tab algn="l" pos="0"/>
               </a:tabLst>
             </a:pPr>
-            <a:fld id="{FC3FFB3B-838B-458A-A6BB-7BF4BDFF2260}" type="slidenum">
-              <a:rPr b="0" lang="de-DE" sz="6130" spc="-1" strike="noStrike">
+            <a:fld id="{7427E8F5-27B6-45D8-9A56-E143CE620442}" type="slidenum">
+              <a:rPr b="0" lang="de-DE" sz="6060" spc="-1" strike="noStrike">
                 <a:solidFill>
                   <a:schemeClr val="dk1"/>
                 </a:solidFill>
@@ -4271,7 +4577,7 @@
               </a:rPr>
               <a:t>&lt;number&gt;</a:t>
             </a:fld>
-            <a:endParaRPr b="0" lang="en-US" sz="6130" spc="-1" strike="noStrike">
+            <a:endParaRPr b="0" lang="en-US" sz="6060" spc="-1" strike="noStrike">
               <a:solidFill>
                 <a:srgbClr val="000000"/>
               </a:solidFill>
@@ -4292,8 +4598,8 @@
         </p:nvSpPr>
         <p:spPr>
           <a:xfrm>
-            <a:off x="3102120" y="27581760"/>
-            <a:ext cx="8623800" cy="2017080"/>
+            <a:off x="3206880" y="27581760"/>
+            <a:ext cx="8915400" cy="2017440"/>
           </a:xfrm>
           <a:prstGeom prst="rect">
             <a:avLst/>
@@ -4385,8 +4691,8 @@
         </p:nvSpPr>
         <p:spPr>
           <a:xfrm>
-            <a:off x="14146200" y="27581760"/>
-            <a:ext cx="13111560" cy="2017080"/>
+            <a:off x="14623920" y="27581760"/>
+            <a:ext cx="13555080" cy="2017440"/>
           </a:xfrm>
           <a:prstGeom prst="rect">
             <a:avLst/>
@@ -4457,8 +4763,8 @@
         </p:nvSpPr>
         <p:spPr>
           <a:xfrm>
-            <a:off x="29678400" y="27581760"/>
-            <a:ext cx="8623800" cy="2017080"/>
+            <a:off x="30680640" y="27581760"/>
+            <a:ext cx="8915400" cy="2017440"/>
           </a:xfrm>
           <a:prstGeom prst="rect">
             <a:avLst/>
@@ -4473,7 +4779,7 @@
             <a:noAutofit/>
           </a:bodyPr>
           <a:lstStyle>
-            <a:lvl1pPr indent="0" algn="r" defTabSz="3897720">
+            <a:lvl1pPr indent="0" algn="r" defTabSz="3855240">
               <a:lnSpc>
                 <a:spcPct val="100000"/>
               </a:lnSpc>
@@ -4481,7 +4787,7 @@
               <a:tabLst>
                 <a:tab algn="l" pos="0"/>
               </a:tabLst>
-              <a:defRPr b="0" lang="de-DE" sz="6130" spc="-1" strike="noStrike">
+              <a:defRPr b="0" lang="de-DE" sz="6060" spc="-1" strike="noStrike">
                 <a:solidFill>
                   <a:schemeClr val="dk1"/>
                 </a:solidFill>
@@ -4490,7 +4796,7 @@
             </a:lvl1pPr>
           </a:lstStyle>
           <a:p>
-            <a:pPr indent="0" algn="r" defTabSz="3897720">
+            <a:pPr indent="0" algn="r" defTabSz="3855240">
               <a:lnSpc>
                 <a:spcPct val="100000"/>
               </a:lnSpc>
@@ -4499,8 +4805,8 @@
                 <a:tab algn="l" pos="0"/>
               </a:tabLst>
             </a:pPr>
-            <a:fld id="{C83C29DA-53BA-44F1-BE9E-B01086F529A6}" type="slidenum">
-              <a:rPr b="0" lang="de-DE" sz="6130" spc="-1" strike="noStrike">
+            <a:fld id="{99B8E0F6-A05C-4931-9238-CBD2C1B45B25}" type="slidenum">
+              <a:rPr b="0" lang="de-DE" sz="6060" spc="-1" strike="noStrike">
                 <a:solidFill>
                   <a:schemeClr val="dk1"/>
                 </a:solidFill>
@@ -4508,7 +4814,7 @@
               </a:rPr>
               <a:t>&lt;number&gt;</a:t>
             </a:fld>
-            <a:endParaRPr b="0" lang="en-US" sz="6130" spc="-1" strike="noStrike">
+            <a:endParaRPr b="0" lang="en-US" sz="6060" spc="-1" strike="noStrike">
               <a:solidFill>
                 <a:srgbClr val="000000"/>
               </a:solidFill>
@@ -4529,8 +4835,8 @@
         </p:nvSpPr>
         <p:spPr>
           <a:xfrm>
-            <a:off x="3102120" y="27581760"/>
-            <a:ext cx="8623800" cy="2017080"/>
+            <a:off x="3206880" y="27581760"/>
+            <a:ext cx="8915400" cy="2017440"/>
           </a:xfrm>
           <a:prstGeom prst="rect">
             <a:avLst/>
@@ -4622,8 +4928,8 @@
         </p:nvSpPr>
         <p:spPr>
           <a:xfrm>
-            <a:off x="2070000" y="1207800"/>
-            <a:ext cx="37263600" cy="5055120"/>
+            <a:off x="2139840" y="1207800"/>
+            <a:ext cx="38522520" cy="5055120"/>
           </a:xfrm>
           <a:prstGeom prst="rect">
             <a:avLst/>
@@ -4671,8 +4977,8 @@
         </p:nvSpPr>
         <p:spPr>
           <a:xfrm>
-            <a:off x="2070000" y="7084080"/>
-            <a:ext cx="18184320" cy="17558640"/>
+            <a:off x="3206880" y="2693160"/>
+            <a:ext cx="17757720" cy="24217200"/>
           </a:xfrm>
           <a:prstGeom prst="rect">
             <a:avLst/>
@@ -4896,8 +5202,8 @@
         </p:nvSpPr>
         <p:spPr>
           <a:xfrm>
-            <a:off x="21164400" y="7084080"/>
-            <a:ext cx="18184320" cy="17558640"/>
+            <a:off x="21853080" y="2693160"/>
+            <a:ext cx="17757720" cy="24217200"/>
           </a:xfrm>
           <a:prstGeom prst="rect">
             <a:avLst/>
@@ -5121,8 +5427,8 @@
         </p:nvSpPr>
         <p:spPr>
           <a:xfrm>
-            <a:off x="14146200" y="27581760"/>
-            <a:ext cx="13111560" cy="2017080"/>
+            <a:off x="14623920" y="27581760"/>
+            <a:ext cx="13555080" cy="2017440"/>
           </a:xfrm>
           <a:prstGeom prst="rect">
             <a:avLst/>
@@ -5193,8 +5499,8 @@
         </p:nvSpPr>
         <p:spPr>
           <a:xfrm>
-            <a:off x="29678400" y="27581760"/>
-            <a:ext cx="8623800" cy="2017080"/>
+            <a:off x="30680640" y="27581760"/>
+            <a:ext cx="8915400" cy="2017440"/>
           </a:xfrm>
           <a:prstGeom prst="rect">
             <a:avLst/>
@@ -5209,7 +5515,7 @@
             <a:noAutofit/>
           </a:bodyPr>
           <a:lstStyle>
-            <a:lvl1pPr indent="0" algn="r" defTabSz="3897720">
+            <a:lvl1pPr indent="0" algn="r" defTabSz="3855240">
               <a:lnSpc>
                 <a:spcPct val="100000"/>
               </a:lnSpc>
@@ -5217,7 +5523,7 @@
               <a:tabLst>
                 <a:tab algn="l" pos="0"/>
               </a:tabLst>
-              <a:defRPr b="0" lang="de-DE" sz="6130" spc="-1" strike="noStrike">
+              <a:defRPr b="0" lang="de-DE" sz="6060" spc="-1" strike="noStrike">
                 <a:solidFill>
                   <a:schemeClr val="dk1"/>
                 </a:solidFill>
@@ -5226,7 +5532,7 @@
             </a:lvl1pPr>
           </a:lstStyle>
           <a:p>
-            <a:pPr indent="0" algn="r" defTabSz="3897720">
+            <a:pPr indent="0" algn="r" defTabSz="3855240">
               <a:lnSpc>
                 <a:spcPct val="100000"/>
               </a:lnSpc>
@@ -5235,8 +5541,8 @@
                 <a:tab algn="l" pos="0"/>
               </a:tabLst>
             </a:pPr>
-            <a:fld id="{4C7242C7-9502-4589-8C82-BCBC7B237DE4}" type="slidenum">
-              <a:rPr b="0" lang="de-DE" sz="6130" spc="-1" strike="noStrike">
+            <a:fld id="{104BEC03-86AB-4835-9648-4F989FCDA5D8}" type="slidenum">
+              <a:rPr b="0" lang="de-DE" sz="6060" spc="-1" strike="noStrike">
                 <a:solidFill>
                   <a:schemeClr val="dk1"/>
                 </a:solidFill>
@@ -5244,7 +5550,7 @@
               </a:rPr>
               <a:t>&lt;number&gt;</a:t>
             </a:fld>
-            <a:endParaRPr b="0" lang="en-US" sz="6130" spc="-1" strike="noStrike">
+            <a:endParaRPr b="0" lang="en-US" sz="6060" spc="-1" strike="noStrike">
               <a:solidFill>
                 <a:srgbClr val="000000"/>
               </a:solidFill>
@@ -5265,8 +5571,8 @@
         </p:nvSpPr>
         <p:spPr>
           <a:xfrm>
-            <a:off x="3102120" y="27581760"/>
-            <a:ext cx="8623800" cy="2017080"/>
+            <a:off x="3206880" y="27581760"/>
+            <a:ext cx="8915400" cy="2017440"/>
           </a:xfrm>
           <a:prstGeom prst="rect">
             <a:avLst/>
@@ -5358,8 +5664,8 @@
         </p:nvSpPr>
         <p:spPr>
           <a:xfrm>
-            <a:off x="14146200" y="27581760"/>
-            <a:ext cx="13111560" cy="2017080"/>
+            <a:off x="14623920" y="27581760"/>
+            <a:ext cx="13555080" cy="2017440"/>
           </a:xfrm>
           <a:prstGeom prst="rect">
             <a:avLst/>
@@ -5430,8 +5736,8 @@
         </p:nvSpPr>
         <p:spPr>
           <a:xfrm>
-            <a:off x="29678400" y="27581760"/>
-            <a:ext cx="8623800" cy="2017080"/>
+            <a:off x="30680640" y="27581760"/>
+            <a:ext cx="8915400" cy="2017440"/>
           </a:xfrm>
           <a:prstGeom prst="rect">
             <a:avLst/>
@@ -5446,7 +5752,7 @@
             <a:noAutofit/>
           </a:bodyPr>
           <a:lstStyle>
-            <a:lvl1pPr indent="0" algn="r" defTabSz="3897720">
+            <a:lvl1pPr indent="0" algn="r" defTabSz="3855240">
               <a:lnSpc>
                 <a:spcPct val="100000"/>
               </a:lnSpc>
@@ -5454,7 +5760,7 @@
               <a:tabLst>
                 <a:tab algn="l" pos="0"/>
               </a:tabLst>
-              <a:defRPr b="0" lang="de-DE" sz="6130" spc="-1" strike="noStrike">
+              <a:defRPr b="0" lang="de-DE" sz="6060" spc="-1" strike="noStrike">
                 <a:solidFill>
                   <a:schemeClr val="dk1"/>
                 </a:solidFill>
@@ -5463,7 +5769,7 @@
             </a:lvl1pPr>
           </a:lstStyle>
           <a:p>
-            <a:pPr indent="0" algn="r" defTabSz="3897720">
+            <a:pPr indent="0" algn="r" defTabSz="3855240">
               <a:lnSpc>
                 <a:spcPct val="100000"/>
               </a:lnSpc>
@@ -5472,8 +5778,8 @@
                 <a:tab algn="l" pos="0"/>
               </a:tabLst>
             </a:pPr>
-            <a:fld id="{2F320F2D-3841-4745-A409-785A5C1806C7}" type="slidenum">
-              <a:rPr b="0" lang="de-DE" sz="6130" spc="-1" strike="noStrike">
+            <a:fld id="{8A9CD9C7-1CBC-4F34-BF97-9CBB6BC8F9C6}" type="slidenum">
+              <a:rPr b="0" lang="de-DE" sz="6060" spc="-1" strike="noStrike">
                 <a:solidFill>
                   <a:schemeClr val="dk1"/>
                 </a:solidFill>
@@ -5481,7 +5787,7 @@
               </a:rPr>
               <a:t>&lt;number&gt;</a:t>
             </a:fld>
-            <a:endParaRPr b="0" lang="en-US" sz="6130" spc="-1" strike="noStrike">
+            <a:endParaRPr b="0" lang="en-US" sz="6060" spc="-1" strike="noStrike">
               <a:solidFill>
                 <a:srgbClr val="000000"/>
               </a:solidFill>
@@ -5502,8 +5808,8 @@
         </p:nvSpPr>
         <p:spPr>
           <a:xfrm>
-            <a:off x="3102120" y="27581760"/>
-            <a:ext cx="8623800" cy="2017080"/>
+            <a:off x="3206880" y="27581760"/>
+            <a:ext cx="8915400" cy="2017440"/>
           </a:xfrm>
           <a:prstGeom prst="rect">
             <a:avLst/>
@@ -5595,8 +5901,8 @@
         </p:nvSpPr>
         <p:spPr>
           <a:xfrm>
-            <a:off x="2070000" y="1207800"/>
-            <a:ext cx="37263600" cy="5055120"/>
+            <a:off x="2139840" y="1207800"/>
+            <a:ext cx="38522520" cy="5055120"/>
           </a:xfrm>
           <a:prstGeom prst="rect">
             <a:avLst/>
@@ -5644,8 +5950,8 @@
         </p:nvSpPr>
         <p:spPr>
           <a:xfrm>
-            <a:off x="14146200" y="27581760"/>
-            <a:ext cx="13111560" cy="2017080"/>
+            <a:off x="14623920" y="27581760"/>
+            <a:ext cx="13555080" cy="2017440"/>
           </a:xfrm>
           <a:prstGeom prst="rect">
             <a:avLst/>
@@ -5716,8 +6022,8 @@
         </p:nvSpPr>
         <p:spPr>
           <a:xfrm>
-            <a:off x="29678400" y="27581760"/>
-            <a:ext cx="8623800" cy="2017080"/>
+            <a:off x="30680640" y="27581760"/>
+            <a:ext cx="8915400" cy="2017440"/>
           </a:xfrm>
           <a:prstGeom prst="rect">
             <a:avLst/>
@@ -5732,7 +6038,7 @@
             <a:noAutofit/>
           </a:bodyPr>
           <a:lstStyle>
-            <a:lvl1pPr indent="0" algn="r" defTabSz="3897720">
+            <a:lvl1pPr indent="0" algn="r" defTabSz="3855240">
               <a:lnSpc>
                 <a:spcPct val="100000"/>
               </a:lnSpc>
@@ -5740,7 +6046,7 @@
               <a:tabLst>
                 <a:tab algn="l" pos="0"/>
               </a:tabLst>
-              <a:defRPr b="0" lang="de-DE" sz="6130" spc="-1" strike="noStrike">
+              <a:defRPr b="0" lang="de-DE" sz="6060" spc="-1" strike="noStrike">
                 <a:solidFill>
                   <a:schemeClr val="dk1"/>
                 </a:solidFill>
@@ -5749,7 +6055,7 @@
             </a:lvl1pPr>
           </a:lstStyle>
           <a:p>
-            <a:pPr indent="0" algn="r" defTabSz="3897720">
+            <a:pPr indent="0" algn="r" defTabSz="3855240">
               <a:lnSpc>
                 <a:spcPct val="100000"/>
               </a:lnSpc>
@@ -5758,8 +6064,8 @@
                 <a:tab algn="l" pos="0"/>
               </a:tabLst>
             </a:pPr>
-            <a:fld id="{5357A378-50B9-4E04-8DA2-BED969E727BD}" type="slidenum">
-              <a:rPr b="0" lang="de-DE" sz="6130" spc="-1" strike="noStrike">
+            <a:fld id="{A2CC3C10-A489-4F50-A692-2DFF8103544B}" type="slidenum">
+              <a:rPr b="0" lang="de-DE" sz="6060" spc="-1" strike="noStrike">
                 <a:solidFill>
                   <a:schemeClr val="dk1"/>
                 </a:solidFill>
@@ -5767,7 +6073,7 @@
               </a:rPr>
               <a:t>&lt;number&gt;</a:t>
             </a:fld>
-            <a:endParaRPr b="0" lang="en-US" sz="6130" spc="-1" strike="noStrike">
+            <a:endParaRPr b="0" lang="en-US" sz="6060" spc="-1" strike="noStrike">
               <a:solidFill>
                 <a:srgbClr val="000000"/>
               </a:solidFill>
@@ -5788,8 +6094,8 @@
         </p:nvSpPr>
         <p:spPr>
           <a:xfrm>
-            <a:off x="3102120" y="27581760"/>
-            <a:ext cx="8623800" cy="2017080"/>
+            <a:off x="3206880" y="27581760"/>
+            <a:ext cx="8915400" cy="2017440"/>
           </a:xfrm>
           <a:prstGeom prst="rect">
             <a:avLst/>
@@ -5864,14 +6170,112 @@
       </p:grpSpPr>
       <p:sp>
         <p:nvSpPr>
-          <p:cNvPr id="59" name="Rectangle 36"/>
+          <p:cNvPr id="59" name="Rectangle 81"/>
           <p:cNvSpPr/>
           <p:nvPr/>
         </p:nvSpPr>
         <p:spPr>
           <a:xfrm>
-            <a:off x="405720" y="4423320"/>
-            <a:ext cx="13309920" cy="24837120"/>
+            <a:off x="1281960" y="19046520"/>
+            <a:ext cx="24367680" cy="10216080"/>
+          </a:xfrm>
+          <a:prstGeom prst="rect">
+            <a:avLst/>
+          </a:prstGeom>
+          <a:solidFill>
+            <a:schemeClr val="bg1"/>
+          </a:solidFill>
+          <a:ln w="57150">
+            <a:solidFill>
+              <a:srgbClr val="264796"/>
+            </a:solidFill>
+            <a:miter/>
+          </a:ln>
+        </p:spPr>
+        <p:style>
+          <a:lnRef idx="0"/>
+          <a:fillRef idx="0"/>
+          <a:effectRef idx="0"/>
+          <a:fontRef idx="minor"/>
+        </p:style>
+        <p:txBody>
+          <a:bodyPr wrap="none" lIns="90000" rIns="90000" tIns="45000" bIns="45000" anchor="ctr">
+            <a:noAutofit/>
+          </a:bodyPr>
+          <a:p>
+            <a:pPr>
+              <a:lnSpc>
+                <a:spcPct val="100000"/>
+              </a:lnSpc>
+            </a:pPr>
+            <a:endParaRPr b="0" lang="de-DE" sz="3359" spc="-1" strike="noStrike">
+              <a:solidFill>
+                <a:schemeClr val="dk1"/>
+              </a:solidFill>
+              <a:latin typeface="Calibri"/>
+            </a:endParaRPr>
+          </a:p>
+        </p:txBody>
+      </p:sp>
+      <p:sp>
+        <p:nvSpPr>
+          <p:cNvPr id="60" name="Rectangle 66"/>
+          <p:cNvSpPr/>
+          <p:nvPr/>
+        </p:nvSpPr>
+        <p:spPr>
+          <a:xfrm>
+            <a:off x="1281960" y="9413640"/>
+            <a:ext cx="24367680" cy="9292680"/>
+          </a:xfrm>
+          <a:prstGeom prst="rect">
+            <a:avLst/>
+          </a:prstGeom>
+          <a:solidFill>
+            <a:schemeClr val="bg1"/>
+          </a:solidFill>
+          <a:ln w="57150">
+            <a:solidFill>
+              <a:srgbClr val="264796"/>
+            </a:solidFill>
+            <a:miter/>
+          </a:ln>
+        </p:spPr>
+        <p:style>
+          <a:lnRef idx="0"/>
+          <a:fillRef idx="0"/>
+          <a:effectRef idx="0"/>
+          <a:fontRef idx="minor"/>
+        </p:style>
+        <p:txBody>
+          <a:bodyPr wrap="none" lIns="90000" rIns="90000" tIns="45000" bIns="45000" anchor="ctr">
+            <a:noAutofit/>
+          </a:bodyPr>
+          <a:p>
+            <a:pPr>
+              <a:lnSpc>
+                <a:spcPct val="100000"/>
+              </a:lnSpc>
+            </a:pPr>
+            <a:endParaRPr b="0" lang="de-DE" sz="3359" spc="-1" strike="noStrike">
+              <a:solidFill>
+                <a:schemeClr val="dk1"/>
+              </a:solidFill>
+              <a:latin typeface="Calibri"/>
+            </a:endParaRPr>
+          </a:p>
+        </p:txBody>
+      </p:sp>
+      <p:sp>
+        <p:nvSpPr>
+          <p:cNvPr id="61" name="Rectangle 36"/>
+          <p:cNvSpPr/>
+          <p:nvPr/>
+        </p:nvSpPr>
+        <p:spPr>
+          <a:xfrm>
+            <a:off x="1323360" y="4030200"/>
+            <a:ext cx="24330960" cy="5110200"/>
           </a:xfrm>
           <a:prstGeom prst="rect">
             <a:avLst/>
@@ -5900,7 +6304,7 @@
                 <a:spcPct val="100000"/>
               </a:lnSpc>
             </a:pPr>
-            <a:endParaRPr b="0" lang="de-DE" sz="2910" spc="-1" strike="noStrike">
+            <a:endParaRPr b="0" lang="de-DE" sz="3359" spc="-1" strike="noStrike">
               <a:solidFill>
                 <a:schemeClr val="dk1"/>
               </a:solidFill>
@@ -5911,14 +6315,14 @@
       </p:sp>
       <p:sp>
         <p:nvSpPr>
-          <p:cNvPr id="60" name="Text Box 32"/>
+          <p:cNvPr id="62" name="Text Box 32"/>
           <p:cNvSpPr/>
           <p:nvPr/>
         </p:nvSpPr>
         <p:spPr>
           <a:xfrm>
-            <a:off x="7293960" y="858240"/>
-            <a:ext cx="26907840" cy="1366920"/>
+            <a:off x="8092080" y="438840"/>
+            <a:ext cx="26619120" cy="1366200"/>
           </a:xfrm>
           <a:prstGeom prst="rect">
             <a:avLst/>
@@ -5935,7 +6339,7 @@
           <a:fontRef idx="minor"/>
         </p:style>
         <p:txBody>
-          <a:bodyPr lIns="84240" rIns="84240" tIns="42120" bIns="42120" anchor="t">
+          <a:bodyPr lIns="83520" rIns="83520" tIns="41760" bIns="41760" anchor="t">
             <a:spAutoFit/>
           </a:bodyPr>
           <a:p>
@@ -5970,14 +6374,14 @@
       </p:sp>
       <p:sp>
         <p:nvSpPr>
-          <p:cNvPr id="61" name="Text Box 35"/>
+          <p:cNvPr id="63" name="Text Box 35"/>
           <p:cNvSpPr/>
           <p:nvPr/>
         </p:nvSpPr>
         <p:spPr>
           <a:xfrm>
-            <a:off x="7398360" y="2760120"/>
-            <a:ext cx="26713440" cy="608400"/>
+            <a:off x="8240760" y="2064600"/>
+            <a:ext cx="26426880" cy="631800"/>
           </a:xfrm>
           <a:prstGeom prst="rect">
             <a:avLst/>
@@ -5994,7 +6398,7 @@
           <a:fontRef idx="minor"/>
         </p:style>
         <p:txBody>
-          <a:bodyPr lIns="84240" rIns="84240" tIns="42120" bIns="42120" anchor="t">
+          <a:bodyPr lIns="83520" rIns="83520" tIns="41760" bIns="41760" anchor="t">
             <a:spAutoFit/>
           </a:bodyPr>
           <a:p>
@@ -6004,15 +6408,16 @@
               </a:lnSpc>
             </a:pPr>
             <a:r>
-              <a:rPr b="0" lang="de-DE" sz="3440" spc="-1" strike="noStrike">
+              <a:rPr b="0" lang="de-DE" sz="3600" spc="-1" strike="noStrike">
                 <a:solidFill>
                   <a:srgbClr val="264796"/>
                 </a:solidFill>
-                <a:latin typeface="Calibri"/>
+                <a:latin typeface="Cambria"/>
+                <a:ea typeface="Cambria"/>
               </a:rPr>
               <a:t>J. Frazier, V. Venugopal, C.C. Stephan</a:t>
             </a:r>
-            <a:endParaRPr b="0" lang="en-US" sz="3440" spc="-1" strike="noStrike">
+            <a:endParaRPr b="0" lang="en-US" sz="3600" spc="-1" strike="noStrike">
               <a:solidFill>
                 <a:srgbClr val="000000"/>
               </a:solidFill>
@@ -6023,14 +6428,14 @@
       </p:sp>
       <p:sp>
         <p:nvSpPr>
-          <p:cNvPr id="62" name="Rectangle 40"/>
+          <p:cNvPr id="64" name="Rectangle 40"/>
           <p:cNvSpPr/>
           <p:nvPr/>
         </p:nvSpPr>
         <p:spPr>
           <a:xfrm>
-            <a:off x="27529200" y="26488440"/>
-            <a:ext cx="13150800" cy="2700000"/>
+            <a:off x="26000280" y="24157440"/>
+            <a:ext cx="15521040" cy="5104800"/>
           </a:xfrm>
           <a:prstGeom prst="rect">
             <a:avLst/>
@@ -6054,7 +6459,7 @@
           <a:fontRef idx="minor"/>
         </p:style>
         <p:txBody>
-          <a:bodyPr wrap="none" lIns="87480" rIns="87480" tIns="43920" bIns="43920" anchor="t">
+          <a:bodyPr wrap="none" lIns="86400" rIns="86400" tIns="43200" bIns="43200" anchor="t">
             <a:noAutofit/>
           </a:bodyPr>
           <a:p>
@@ -6066,7 +6471,7 @@
                 <a:tab algn="l" pos="0"/>
               </a:tabLst>
             </a:pPr>
-            <a:endParaRPr b="0" lang="de-DE" sz="2910" spc="-1" strike="noStrike">
+            <a:endParaRPr b="0" lang="de-DE" sz="3359" spc="-1" strike="noStrike">
               <a:solidFill>
                 <a:schemeClr val="dk1"/>
               </a:solidFill>
@@ -6075,20 +6480,362 @@
           </a:p>
         </p:txBody>
       </p:sp>
+      <p:sp>
+        <p:nvSpPr>
+          <p:cNvPr id="65" name="Rectangle 195"/>
+          <p:cNvSpPr/>
+          <p:nvPr/>
+        </p:nvSpPr>
+        <p:spPr>
+          <a:xfrm>
+            <a:off x="26000280" y="4030200"/>
+            <a:ext cx="15521040" cy="19743840"/>
+          </a:xfrm>
+          <a:prstGeom prst="rect">
+            <a:avLst/>
+          </a:prstGeom>
+          <a:solidFill>
+            <a:schemeClr val="bg1"/>
+          </a:solidFill>
+          <a:ln w="57150">
+            <a:solidFill>
+              <a:srgbClr val="264796"/>
+            </a:solidFill>
+            <a:miter/>
+          </a:ln>
+        </p:spPr>
+        <p:style>
+          <a:lnRef idx="0"/>
+          <a:fillRef idx="0"/>
+          <a:effectRef idx="0"/>
+          <a:fontRef idx="minor"/>
+        </p:style>
+        <p:txBody>
+          <a:bodyPr wrap="none" lIns="90000" rIns="90000" tIns="45000" bIns="45000" anchor="ctr">
+            <a:noAutofit/>
+          </a:bodyPr>
+          <a:p>
+            <a:endParaRPr b="0" lang="de-DE" sz="3359" spc="-1" strike="noStrike">
+              <a:solidFill>
+                <a:schemeClr val="dk1"/>
+              </a:solidFill>
+              <a:latin typeface="Segoe UI"/>
+            </a:endParaRPr>
+          </a:p>
+        </p:txBody>
+      </p:sp>
+      <p:sp>
+        <p:nvSpPr>
+          <p:cNvPr id="66" name="Text Box 223"/>
+          <p:cNvSpPr/>
+          <p:nvPr/>
+        </p:nvSpPr>
+        <p:spPr>
+          <a:xfrm>
+            <a:off x="26336880" y="24426720"/>
+            <a:ext cx="14840280" cy="601560"/>
+          </a:xfrm>
+          <a:prstGeom prst="rect">
+            <a:avLst/>
+          </a:prstGeom>
+          <a:solidFill>
+            <a:srgbClr val="264796"/>
+          </a:solidFill>
+          <a:ln w="0">
+            <a:noFill/>
+          </a:ln>
+        </p:spPr>
+        <p:style>
+          <a:lnRef idx="0"/>
+          <a:fillRef idx="0"/>
+          <a:effectRef idx="0"/>
+          <a:fontRef idx="minor"/>
+        </p:style>
+        <p:txBody>
+          <a:bodyPr lIns="90000" rIns="90000" tIns="45000" bIns="45000" anchor="t">
+            <a:spAutoFit/>
+          </a:bodyPr>
+          <a:p>
+            <a:pPr algn="ctr">
+              <a:lnSpc>
+                <a:spcPct val="100000"/>
+              </a:lnSpc>
+            </a:pPr>
+            <a:r>
+              <a:rPr b="1" lang="de-DE" sz="3359" spc="-1" strike="noStrike">
+                <a:solidFill>
+                  <a:schemeClr val="lt1"/>
+                </a:solidFill>
+                <a:latin typeface="Segoe UI"/>
+              </a:rPr>
+              <a:t>References</a:t>
+            </a:r>
+            <a:endParaRPr b="0" lang="en-US" sz="3359" spc="-1" strike="noStrike">
+              <a:solidFill>
+                <a:srgbClr val="ffffff"/>
+              </a:solidFill>
+              <a:latin typeface="Arial"/>
+            </a:endParaRPr>
+          </a:p>
+        </p:txBody>
+      </p:sp>
+      <p:sp>
+        <p:nvSpPr>
+          <p:cNvPr id="67" name="Textfeld 7"/>
+          <p:cNvSpPr/>
+          <p:nvPr/>
+        </p:nvSpPr>
+        <p:spPr>
+          <a:xfrm>
+            <a:off x="1660320" y="4336560"/>
+            <a:ext cx="23657760" cy="607680"/>
+          </a:xfrm>
+          <a:prstGeom prst="rect">
+            <a:avLst/>
+          </a:prstGeom>
+          <a:solidFill>
+            <a:srgbClr val="264796"/>
+          </a:solidFill>
+          <a:ln w="0">
+            <a:noFill/>
+          </a:ln>
+        </p:spPr>
+        <p:style>
+          <a:lnRef idx="0"/>
+          <a:fillRef idx="0"/>
+          <a:effectRef idx="0"/>
+          <a:fontRef idx="minor"/>
+        </p:style>
+        <p:txBody>
+          <a:bodyPr lIns="90000" rIns="90000" tIns="45000" bIns="45000" anchor="t">
+            <a:spAutoFit/>
+          </a:bodyPr>
+          <a:p>
+            <a:pPr algn="ctr">
+              <a:lnSpc>
+                <a:spcPct val="100000"/>
+              </a:lnSpc>
+            </a:pPr>
+            <a:r>
+              <a:rPr b="1" lang="de-DE" sz="3400" spc="-1" strike="noStrike">
+                <a:solidFill>
+                  <a:schemeClr val="lt1"/>
+                </a:solidFill>
+                <a:latin typeface="Segoe UI"/>
+              </a:rPr>
+              <a:t>Overview</a:t>
+            </a:r>
+            <a:endParaRPr b="0" lang="en-US" sz="3400" spc="-1" strike="noStrike">
+              <a:solidFill>
+                <a:srgbClr val="ffffff"/>
+              </a:solidFill>
+              <a:latin typeface="Arial"/>
+            </a:endParaRPr>
+          </a:p>
+        </p:txBody>
+      </p:sp>
+      <p:sp>
+        <p:nvSpPr>
+          <p:cNvPr id="68" name="Textfeld 105"/>
+          <p:cNvSpPr/>
+          <p:nvPr/>
+        </p:nvSpPr>
+        <p:spPr>
+          <a:xfrm>
+            <a:off x="1660320" y="9726480"/>
+            <a:ext cx="23657760" cy="607680"/>
+          </a:xfrm>
+          <a:prstGeom prst="rect">
+            <a:avLst/>
+          </a:prstGeom>
+          <a:solidFill>
+            <a:srgbClr val="264796"/>
+          </a:solidFill>
+          <a:ln w="0">
+            <a:noFill/>
+          </a:ln>
+        </p:spPr>
+        <p:style>
+          <a:lnRef idx="0"/>
+          <a:fillRef idx="0"/>
+          <a:effectRef idx="0"/>
+          <a:fontRef idx="minor"/>
+        </p:style>
+        <p:txBody>
+          <a:bodyPr lIns="90000" rIns="90000" tIns="45000" bIns="45000" anchor="t">
+            <a:spAutoFit/>
+          </a:bodyPr>
+          <a:p>
+            <a:pPr algn="ctr">
+              <a:lnSpc>
+                <a:spcPct val="100000"/>
+              </a:lnSpc>
+            </a:pPr>
+            <a:r>
+              <a:rPr b="1" lang="de-DE" sz="3400" spc="-1" strike="noStrike">
+                <a:solidFill>
+                  <a:schemeClr val="lt1"/>
+                </a:solidFill>
+                <a:latin typeface="Segoe UI"/>
+              </a:rPr>
+              <a:t>Approach</a:t>
+            </a:r>
+            <a:endParaRPr b="0" lang="en-US" sz="3400" spc="-1" strike="noStrike">
+              <a:solidFill>
+                <a:srgbClr val="ffffff"/>
+              </a:solidFill>
+              <a:latin typeface="Arial"/>
+            </a:endParaRPr>
+          </a:p>
+        </p:txBody>
+      </p:sp>
+      <p:sp>
+        <p:nvSpPr>
+          <p:cNvPr id="69" name="Textfeld 106"/>
+          <p:cNvSpPr/>
+          <p:nvPr/>
+        </p:nvSpPr>
+        <p:spPr>
+          <a:xfrm>
+            <a:off x="1660320" y="19274400"/>
+            <a:ext cx="23657760" cy="601560"/>
+          </a:xfrm>
+          <a:prstGeom prst="rect">
+            <a:avLst/>
+          </a:prstGeom>
+          <a:solidFill>
+            <a:srgbClr val="264796"/>
+          </a:solidFill>
+          <a:ln w="0">
+            <a:noFill/>
+          </a:ln>
+        </p:spPr>
+        <p:style>
+          <a:lnRef idx="0"/>
+          <a:fillRef idx="0"/>
+          <a:effectRef idx="0"/>
+          <a:fontRef idx="minor"/>
+        </p:style>
+        <p:txBody>
+          <a:bodyPr lIns="90000" rIns="90000" tIns="45000" bIns="45000" anchor="t">
+            <a:spAutoFit/>
+          </a:bodyPr>
+          <a:p>
+            <a:pPr algn="ctr">
+              <a:lnSpc>
+                <a:spcPct val="100000"/>
+              </a:lnSpc>
+            </a:pPr>
+            <a:r>
+              <a:rPr b="1" lang="de-DE" sz="3359" spc="-1" strike="noStrike">
+                <a:solidFill>
+                  <a:schemeClr val="lt1"/>
+                </a:solidFill>
+                <a:latin typeface="Segoe UI"/>
+              </a:rPr>
+              <a:t>Technical Challenges</a:t>
+            </a:r>
+            <a:endParaRPr b="0" lang="en-US" sz="3359" spc="-1" strike="noStrike">
+              <a:solidFill>
+                <a:srgbClr val="ffffff"/>
+              </a:solidFill>
+              <a:latin typeface="Arial"/>
+            </a:endParaRPr>
+          </a:p>
+        </p:txBody>
+      </p:sp>
+      <p:sp>
+        <p:nvSpPr>
+          <p:cNvPr id="70" name="Textfeld 107"/>
+          <p:cNvSpPr/>
+          <p:nvPr/>
+        </p:nvSpPr>
+        <p:spPr>
+          <a:xfrm>
+            <a:off x="26336880" y="4343040"/>
+            <a:ext cx="14840280" cy="601560"/>
+          </a:xfrm>
+          <a:prstGeom prst="rect">
+            <a:avLst/>
+          </a:prstGeom>
+          <a:solidFill>
+            <a:srgbClr val="264796"/>
+          </a:solidFill>
+          <a:ln w="0">
+            <a:noFill/>
+          </a:ln>
+        </p:spPr>
+        <p:style>
+          <a:lnRef idx="0"/>
+          <a:fillRef idx="0"/>
+          <a:effectRef idx="0"/>
+          <a:fontRef idx="minor"/>
+        </p:style>
+        <p:txBody>
+          <a:bodyPr lIns="90000" rIns="90000" tIns="45000" bIns="45000" anchor="t">
+            <a:spAutoFit/>
+          </a:bodyPr>
+          <a:p>
+            <a:pPr algn="ctr">
+              <a:lnSpc>
+                <a:spcPct val="100000"/>
+              </a:lnSpc>
+            </a:pPr>
+            <a:r>
+              <a:rPr b="1" lang="de-DE" sz="3359" spc="-1" strike="noStrike">
+                <a:solidFill>
+                  <a:schemeClr val="lt1"/>
+                </a:solidFill>
+                <a:latin typeface="Segoe UI"/>
+              </a:rPr>
+              <a:t>Outlook</a:t>
+            </a:r>
+            <a:endParaRPr b="0" lang="en-US" sz="3359" spc="-1" strike="noStrike">
+              <a:solidFill>
+                <a:srgbClr val="ffffff"/>
+              </a:solidFill>
+              <a:latin typeface="Arial"/>
+            </a:endParaRPr>
+          </a:p>
+        </p:txBody>
+      </p:sp>
+      <p:cxnSp>
+        <p:nvCxnSpPr>
+          <p:cNvPr id="71" name="Gerade Verbindung 2"/>
+          <p:cNvCxnSpPr/>
+          <p:nvPr/>
+        </p:nvCxnSpPr>
+        <p:spPr>
+          <a:xfrm>
+            <a:off x="1281240" y="3525120"/>
+            <a:ext cx="40241160" cy="36360"/>
+          </a:xfrm>
+          <a:prstGeom prst="straightConnector1">
+            <a:avLst/>
+          </a:prstGeom>
+          <a:ln w="101600">
+            <a:solidFill>
+              <a:srgbClr val="264796"/>
+            </a:solidFill>
+            <a:round/>
+          </a:ln>
+        </p:spPr>
+      </p:cxnSp>
       <p:pic>
         <p:nvPicPr>
-          <p:cNvPr id="63" name="Picture 13044" descr=""/>
+          <p:cNvPr id="72" name="Picture 5" descr=""/>
           <p:cNvPicPr/>
           <p:nvPr/>
         </p:nvPicPr>
         <p:blipFill>
           <a:blip r:embed="rId1"/>
+          <a:srcRect l="0" t="7158" r="0" b="6785"/>
           <a:stretch/>
         </p:blipFill>
         <p:spPr>
           <a:xfrm>
-            <a:off x="746280" y="4698360"/>
-            <a:ext cx="12512160" cy="550080"/>
+            <a:off x="38322000" y="889200"/>
+            <a:ext cx="3180240" cy="2243160"/>
           </a:xfrm>
           <a:prstGeom prst="rect">
             <a:avLst/>
@@ -6100,7 +6847,7 @@
       </p:pic>
       <p:pic>
         <p:nvPicPr>
-          <p:cNvPr id="64" name="Picture 13044" descr=""/>
+          <p:cNvPr id="73" name="Grafik 3" descr="Ein Bild, das Schrift, Text, Grafiken, Logo enthält.&#10;&#10;KI-generierte Inhalte können fehlerhaft sein."/>
           <p:cNvPicPr/>
           <p:nvPr/>
         </p:nvPicPr>
@@ -6110,8 +6857,8 @@
         </p:blipFill>
         <p:spPr>
           <a:xfrm>
-            <a:off x="27685800" y="26678160"/>
-            <a:ext cx="12782160" cy="471960"/>
+            <a:off x="1324800" y="93600"/>
+            <a:ext cx="8282880" cy="3185280"/>
           </a:xfrm>
           <a:prstGeom prst="rect">
             <a:avLst/>
@@ -6123,14 +6870,14 @@
       </p:pic>
       <p:sp>
         <p:nvSpPr>
-          <p:cNvPr id="65" name="Text Box 223"/>
+          <p:cNvPr id="74" name="Textfeld 4"/>
           <p:cNvSpPr/>
           <p:nvPr/>
         </p:nvSpPr>
         <p:spPr>
           <a:xfrm>
-            <a:off x="27757800" y="26641080"/>
-            <a:ext cx="12546360" cy="544680"/>
+            <a:off x="1651680" y="5137560"/>
+            <a:ext cx="4427640" cy="455400"/>
           </a:xfrm>
           <a:prstGeom prst="rect">
             <a:avLst/>
@@ -6147,25 +6894,26 @@
           <a:fontRef idx="minor"/>
         </p:style>
         <p:txBody>
-          <a:bodyPr lIns="87480" rIns="87480" tIns="43920" bIns="43920" anchor="t">
+          <a:bodyPr lIns="90000" rIns="90000" tIns="45000" bIns="45000" anchor="t">
             <a:spAutoFit/>
           </a:bodyPr>
           <a:p>
-            <a:pPr algn="ctr" defTabSz="4071960">
+            <a:pPr>
               <a:lnSpc>
                 <a:spcPct val="100000"/>
               </a:lnSpc>
             </a:pPr>
             <a:r>
-              <a:rPr b="1" lang="de-DE" sz="3000" spc="-1" strike="noStrike">
-                <a:solidFill>
-                  <a:schemeClr val="lt1"/>
-                </a:solidFill>
-                <a:latin typeface="Calibri"/>
-              </a:rPr>
-              <a:t>References</a:t>
-            </a:r>
-            <a:endParaRPr b="0" lang="en-US" sz="3000" spc="-1" strike="noStrike">
+              <a:rPr b="0" lang="de-DE" sz="2400" spc="-1" strike="noStrike">
+                <a:solidFill>
+                  <a:schemeClr val="dk1"/>
+                </a:solidFill>
+                <a:latin typeface="Cambria"/>
+                <a:ea typeface="Cambria"/>
+              </a:rPr>
+              <a:t>Text</a:t>
+            </a:r>
+            <a:endParaRPr b="0" lang="en-US" sz="2400" spc="-1" strike="noStrike">
               <a:solidFill>
                 <a:srgbClr val="000000"/>
               </a:solidFill>
@@ -6174,16 +6922,480 @@
           </a:p>
         </p:txBody>
       </p:sp>
-      <p:sp>
-        <p:nvSpPr>
-          <p:cNvPr id="66" name="Textfeld 7"/>
+      <p:grpSp>
+        <p:nvGrpSpPr>
+          <p:cNvPr id="75" name=""/>
+          <p:cNvGrpSpPr/>
+          <p:nvPr/>
+        </p:nvGrpSpPr>
+        <p:grpSpPr>
+          <a:xfrm>
+            <a:off x="3566880" y="21400560"/>
+            <a:ext cx="2575440" cy="1085400"/>
+            <a:chOff x="3566880" y="21400560"/>
+            <a:chExt cx="2575440" cy="1085400"/>
+          </a:xfrm>
+        </p:grpSpPr>
+        <p:sp>
+          <p:nvSpPr>
+            <p:cNvPr id="76" name=""/>
+            <p:cNvSpPr/>
+            <p:nvPr/>
+          </p:nvSpPr>
+          <p:spPr>
+            <a:xfrm>
+              <a:off x="4854600" y="21400560"/>
+              <a:ext cx="0" cy="542520"/>
+            </a:xfrm>
+            <a:prstGeom prst="line">
+              <a:avLst/>
+            </a:prstGeom>
+            <a:ln w="19080">
+              <a:solidFill>
+                <a:srgbClr val="000000"/>
+              </a:solidFill>
+              <a:round/>
+            </a:ln>
+          </p:spPr>
+          <p:style>
+            <a:lnRef idx="0"/>
+            <a:fillRef idx="0"/>
+            <a:effectRef idx="0"/>
+            <a:fontRef idx="minor"/>
+          </p:style>
+          <p:txBody>
+            <a:bodyPr lIns="99360" rIns="99360" tIns="54360" bIns="54360" anchor="ctr">
+              <a:noAutofit/>
+            </a:bodyPr>
+            <a:p>
+              <a:endParaRPr b="0" lang="en-US" sz="3200" spc="-1" strike="noStrike">
+                <a:solidFill>
+                  <a:srgbClr val="000000"/>
+                </a:solidFill>
+                <a:latin typeface="Segoe UI"/>
+              </a:endParaRPr>
+            </a:p>
+          </p:txBody>
+        </p:sp>
+        <p:sp>
+          <p:nvSpPr>
+            <p:cNvPr id="77" name=""/>
+            <p:cNvSpPr/>
+            <p:nvPr/>
+          </p:nvSpPr>
+          <p:spPr>
+            <a:xfrm>
+              <a:off x="3566880" y="21943080"/>
+              <a:ext cx="2575440" cy="0"/>
+            </a:xfrm>
+            <a:prstGeom prst="line">
+              <a:avLst/>
+            </a:prstGeom>
+            <a:ln w="19080">
+              <a:solidFill>
+                <a:srgbClr val="000000"/>
+              </a:solidFill>
+              <a:round/>
+            </a:ln>
+          </p:spPr>
+          <p:style>
+            <a:lnRef idx="0"/>
+            <a:fillRef idx="0"/>
+            <a:effectRef idx="0"/>
+            <a:fontRef idx="minor"/>
+          </p:style>
+          <p:txBody>
+            <a:bodyPr lIns="99360" rIns="99360" tIns="-54360" bIns="-54360" anchor="ctr">
+              <a:noAutofit/>
+            </a:bodyPr>
+            <a:p>
+              <a:endParaRPr b="0" lang="en-US" sz="3200" spc="-1" strike="noStrike">
+                <a:solidFill>
+                  <a:srgbClr val="000000"/>
+                </a:solidFill>
+                <a:latin typeface="Segoe UI"/>
+              </a:endParaRPr>
+            </a:p>
+          </p:txBody>
+        </p:sp>
+        <p:sp>
+          <p:nvSpPr>
+            <p:cNvPr id="78" name=""/>
+            <p:cNvSpPr/>
+            <p:nvPr/>
+          </p:nvSpPr>
+          <p:spPr>
+            <a:xfrm>
+              <a:off x="3566880" y="21943080"/>
+              <a:ext cx="0" cy="542520"/>
+            </a:xfrm>
+            <a:prstGeom prst="line">
+              <a:avLst/>
+            </a:prstGeom>
+            <a:ln w="19080">
+              <a:solidFill>
+                <a:srgbClr val="000000"/>
+              </a:solidFill>
+              <a:round/>
+            </a:ln>
+          </p:spPr>
+          <p:style>
+            <a:lnRef idx="0"/>
+            <a:fillRef idx="0"/>
+            <a:effectRef idx="0"/>
+            <a:fontRef idx="minor"/>
+          </p:style>
+          <p:txBody>
+            <a:bodyPr lIns="99360" rIns="99360" tIns="54360" bIns="54360" anchor="ctr">
+              <a:noAutofit/>
+            </a:bodyPr>
+            <a:p>
+              <a:endParaRPr b="0" lang="en-US" sz="3200" spc="-1" strike="noStrike">
+                <a:solidFill>
+                  <a:srgbClr val="000000"/>
+                </a:solidFill>
+                <a:latin typeface="Segoe UI"/>
+              </a:endParaRPr>
+            </a:p>
+          </p:txBody>
+        </p:sp>
+        <p:sp>
+          <p:nvSpPr>
+            <p:cNvPr id="79" name=""/>
+            <p:cNvSpPr/>
+            <p:nvPr/>
+          </p:nvSpPr>
+          <p:spPr>
+            <a:xfrm>
+              <a:off x="6142320" y="21943440"/>
+              <a:ext cx="0" cy="542520"/>
+            </a:xfrm>
+            <a:prstGeom prst="line">
+              <a:avLst/>
+            </a:prstGeom>
+            <a:ln w="19080">
+              <a:solidFill>
+                <a:srgbClr val="000000"/>
+              </a:solidFill>
+              <a:round/>
+            </a:ln>
+          </p:spPr>
+          <p:style>
+            <a:lnRef idx="0"/>
+            <a:fillRef idx="0"/>
+            <a:effectRef idx="0"/>
+            <a:fontRef idx="minor"/>
+          </p:style>
+          <p:txBody>
+            <a:bodyPr lIns="99360" rIns="99360" tIns="54360" bIns="54360" anchor="ctr">
+              <a:noAutofit/>
+            </a:bodyPr>
+            <a:p>
+              <a:endParaRPr b="0" lang="en-US" sz="3200" spc="-1" strike="noStrike">
+                <a:solidFill>
+                  <a:srgbClr val="000000"/>
+                </a:solidFill>
+                <a:latin typeface="Segoe UI"/>
+              </a:endParaRPr>
+            </a:p>
+          </p:txBody>
+        </p:sp>
+      </p:grpSp>
+      <p:sp>
+        <p:nvSpPr>
+          <p:cNvPr id="80" name=""/>
           <p:cNvSpPr/>
           <p:nvPr/>
         </p:nvSpPr>
         <p:spPr>
           <a:xfrm>
-            <a:off x="746280" y="4636440"/>
-            <a:ext cx="12512160" cy="620280"/>
+            <a:off x="3676320" y="20399400"/>
+            <a:ext cx="2351880" cy="965880"/>
+          </a:xfrm>
+          <a:prstGeom prst="roundRect">
+            <a:avLst>
+              <a:gd name="adj" fmla="val 16667"/>
+            </a:avLst>
+          </a:prstGeom>
+          <a:noFill/>
+          <a:ln w="29160">
+            <a:solidFill>
+              <a:srgbClr val="000000"/>
+            </a:solidFill>
+            <a:round/>
+          </a:ln>
+        </p:spPr>
+        <p:style>
+          <a:lnRef idx="0"/>
+          <a:fillRef idx="0"/>
+          <a:effectRef idx="0"/>
+          <a:fontRef idx="minor"/>
+        </p:style>
+        <p:txBody>
+          <a:bodyPr lIns="104400" rIns="104400" tIns="59400" bIns="59400" anchor="ctr">
+            <a:noAutofit/>
+          </a:bodyPr>
+          <a:p>
+            <a:pPr algn="ctr"/>
+            <a:r>
+              <a:rPr b="0" lang="en-US" sz="3200" spc="-1" strike="noStrike">
+                <a:solidFill>
+                  <a:srgbClr val="000000"/>
+                </a:solidFill>
+                <a:latin typeface="Segoe UI"/>
+              </a:rPr>
+              <a:t>ICON-XPP</a:t>
+            </a:r>
+            <a:endParaRPr b="0" lang="en-US" sz="3200" spc="-1" strike="noStrike">
+              <a:solidFill>
+                <a:srgbClr val="000000"/>
+              </a:solidFill>
+              <a:latin typeface="Segoe UI"/>
+            </a:endParaRPr>
+          </a:p>
+        </p:txBody>
+      </p:sp>
+      <p:sp>
+        <p:nvSpPr>
+          <p:cNvPr id="81" name=""/>
+          <p:cNvSpPr/>
+          <p:nvPr/>
+        </p:nvSpPr>
+        <p:spPr>
+          <a:xfrm>
+            <a:off x="2248560" y="22554000"/>
+            <a:ext cx="2101680" cy="965880"/>
+          </a:xfrm>
+          <a:prstGeom prst="roundRect">
+            <a:avLst>
+              <a:gd name="adj" fmla="val 16667"/>
+            </a:avLst>
+          </a:prstGeom>
+          <a:noFill/>
+          <a:ln w="29160">
+            <a:solidFill>
+              <a:srgbClr val="000000"/>
+            </a:solidFill>
+            <a:round/>
+          </a:ln>
+        </p:spPr>
+        <p:style>
+          <a:lnRef idx="0"/>
+          <a:fillRef idx="0"/>
+          <a:effectRef idx="0"/>
+          <a:fontRef idx="minor"/>
+        </p:style>
+        <p:txBody>
+          <a:bodyPr lIns="104400" rIns="104400" tIns="59400" bIns="59400" anchor="ctr">
+            <a:noAutofit/>
+          </a:bodyPr>
+          <a:p>
+            <a:pPr algn="ctr"/>
+            <a:r>
+              <a:rPr b="0" lang="en-US" sz="3200" spc="-1" strike="noStrike">
+                <a:solidFill>
+                  <a:srgbClr val="000000"/>
+                </a:solidFill>
+                <a:latin typeface="Segoe UI"/>
+              </a:rPr>
+              <a:t>LLVM IR</a:t>
+            </a:r>
+            <a:endParaRPr b="0" lang="en-US" sz="3200" spc="-1" strike="noStrike">
+              <a:solidFill>
+                <a:srgbClr val="000000"/>
+              </a:solidFill>
+              <a:latin typeface="Segoe UI"/>
+            </a:endParaRPr>
+          </a:p>
+        </p:txBody>
+      </p:sp>
+      <p:sp>
+        <p:nvSpPr>
+          <p:cNvPr id="82" name=""/>
+          <p:cNvSpPr/>
+          <p:nvPr/>
+        </p:nvSpPr>
+        <p:spPr>
+          <a:xfrm>
+            <a:off x="5442480" y="22554000"/>
+            <a:ext cx="2101320" cy="965880"/>
+          </a:xfrm>
+          <a:prstGeom prst="roundRect">
+            <a:avLst>
+              <a:gd name="adj" fmla="val 16667"/>
+            </a:avLst>
+          </a:prstGeom>
+          <a:noFill/>
+          <a:ln w="29160">
+            <a:solidFill>
+              <a:srgbClr val="000000"/>
+            </a:solidFill>
+            <a:round/>
+          </a:ln>
+        </p:spPr>
+        <p:style>
+          <a:lnRef idx="0"/>
+          <a:fillRef idx="0"/>
+          <a:effectRef idx="0"/>
+          <a:fontRef idx="minor"/>
+        </p:style>
+        <p:txBody>
+          <a:bodyPr lIns="104400" rIns="104400" tIns="59400" bIns="59400" anchor="ctr">
+            <a:noAutofit/>
+          </a:bodyPr>
+          <a:p>
+            <a:pPr algn="ctr"/>
+            <a:r>
+              <a:rPr b="0" lang="en-US" sz="3200" spc="-1" strike="noStrike">
+                <a:solidFill>
+                  <a:srgbClr val="000000"/>
+                </a:solidFill>
+                <a:latin typeface="Segoe UI"/>
+              </a:rPr>
+              <a:t>LLVM IR</a:t>
+            </a:r>
+            <a:endParaRPr b="0" lang="en-US" sz="3200" spc="-1" strike="noStrike">
+              <a:solidFill>
+                <a:srgbClr val="000000"/>
+              </a:solidFill>
+              <a:latin typeface="Segoe UI"/>
+            </a:endParaRPr>
+          </a:p>
+        </p:txBody>
+      </p:sp>
+      <p:sp>
+        <p:nvSpPr>
+          <p:cNvPr id="83" name=""/>
+          <p:cNvSpPr/>
+          <p:nvPr/>
+        </p:nvSpPr>
+        <p:spPr>
+          <a:xfrm flipH="1">
+            <a:off x="3566880" y="24123600"/>
+            <a:ext cx="2575440" cy="0"/>
+          </a:xfrm>
+          <a:prstGeom prst="line">
+            <a:avLst/>
+          </a:prstGeom>
+          <a:ln w="19080">
+            <a:solidFill>
+              <a:srgbClr val="000000"/>
+            </a:solidFill>
+            <a:round/>
+          </a:ln>
+        </p:spPr>
+        <p:style>
+          <a:lnRef idx="0"/>
+          <a:fillRef idx="0"/>
+          <a:effectRef idx="0"/>
+          <a:fontRef idx="minor"/>
+        </p:style>
+        <p:txBody>
+          <a:bodyPr lIns="99360" rIns="99360" tIns="-54360" bIns="-54360" anchor="ctr">
+            <a:noAutofit/>
+          </a:bodyPr>
+          <a:p>
+            <a:endParaRPr b="0" lang="en-US" sz="3200" spc="-1" strike="noStrike">
+              <a:solidFill>
+                <a:srgbClr val="000000"/>
+              </a:solidFill>
+              <a:latin typeface="Segoe UI"/>
+            </a:endParaRPr>
+          </a:p>
+        </p:txBody>
+      </p:sp>
+      <p:sp>
+        <p:nvSpPr>
+          <p:cNvPr id="84" name=""/>
+          <p:cNvSpPr/>
+          <p:nvPr/>
+        </p:nvSpPr>
+        <p:spPr>
+          <a:xfrm flipV="1">
+            <a:off x="6142320" y="23581080"/>
+            <a:ext cx="0" cy="542520"/>
+          </a:xfrm>
+          <a:prstGeom prst="line">
+            <a:avLst/>
+          </a:prstGeom>
+          <a:ln w="19080">
+            <a:solidFill>
+              <a:srgbClr val="000000"/>
+            </a:solidFill>
+            <a:round/>
+          </a:ln>
+        </p:spPr>
+        <p:style>
+          <a:lnRef idx="0"/>
+          <a:fillRef idx="0"/>
+          <a:effectRef idx="0"/>
+          <a:fontRef idx="minor"/>
+        </p:style>
+        <p:txBody>
+          <a:bodyPr lIns="99360" rIns="99360" tIns="54360" bIns="54360" anchor="ctr">
+            <a:noAutofit/>
+          </a:bodyPr>
+          <a:p>
+            <a:endParaRPr b="0" lang="en-US" sz="3200" spc="-1" strike="noStrike">
+              <a:solidFill>
+                <a:srgbClr val="000000"/>
+              </a:solidFill>
+              <a:latin typeface="Segoe UI"/>
+            </a:endParaRPr>
+          </a:p>
+        </p:txBody>
+      </p:sp>
+      <p:sp>
+        <p:nvSpPr>
+          <p:cNvPr id="85" name=""/>
+          <p:cNvSpPr/>
+          <p:nvPr/>
+        </p:nvSpPr>
+        <p:spPr>
+          <a:xfrm flipV="1">
+            <a:off x="3566880" y="23580720"/>
+            <a:ext cx="0" cy="542160"/>
+          </a:xfrm>
+          <a:prstGeom prst="line">
+            <a:avLst/>
+          </a:prstGeom>
+          <a:ln w="19080">
+            <a:solidFill>
+              <a:srgbClr val="000000"/>
+            </a:solidFill>
+            <a:round/>
+          </a:ln>
+        </p:spPr>
+        <p:style>
+          <a:lnRef idx="0"/>
+          <a:fillRef idx="0"/>
+          <a:effectRef idx="0"/>
+          <a:fontRef idx="minor"/>
+        </p:style>
+        <p:txBody>
+          <a:bodyPr lIns="99360" rIns="99360" tIns="54360" bIns="54360" anchor="ctr">
+            <a:noAutofit/>
+          </a:bodyPr>
+          <a:p>
+            <a:endParaRPr b="0" lang="en-US" sz="3200" spc="-1" strike="noStrike">
+              <a:solidFill>
+                <a:srgbClr val="000000"/>
+              </a:solidFill>
+              <a:latin typeface="Segoe UI"/>
+            </a:endParaRPr>
+          </a:p>
+        </p:txBody>
+      </p:sp>
+      <p:sp>
+        <p:nvSpPr>
+          <p:cNvPr id="86" name=""/>
+          <p:cNvSpPr txBox="1"/>
+          <p:nvPr/>
+        </p:nvSpPr>
+        <p:spPr>
+          <a:xfrm>
+            <a:off x="1600200" y="21319200"/>
+            <a:ext cx="2286000" cy="1208520"/>
           </a:xfrm>
           <a:prstGeom prst="rect">
             <a:avLst/>
@@ -6193,6 +7405,98 @@
             <a:noFill/>
           </a:ln>
         </p:spPr>
+        <p:txBody>
+          <a:bodyPr lIns="90000" rIns="90000" tIns="45000" bIns="45000" anchor="t">
+            <a:noAutofit/>
+          </a:bodyPr>
+          <a:p>
+            <a:pPr algn="ctr"/>
+            <a:r>
+              <a:rPr b="0" lang="en-US" sz="3200" spc="-1" strike="noStrike">
+                <a:solidFill>
+                  <a:srgbClr val="000000"/>
+                </a:solidFill>
+                <a:latin typeface="Segoe UI"/>
+              </a:rPr>
+              <a:t>IFX 2023.x</a:t>
+            </a:r>
+            <a:endParaRPr b="0" lang="en-US" sz="3200" spc="-1" strike="noStrike">
+              <a:solidFill>
+                <a:srgbClr val="000000"/>
+              </a:solidFill>
+              <a:latin typeface="Segoe UI"/>
+            </a:endParaRPr>
+          </a:p>
+        </p:txBody>
+      </p:sp>
+      <p:sp>
+        <p:nvSpPr>
+          <p:cNvPr id="87" name=""/>
+          <p:cNvSpPr txBox="1"/>
+          <p:nvPr/>
+        </p:nvSpPr>
+        <p:spPr>
+          <a:xfrm>
+            <a:off x="5581800" y="21333240"/>
+            <a:ext cx="1931400" cy="1208520"/>
+          </a:xfrm>
+          <a:prstGeom prst="rect">
+            <a:avLst/>
+          </a:prstGeom>
+          <a:noFill/>
+          <a:ln w="0">
+            <a:noFill/>
+          </a:ln>
+        </p:spPr>
+        <p:txBody>
+          <a:bodyPr lIns="90000" rIns="90000" tIns="45000" bIns="45000" anchor="t">
+            <a:noAutofit/>
+          </a:bodyPr>
+          <a:p>
+            <a:pPr algn="ctr"/>
+            <a:r>
+              <a:rPr b="0" lang="en-US" sz="3200" spc="-1" strike="noStrike">
+                <a:solidFill>
+                  <a:srgbClr val="000000"/>
+                </a:solidFill>
+                <a:latin typeface="Segoe UI"/>
+              </a:rPr>
+              <a:t>Flang</a:t>
+            </a:r>
+            <a:endParaRPr b="0" lang="en-US" sz="3200" spc="-1" strike="noStrike">
+              <a:solidFill>
+                <a:srgbClr val="000000"/>
+              </a:solidFill>
+              <a:latin typeface="Segoe UI"/>
+            </a:endParaRPr>
+          </a:p>
+        </p:txBody>
+      </p:sp>
+      <p:sp>
+        <p:nvSpPr>
+          <p:cNvPr id="88" name=""/>
+          <p:cNvSpPr/>
+          <p:nvPr/>
+        </p:nvSpPr>
+        <p:spPr>
+          <a:xfrm rot="10800000">
+            <a:off x="4694400" y="25091280"/>
+            <a:ext cx="321840" cy="321840"/>
+          </a:xfrm>
+          <a:prstGeom prst="triangle">
+            <a:avLst>
+              <a:gd name="adj" fmla="val 50000"/>
+            </a:avLst>
+          </a:prstGeom>
+          <a:solidFill>
+            <a:srgbClr val="000000"/>
+          </a:solidFill>
+          <a:ln w="0">
+            <a:solidFill>
+              <a:srgbClr val="000000"/>
+            </a:solidFill>
+          </a:ln>
+        </p:spPr>
         <p:style>
           <a:lnRef idx="0"/>
           <a:fillRef idx="0"/>
@@ -6200,70 +7504,360 @@
           <a:fontRef idx="minor"/>
         </p:style>
         <p:txBody>
-          <a:bodyPr lIns="90000" rIns="90000" tIns="45000" bIns="45000" anchor="t">
-            <a:spAutoFit/>
+          <a:bodyPr lIns="90000" rIns="90000" tIns="45000" bIns="45000" anchor="ctr">
+            <a:noAutofit/>
           </a:bodyPr>
           <a:p>
-            <a:pPr algn="ctr">
-              <a:lnSpc>
-                <a:spcPct val="100000"/>
-              </a:lnSpc>
-            </a:pPr>
-            <a:r>
-              <a:rPr b="1" lang="de-DE" sz="3480" spc="-1" strike="noStrike">
-                <a:solidFill>
-                  <a:schemeClr val="lt1"/>
-                </a:solidFill>
-                <a:latin typeface="Calibri"/>
-              </a:rPr>
-              <a:t>Motivation</a:t>
-            </a:r>
-            <a:endParaRPr b="0" lang="en-US" sz="3480" spc="-1" strike="noStrike">
-              <a:solidFill>
-                <a:srgbClr val="000000"/>
-              </a:solidFill>
-              <a:latin typeface="Arial"/>
-            </a:endParaRPr>
-          </a:p>
-        </p:txBody>
-      </p:sp>
-      <p:cxnSp>
-        <p:nvCxnSpPr>
-          <p:cNvPr id="67" name="Gerade Verbindung 2"/>
-          <p:cNvCxnSpPr/>
+            <a:endParaRPr b="0" lang="en-US" sz="3200" spc="-1" strike="noStrike">
+              <a:solidFill>
+                <a:srgbClr val="ffffff"/>
+              </a:solidFill>
+              <a:latin typeface="Segoe UI"/>
+            </a:endParaRPr>
+          </a:p>
+        </p:txBody>
+      </p:sp>
+      <p:sp>
+        <p:nvSpPr>
+          <p:cNvPr id="89" name=""/>
+          <p:cNvSpPr/>
           <p:nvPr/>
-        </p:nvCxnSpPr>
+        </p:nvSpPr>
         <p:spPr>
-          <a:xfrm flipV="1">
-            <a:off x="363600" y="3992760"/>
-            <a:ext cx="40678560" cy="39960"/>
+          <a:xfrm>
+            <a:off x="4848840" y="24128640"/>
+            <a:ext cx="0" cy="965880"/>
           </a:xfrm>
-          <a:prstGeom prst="straightConnector1">
+          <a:prstGeom prst="line">
             <a:avLst/>
           </a:prstGeom>
-          <a:ln w="101600">
+          <a:ln w="19080">
             <a:solidFill>
-              <a:srgbClr val="264796"/>
+              <a:srgbClr val="000000"/>
             </a:solidFill>
             <a:round/>
           </a:ln>
         </p:spPr>
-      </p:cxnSp>
+        <p:style>
+          <a:lnRef idx="0"/>
+          <a:fillRef idx="0"/>
+          <a:effectRef idx="0"/>
+          <a:fontRef idx="minor"/>
+        </p:style>
+        <p:txBody>
+          <a:bodyPr lIns="99360" rIns="99360" tIns="54360" bIns="54360" anchor="ctr">
+            <a:noAutofit/>
+          </a:bodyPr>
+          <a:p>
+            <a:endParaRPr b="0" lang="en-US" sz="3200" spc="-1" strike="noStrike">
+              <a:solidFill>
+                <a:srgbClr val="000000"/>
+              </a:solidFill>
+              <a:latin typeface="Segoe UI"/>
+            </a:endParaRPr>
+          </a:p>
+        </p:txBody>
+      </p:sp>
+      <p:sp>
+        <p:nvSpPr>
+          <p:cNvPr id="90" name=""/>
+          <p:cNvSpPr txBox="1"/>
+          <p:nvPr/>
+        </p:nvSpPr>
+        <p:spPr>
+          <a:xfrm>
+            <a:off x="4684680" y="24417720"/>
+            <a:ext cx="2401920" cy="1065960"/>
+          </a:xfrm>
+          <a:prstGeom prst="rect">
+            <a:avLst/>
+          </a:prstGeom>
+          <a:noFill/>
+          <a:ln w="0">
+            <a:noFill/>
+          </a:ln>
+        </p:spPr>
+        <p:txBody>
+          <a:bodyPr lIns="90000" rIns="90000" tIns="45000" bIns="45000" anchor="t">
+            <a:noAutofit/>
+          </a:bodyPr>
+          <a:p>
+            <a:pPr algn="ctr"/>
+            <a:r>
+              <a:rPr b="0" lang="en-US" sz="3200" spc="-1" strike="noStrike">
+                <a:solidFill>
+                  <a:srgbClr val="000000"/>
+                </a:solidFill>
+                <a:latin typeface="Segoe UI"/>
+              </a:rPr>
+              <a:t>Enzyme</a:t>
+            </a:r>
+            <a:endParaRPr b="0" lang="en-US" sz="3200" spc="-1" strike="noStrike">
+              <a:solidFill>
+                <a:srgbClr val="000000"/>
+              </a:solidFill>
+              <a:latin typeface="Segoe UI"/>
+            </a:endParaRPr>
+          </a:p>
+        </p:txBody>
+      </p:sp>
+      <p:sp>
+        <p:nvSpPr>
+          <p:cNvPr id="91" name=""/>
+          <p:cNvSpPr/>
+          <p:nvPr/>
+        </p:nvSpPr>
+        <p:spPr>
+          <a:xfrm>
+            <a:off x="3377160" y="25443720"/>
+            <a:ext cx="2928240" cy="965880"/>
+          </a:xfrm>
+          <a:prstGeom prst="roundRect">
+            <a:avLst>
+              <a:gd name="adj" fmla="val 16667"/>
+            </a:avLst>
+          </a:prstGeom>
+          <a:noFill/>
+          <a:ln w="29160">
+            <a:solidFill>
+              <a:srgbClr val="000000"/>
+            </a:solidFill>
+            <a:round/>
+          </a:ln>
+        </p:spPr>
+        <p:style>
+          <a:lnRef idx="0"/>
+          <a:fillRef idx="0"/>
+          <a:effectRef idx="0"/>
+          <a:fontRef idx="minor"/>
+        </p:style>
+        <p:txBody>
+          <a:bodyPr lIns="104400" rIns="104400" tIns="59400" bIns="59400" anchor="ctr">
+            <a:noAutofit/>
+          </a:bodyPr>
+          <a:p>
+            <a:pPr algn="ctr"/>
+            <a:r>
+              <a:rPr b="0" lang="en-US" sz="3200" spc="-1" strike="noStrike">
+                <a:solidFill>
+                  <a:srgbClr val="000000"/>
+                </a:solidFill>
+                <a:latin typeface="Segoe UI"/>
+              </a:rPr>
+              <a:t>AD LLVM IR</a:t>
+            </a:r>
+            <a:endParaRPr b="0" lang="en-US" sz="3200" spc="-1" strike="noStrike">
+              <a:solidFill>
+                <a:srgbClr val="000000"/>
+              </a:solidFill>
+              <a:latin typeface="Segoe UI"/>
+            </a:endParaRPr>
+          </a:p>
+        </p:txBody>
+      </p:sp>
+      <p:sp>
+        <p:nvSpPr>
+          <p:cNvPr id="92" name=""/>
+          <p:cNvSpPr/>
+          <p:nvPr/>
+        </p:nvSpPr>
+        <p:spPr>
+          <a:xfrm>
+            <a:off x="4848840" y="26409960"/>
+            <a:ext cx="0" cy="643680"/>
+          </a:xfrm>
+          <a:prstGeom prst="line">
+            <a:avLst/>
+          </a:prstGeom>
+          <a:ln w="19080">
+            <a:solidFill>
+              <a:srgbClr val="000000"/>
+            </a:solidFill>
+            <a:round/>
+          </a:ln>
+        </p:spPr>
+        <p:style>
+          <a:lnRef idx="0"/>
+          <a:fillRef idx="0"/>
+          <a:effectRef idx="0"/>
+          <a:fontRef idx="minor"/>
+        </p:style>
+        <p:txBody>
+          <a:bodyPr lIns="99360" rIns="99360" tIns="54360" bIns="54360" anchor="ctr">
+            <a:noAutofit/>
+          </a:bodyPr>
+          <a:p>
+            <a:endParaRPr b="0" lang="en-US" sz="3200" spc="-1" strike="noStrike">
+              <a:solidFill>
+                <a:srgbClr val="000000"/>
+              </a:solidFill>
+              <a:latin typeface="Segoe UI"/>
+            </a:endParaRPr>
+          </a:p>
+        </p:txBody>
+      </p:sp>
+      <p:sp>
+        <p:nvSpPr>
+          <p:cNvPr id="93" name=""/>
+          <p:cNvSpPr/>
+          <p:nvPr/>
+        </p:nvSpPr>
+        <p:spPr>
+          <a:xfrm rot="10800000">
+            <a:off x="4694400" y="26967240"/>
+            <a:ext cx="321840" cy="321840"/>
+          </a:xfrm>
+          <a:prstGeom prst="triangle">
+            <a:avLst>
+              <a:gd name="adj" fmla="val 50000"/>
+            </a:avLst>
+          </a:prstGeom>
+          <a:solidFill>
+            <a:srgbClr val="000000"/>
+          </a:solidFill>
+          <a:ln w="0">
+            <a:solidFill>
+              <a:srgbClr val="000000"/>
+            </a:solidFill>
+          </a:ln>
+        </p:spPr>
+        <p:style>
+          <a:lnRef idx="0"/>
+          <a:fillRef idx="0"/>
+          <a:effectRef idx="0"/>
+          <a:fontRef idx="minor"/>
+        </p:style>
+        <p:txBody>
+          <a:bodyPr lIns="90000" rIns="90000" tIns="45000" bIns="45000" anchor="ctr">
+            <a:noAutofit/>
+          </a:bodyPr>
+          <a:p>
+            <a:endParaRPr b="0" lang="en-US" sz="3200" spc="-1" strike="noStrike">
+              <a:solidFill>
+                <a:srgbClr val="ffffff"/>
+              </a:solidFill>
+              <a:latin typeface="Segoe UI"/>
+            </a:endParaRPr>
+          </a:p>
+        </p:txBody>
+      </p:sp>
+      <p:sp>
+        <p:nvSpPr>
+          <p:cNvPr id="94" name=""/>
+          <p:cNvSpPr/>
+          <p:nvPr/>
+        </p:nvSpPr>
+        <p:spPr>
+          <a:xfrm>
+            <a:off x="3452400" y="27319320"/>
+            <a:ext cx="2823120" cy="965880"/>
+          </a:xfrm>
+          <a:prstGeom prst="roundRect">
+            <a:avLst>
+              <a:gd name="adj" fmla="val 16667"/>
+            </a:avLst>
+          </a:prstGeom>
+          <a:noFill/>
+          <a:ln w="29160">
+            <a:solidFill>
+              <a:srgbClr val="000000"/>
+            </a:solidFill>
+            <a:round/>
+          </a:ln>
+        </p:spPr>
+        <p:style>
+          <a:lnRef idx="0"/>
+          <a:fillRef idx="0"/>
+          <a:effectRef idx="0"/>
+          <a:fontRef idx="minor"/>
+        </p:style>
+        <p:txBody>
+          <a:bodyPr lIns="104400" rIns="104400" tIns="59400" bIns="59400" anchor="ctr">
+            <a:noAutofit/>
+          </a:bodyPr>
+          <a:p>
+            <a:pPr algn="ctr"/>
+            <a:r>
+              <a:rPr b="0" lang="en-US" sz="3200" spc="-1" strike="noStrike">
+                <a:solidFill>
+                  <a:srgbClr val="000000"/>
+                </a:solidFill>
+                <a:latin typeface="Segoe UI"/>
+              </a:rPr>
+              <a:t>AD ICON-XPP</a:t>
+            </a:r>
+            <a:endParaRPr b="0" lang="en-US" sz="3200" spc="-1" strike="noStrike">
+              <a:solidFill>
+                <a:srgbClr val="000000"/>
+              </a:solidFill>
+              <a:latin typeface="Segoe UI"/>
+            </a:endParaRPr>
+          </a:p>
+        </p:txBody>
+      </p:sp>
+      <p:sp>
+        <p:nvSpPr>
+          <p:cNvPr id="95" name=""/>
+          <p:cNvSpPr txBox="1"/>
+          <p:nvPr/>
+        </p:nvSpPr>
+        <p:spPr>
+          <a:xfrm>
+            <a:off x="4685040" y="26546760"/>
+            <a:ext cx="4001760" cy="1065960"/>
+          </a:xfrm>
+          <a:prstGeom prst="rect">
+            <a:avLst/>
+          </a:prstGeom>
+          <a:noFill/>
+          <a:ln w="0">
+            <a:noFill/>
+          </a:ln>
+        </p:spPr>
+        <p:txBody>
+          <a:bodyPr lIns="90000" rIns="90000" tIns="45000" bIns="45000" anchor="t">
+            <a:noAutofit/>
+          </a:bodyPr>
+          <a:p>
+            <a:pPr algn="ctr"/>
+            <a:r>
+              <a:rPr b="0" lang="en-US" sz="3200" spc="-1" strike="noStrike">
+                <a:solidFill>
+                  <a:srgbClr val="000000"/>
+                </a:solidFill>
+                <a:latin typeface="Segoe UI"/>
+              </a:rPr>
+              <a:t>GNU Autotools</a:t>
+            </a:r>
+            <a:endParaRPr b="0" lang="en-US" sz="3200" spc="-1" strike="noStrike">
+              <a:solidFill>
+                <a:srgbClr val="000000"/>
+              </a:solidFill>
+              <a:latin typeface="Segoe UI"/>
+            </a:endParaRPr>
+          </a:p>
+        </p:txBody>
+      </p:sp>
       <p:pic>
         <p:nvPicPr>
-          <p:cNvPr id="68" name="Picture 5" descr=""/>
+          <p:cNvPr id="96" name="" descr=""/>
           <p:cNvPicPr/>
           <p:nvPr/>
         </p:nvPicPr>
         <p:blipFill>
-          <a:blip r:embed="rId3"/>
-          <a:srcRect l="0" t="7161" r="0" b="6779"/>
+          <a:blip r:embed="rId3">
+            <a:extLst>
+              <a:ext uri="{96DAC541-7B7A-43D3-8B79-37D633B846F1}">
+                <asvg:svgBlip xmlns:asvg="http://schemas.microsoft.com/office/drawing/2016/SVG/main" r:embed="rId4"/>
+              </a:ext>
+            </a:extLst>
+          </a:blip>
           <a:stretch/>
         </p:blipFill>
         <p:spPr>
           <a:xfrm>
-            <a:off x="37942200" y="1241280"/>
-            <a:ext cx="3108960" cy="2192760"/>
+            <a:off x="1660320" y="10515600"/>
+            <a:ext cx="7056000" cy="8001000"/>
           </a:xfrm>
           <a:prstGeom prst="rect">
             <a:avLst/>
@@ -6273,495 +7867,6 @@
           </a:ln>
         </p:spPr>
       </p:pic>
-      <p:pic>
-        <p:nvPicPr>
-          <p:cNvPr id="69" name="Picture 4" descr=""/>
-          <p:cNvPicPr/>
-          <p:nvPr/>
-        </p:nvPicPr>
-        <p:blipFill>
-          <a:blip r:embed="rId4"/>
-          <a:stretch/>
-        </p:blipFill>
-        <p:spPr>
-          <a:xfrm>
-            <a:off x="406080" y="893520"/>
-            <a:ext cx="5965920" cy="2192760"/>
-          </a:xfrm>
-          <a:prstGeom prst="rect">
-            <a:avLst/>
-          </a:prstGeom>
-          <a:ln w="0">
-            <a:noFill/>
-          </a:ln>
-        </p:spPr>
-      </p:pic>
-      <p:sp>
-        <p:nvSpPr>
-          <p:cNvPr id="70" name="Textfeld 27331"/>
-          <p:cNvSpPr/>
-          <p:nvPr/>
-        </p:nvSpPr>
-        <p:spPr>
-          <a:xfrm>
-            <a:off x="27660600" y="27264960"/>
-            <a:ext cx="12324600" cy="1081440"/>
-          </a:xfrm>
-          <a:prstGeom prst="rect">
-            <a:avLst/>
-          </a:prstGeom>
-          <a:noFill/>
-          <a:ln w="0">
-            <a:noFill/>
-          </a:ln>
-        </p:spPr>
-        <p:style>
-          <a:lnRef idx="0"/>
-          <a:fillRef idx="0"/>
-          <a:effectRef idx="0"/>
-          <a:fontRef idx="minor"/>
-        </p:style>
-        <p:txBody>
-          <a:bodyPr lIns="90000" rIns="90000" tIns="45000" bIns="45000" anchor="t">
-            <a:spAutoFit/>
-          </a:bodyPr>
-          <a:p>
-            <a:pPr>
-              <a:lnSpc>
-                <a:spcPct val="100000"/>
-              </a:lnSpc>
-            </a:pPr>
-            <a:r>
-              <a:rPr b="0" lang="de-DE" sz="1300" spc="-1" strike="noStrike">
-                <a:solidFill>
-                  <a:schemeClr val="dk1"/>
-                </a:solidFill>
-                <a:latin typeface="Calibri"/>
-              </a:rPr>
-              <a:t>* add differentiating esms here</a:t>
-            </a:r>
-            <a:endParaRPr b="0" lang="en-US" sz="1300" spc="-1" strike="noStrike">
-              <a:solidFill>
-                <a:srgbClr val="000000"/>
-              </a:solidFill>
-              <a:latin typeface="Arial"/>
-            </a:endParaRPr>
-          </a:p>
-          <a:p>
-            <a:pPr>
-              <a:lnSpc>
-                <a:spcPct val="100000"/>
-              </a:lnSpc>
-            </a:pPr>
-            <a:r>
-              <a:rPr b="0" lang="de-DE" sz="1300" spc="-1" strike="noStrike">
-                <a:solidFill>
-                  <a:schemeClr val="dk1"/>
-                </a:solidFill>
-                <a:latin typeface="Calibri"/>
-              </a:rPr>
-              <a:t>* add icon tunable parameters reference here</a:t>
-            </a:r>
-            <a:endParaRPr b="0" lang="en-US" sz="1300" spc="-1" strike="noStrike">
-              <a:solidFill>
-                <a:srgbClr val="000000"/>
-              </a:solidFill>
-              <a:latin typeface="Arial"/>
-            </a:endParaRPr>
-          </a:p>
-          <a:p>
-            <a:pPr>
-              <a:lnSpc>
-                <a:spcPct val="100000"/>
-              </a:lnSpc>
-            </a:pPr>
-            <a:r>
-              <a:rPr b="0" lang="de-DE" sz="1300" spc="-1" strike="noStrike">
-                <a:solidFill>
-                  <a:schemeClr val="dk1"/>
-                </a:solidFill>
-                <a:latin typeface="Calibri"/>
-              </a:rPr>
-              <a:t>* add ICON XPP papers if necessary</a:t>
-            </a:r>
-            <a:endParaRPr b="0" lang="en-US" sz="1300" spc="-1" strike="noStrike">
-              <a:solidFill>
-                <a:srgbClr val="000000"/>
-              </a:solidFill>
-              <a:latin typeface="Arial"/>
-            </a:endParaRPr>
-          </a:p>
-          <a:p>
-            <a:pPr>
-              <a:lnSpc>
-                <a:spcPct val="100000"/>
-              </a:lnSpc>
-            </a:pPr>
-            <a:r>
-              <a:rPr b="0" lang="de-DE" sz="1300" spc="-1" strike="noStrike">
-                <a:solidFill>
-                  <a:schemeClr val="dk1"/>
-                </a:solidFill>
-                <a:latin typeface="Calibri"/>
-              </a:rPr>
-              <a:t>* add Enzyme papers if necessary</a:t>
-            </a:r>
-            <a:endParaRPr b="0" lang="en-US" sz="1300" spc="-1" strike="noStrike">
-              <a:solidFill>
-                <a:srgbClr val="000000"/>
-              </a:solidFill>
-              <a:latin typeface="Arial"/>
-            </a:endParaRPr>
-          </a:p>
-          <a:p>
-            <a:pPr>
-              <a:lnSpc>
-                <a:spcPct val="100000"/>
-              </a:lnSpc>
-            </a:pPr>
-            <a:endParaRPr b="0" lang="en-US" sz="1300" spc="-1" strike="noStrike">
-              <a:solidFill>
-                <a:srgbClr val="000000"/>
-              </a:solidFill>
-              <a:latin typeface="Arial"/>
-            </a:endParaRPr>
-          </a:p>
-        </p:txBody>
-      </p:sp>
-      <p:sp>
-        <p:nvSpPr>
-          <p:cNvPr id="71" name="Textfeld 22"/>
-          <p:cNvSpPr/>
-          <p:nvPr/>
-        </p:nvSpPr>
-        <p:spPr>
-          <a:xfrm>
-            <a:off x="25653600" y="22271760"/>
-            <a:ext cx="14997240" cy="2100240"/>
-          </a:xfrm>
-          <a:prstGeom prst="rect">
-            <a:avLst/>
-          </a:prstGeom>
-          <a:noFill/>
-          <a:ln w="9525">
-            <a:noFill/>
-          </a:ln>
-        </p:spPr>
-        <p:style>
-          <a:lnRef idx="0"/>
-          <a:fillRef idx="0"/>
-          <a:effectRef idx="0"/>
-          <a:fontRef idx="minor"/>
-        </p:style>
-        <p:txBody>
-          <a:bodyPr lIns="90000" rIns="90000" tIns="45000" bIns="45000" anchor="t">
-            <a:spAutoFit/>
-          </a:bodyPr>
-          <a:p>
-            <a:pPr>
-              <a:lnSpc>
-                <a:spcPct val="100000"/>
-              </a:lnSpc>
-            </a:pPr>
-            <a:endParaRPr b="0" lang="en-US" sz="1800" spc="-1" strike="noStrike">
-              <a:solidFill>
-                <a:srgbClr val="000000"/>
-              </a:solidFill>
-              <a:latin typeface="Arial"/>
-            </a:endParaRPr>
-          </a:p>
-        </p:txBody>
-      </p:sp>
-      <p:sp>
-        <p:nvSpPr>
-          <p:cNvPr id="72" name="Textfeld 22"/>
-          <p:cNvSpPr/>
-          <p:nvPr/>
-        </p:nvSpPr>
-        <p:spPr>
-          <a:xfrm>
-            <a:off x="25653600" y="24478920"/>
-            <a:ext cx="14997240" cy="1552320"/>
-          </a:xfrm>
-          <a:prstGeom prst="rect">
-            <a:avLst/>
-          </a:prstGeom>
-          <a:noFill/>
-          <a:ln w="9525">
-            <a:noFill/>
-          </a:ln>
-        </p:spPr>
-        <p:style>
-          <a:lnRef idx="0"/>
-          <a:fillRef idx="0"/>
-          <a:effectRef idx="0"/>
-          <a:fontRef idx="minor"/>
-        </p:style>
-        <p:txBody>
-          <a:bodyPr lIns="90000" rIns="90000" tIns="45000" bIns="45000" anchor="t">
-            <a:spAutoFit/>
-          </a:bodyPr>
-          <a:p>
-            <a:pPr>
-              <a:lnSpc>
-                <a:spcPct val="100000"/>
-              </a:lnSpc>
-            </a:pPr>
-            <a:endParaRPr b="0" lang="en-US" sz="1800" spc="-1" strike="noStrike">
-              <a:solidFill>
-                <a:srgbClr val="000000"/>
-              </a:solidFill>
-              <a:latin typeface="Arial"/>
-            </a:endParaRPr>
-          </a:p>
-        </p:txBody>
-      </p:sp>
-      <p:sp>
-        <p:nvSpPr>
-          <p:cNvPr id="73" name="Rectangle 1"/>
-          <p:cNvSpPr/>
-          <p:nvPr/>
-        </p:nvSpPr>
-        <p:spPr>
-          <a:xfrm>
-            <a:off x="13869720" y="4423320"/>
-            <a:ext cx="13309920" cy="24837120"/>
-          </a:xfrm>
-          <a:prstGeom prst="rect">
-            <a:avLst/>
-          </a:prstGeom>
-          <a:noFill/>
-          <a:ln w="57150">
-            <a:solidFill>
-              <a:srgbClr val="264796"/>
-            </a:solidFill>
-            <a:miter/>
-          </a:ln>
-        </p:spPr>
-        <p:style>
-          <a:lnRef idx="0"/>
-          <a:fillRef idx="0"/>
-          <a:effectRef idx="0"/>
-          <a:fontRef idx="minor"/>
-        </p:style>
-        <p:txBody>
-          <a:bodyPr wrap="none" lIns="90000" rIns="90000" tIns="45000" bIns="45000" anchor="ctr">
-            <a:noAutofit/>
-          </a:bodyPr>
-          <a:p>
-            <a:pPr>
-              <a:lnSpc>
-                <a:spcPct val="100000"/>
-              </a:lnSpc>
-            </a:pPr>
-            <a:endParaRPr b="0" lang="de-DE" sz="2910" spc="-1" strike="noStrike">
-              <a:solidFill>
-                <a:schemeClr val="dk1"/>
-              </a:solidFill>
-              <a:latin typeface="Calibri"/>
-            </a:endParaRPr>
-          </a:p>
-        </p:txBody>
-      </p:sp>
-      <p:pic>
-        <p:nvPicPr>
-          <p:cNvPr id="74" name="Picture 1" descr=""/>
-          <p:cNvPicPr/>
-          <p:nvPr/>
-        </p:nvPicPr>
-        <p:blipFill>
-          <a:blip r:embed="rId5"/>
-          <a:stretch/>
-        </p:blipFill>
-        <p:spPr>
-          <a:xfrm>
-            <a:off x="13994280" y="4698360"/>
-            <a:ext cx="12512160" cy="550080"/>
-          </a:xfrm>
-          <a:prstGeom prst="rect">
-            <a:avLst/>
-          </a:prstGeom>
-          <a:ln w="0">
-            <a:noFill/>
-          </a:ln>
-        </p:spPr>
-      </p:pic>
-      <p:sp>
-        <p:nvSpPr>
-          <p:cNvPr id="75" name="Textfeld 1"/>
-          <p:cNvSpPr/>
-          <p:nvPr/>
-        </p:nvSpPr>
-        <p:spPr>
-          <a:xfrm>
-            <a:off x="13994280" y="4636440"/>
-            <a:ext cx="12512160" cy="620280"/>
-          </a:xfrm>
-          <a:prstGeom prst="rect">
-            <a:avLst/>
-          </a:prstGeom>
-          <a:noFill/>
-          <a:ln w="0">
-            <a:noFill/>
-          </a:ln>
-        </p:spPr>
-        <p:style>
-          <a:lnRef idx="0"/>
-          <a:fillRef idx="0"/>
-          <a:effectRef idx="0"/>
-          <a:fontRef idx="minor"/>
-        </p:style>
-        <p:txBody>
-          <a:bodyPr lIns="90000" rIns="90000" tIns="45000" bIns="45000" anchor="t">
-            <a:spAutoFit/>
-          </a:bodyPr>
-          <a:p>
-            <a:pPr algn="ctr">
-              <a:lnSpc>
-                <a:spcPct val="100000"/>
-              </a:lnSpc>
-            </a:pPr>
-            <a:r>
-              <a:rPr b="1" lang="de-DE" sz="3480" spc="-1" strike="noStrike">
-                <a:solidFill>
-                  <a:schemeClr val="lt1"/>
-                </a:solidFill>
-                <a:latin typeface="Calibri"/>
-              </a:rPr>
-              <a:t>Approach</a:t>
-            </a:r>
-            <a:endParaRPr b="0" lang="en-US" sz="3480" spc="-1" strike="noStrike">
-              <a:solidFill>
-                <a:srgbClr val="000000"/>
-              </a:solidFill>
-              <a:latin typeface="Arial"/>
-            </a:endParaRPr>
-          </a:p>
-        </p:txBody>
-      </p:sp>
-      <p:sp>
-        <p:nvSpPr>
-          <p:cNvPr id="76" name="Rectangle 2"/>
-          <p:cNvSpPr/>
-          <p:nvPr/>
-        </p:nvSpPr>
-        <p:spPr>
-          <a:xfrm>
-            <a:off x="27455400" y="4423320"/>
-            <a:ext cx="13309920" cy="24837120"/>
-          </a:xfrm>
-          <a:prstGeom prst="rect">
-            <a:avLst/>
-          </a:prstGeom>
-          <a:noFill/>
-          <a:ln w="57150">
-            <a:solidFill>
-              <a:srgbClr val="264796"/>
-            </a:solidFill>
-            <a:miter/>
-          </a:ln>
-        </p:spPr>
-        <p:style>
-          <a:lnRef idx="0"/>
-          <a:fillRef idx="0"/>
-          <a:effectRef idx="0"/>
-          <a:fontRef idx="minor"/>
-        </p:style>
-        <p:txBody>
-          <a:bodyPr wrap="none" lIns="90000" rIns="90000" tIns="45000" bIns="45000" anchor="ctr">
-            <a:noAutofit/>
-          </a:bodyPr>
-          <a:p>
-            <a:pPr>
-              <a:lnSpc>
-                <a:spcPct val="100000"/>
-              </a:lnSpc>
-            </a:pPr>
-            <a:endParaRPr b="0" lang="de-DE" sz="2910" spc="-1" strike="noStrike">
-              <a:solidFill>
-                <a:schemeClr val="dk1"/>
-              </a:solidFill>
-              <a:latin typeface="Calibri"/>
-            </a:endParaRPr>
-          </a:p>
-        </p:txBody>
-      </p:sp>
-      <p:pic>
-        <p:nvPicPr>
-          <p:cNvPr id="77" name="Picture 2" descr=""/>
-          <p:cNvPicPr/>
-          <p:nvPr/>
-        </p:nvPicPr>
-        <p:blipFill>
-          <a:blip r:embed="rId6"/>
-          <a:stretch/>
-        </p:blipFill>
-        <p:spPr>
-          <a:xfrm>
-            <a:off x="27831960" y="4698360"/>
-            <a:ext cx="12512160" cy="550080"/>
-          </a:xfrm>
-          <a:prstGeom prst="rect">
-            <a:avLst/>
-          </a:prstGeom>
-          <a:ln w="0">
-            <a:noFill/>
-          </a:ln>
-        </p:spPr>
-      </p:pic>
-      <p:sp>
-        <p:nvSpPr>
-          <p:cNvPr id="78" name="Textfeld 2"/>
-          <p:cNvSpPr/>
-          <p:nvPr/>
-        </p:nvSpPr>
-        <p:spPr>
-          <a:xfrm>
-            <a:off x="27867960" y="4636440"/>
-            <a:ext cx="12512160" cy="620280"/>
-          </a:xfrm>
-          <a:prstGeom prst="rect">
-            <a:avLst/>
-          </a:prstGeom>
-          <a:noFill/>
-          <a:ln w="0">
-            <a:noFill/>
-          </a:ln>
-        </p:spPr>
-        <p:style>
-          <a:lnRef idx="0"/>
-          <a:fillRef idx="0"/>
-          <a:effectRef idx="0"/>
-          <a:fontRef idx="minor"/>
-        </p:style>
-        <p:txBody>
-          <a:bodyPr lIns="90000" rIns="90000" tIns="45000" bIns="45000" anchor="t">
-            <a:spAutoFit/>
-          </a:bodyPr>
-          <a:p>
-            <a:pPr algn="ctr">
-              <a:lnSpc>
-                <a:spcPct val="100000"/>
-              </a:lnSpc>
-            </a:pPr>
-            <a:r>
-              <a:rPr b="1" lang="de-DE" sz="3480" spc="-1" strike="noStrike">
-                <a:solidFill>
-                  <a:schemeClr val="lt1"/>
-                </a:solidFill>
-                <a:latin typeface="Calibri"/>
-              </a:rPr>
-              <a:t>Technical Challenges and Solutions</a:t>
-            </a:r>
-            <a:endParaRPr b="0" lang="en-US" sz="3480" spc="-1" strike="noStrike">
-              <a:solidFill>
-                <a:srgbClr val="000000"/>
-              </a:solidFill>
-              <a:latin typeface="Arial"/>
-            </a:endParaRPr>
-          </a:p>
-        </p:txBody>
-      </p:sp>
     </p:spTree>
   </p:cSld>
   <mc:AlternateContent>

</xml_diff>

<commit_message>
clean up... idk what equations render poorly...
</commit_message>
<xml_diff>
--- a/_posts/2026-07-13-contributing-enzyme-ifx-2025-3_assets/proposal/EuroAD_2029_ICON_Enzyme.pptx
+++ b/_posts/2026-07-13-contributing-enzyme-ifx-2025-3_assets/proposal/EuroAD_2029_ICON_Enzyme.pptx
@@ -292,7 +292,7 @@
             <a:pPr algn="r">
               <a:buNone/>
             </a:pPr>
-            <a:fld id="{9C783EA2-BB7A-4288-ACE7-6839B1307C90}" type="slidenum">
+            <a:fld id="{25493D29-A220-4EC2-9A53-88BAF2B34FCF}" type="slidenum">
               <a:rPr b="0" lang="en-US" sz="1400" spc="-1" strike="noStrike">
                 <a:latin typeface="Times New Roman"/>
               </a:rPr>
@@ -340,7 +340,7 @@
         <p:spPr>
           <a:xfrm>
             <a:off x="5622480" y="6456240"/>
-            <a:ext cx="4303440" cy="339480"/>
+            <a:ext cx="4302720" cy="338760"/>
           </a:xfrm>
           <a:prstGeom prst="rect">
             <a:avLst/>
@@ -351,7 +351,7 @@
           </a:ln>
         </p:spPr>
         <p:txBody>
-          <a:bodyPr numCol="1" spcCol="0" anchor="b">
+          <a:bodyPr numCol="1" spcCol="0" lIns="0" rIns="0" tIns="0" bIns="0" anchor="b">
             <a:noAutofit/>
           </a:bodyPr>
           <a:lstStyle>
@@ -381,7 +381,7 @@
                 <a:tab algn="l" pos="0"/>
               </a:tabLst>
             </a:pPr>
-            <a:fld id="{0EC417FB-A79E-4375-810B-614E834CA04E}" type="slidenum">
+            <a:fld id="{BDA9E39E-CF53-4223-B4B0-17A799952107}" type="slidenum">
               <a:rPr b="0" lang="de-DE" sz="1200" spc="-1" strike="noStrike">
                 <a:solidFill>
                   <a:srgbClr val="000000"/>
@@ -409,7 +409,7 @@
         <p:spPr>
           <a:xfrm>
             <a:off x="3165480" y="509760"/>
-            <a:ext cx="3601080" cy="2547000"/>
+            <a:ext cx="3600360" cy="2546280"/>
           </a:xfrm>
           <a:prstGeom prst="rect">
             <a:avLst/>
@@ -432,7 +432,7 @@
         <p:spPr>
           <a:xfrm>
             <a:off x="992520" y="3229200"/>
-            <a:ext cx="7941960" cy="3057120"/>
+            <a:ext cx="7941240" cy="3056400"/>
           </a:xfrm>
           <a:prstGeom prst="rect">
             <a:avLst/>
@@ -443,7 +443,7 @@
           </a:ln>
         </p:spPr>
         <p:txBody>
-          <a:bodyPr numCol="1" spcCol="0" anchor="t">
+          <a:bodyPr numCol="1" spcCol="0" lIns="0" rIns="0" tIns="0" bIns="0" anchor="t">
             <a:noAutofit/>
           </a:bodyPr>
           <a:p>
@@ -509,7 +509,7 @@
         <p:txBody>
           <a:bodyPr/>
           <a:p>
-            <a:fld id="{C4C9F7AF-5E67-46F2-B670-1E9FDF10DAC1}" type="slidenum">
+            <a:fld id="{31CDA6E9-4008-43A9-A24D-DB436D88935A}" type="slidenum">
               <a:t>&lt;#&gt;</a:t>
             </a:fld>
           </a:p>
@@ -697,7 +697,7 @@
         <p:txBody>
           <a:bodyPr/>
           <a:p>
-            <a:fld id="{15E3FA6B-A27E-4C77-A393-53B1F434E51B}" type="slidenum">
+            <a:fld id="{25D95010-CC2F-45F0-817C-D4FC02C26F5E}" type="slidenum">
               <a:t>&lt;#&gt;</a:t>
             </a:fld>
           </a:p>
@@ -953,7 +953,7 @@
         <p:txBody>
           <a:bodyPr/>
           <a:p>
-            <a:fld id="{7A45056A-804A-48B1-910F-C750CDBFD542}" type="slidenum">
+            <a:fld id="{6F084C12-7034-4C21-9A9F-01105E182C0E}" type="slidenum">
               <a:t>&lt;#&gt;</a:t>
             </a:fld>
           </a:p>
@@ -1277,7 +1277,7 @@
         <p:txBody>
           <a:bodyPr/>
           <a:p>
-            <a:fld id="{DC1F33EF-8657-45A9-8E64-E81058A8E36A}" type="slidenum">
+            <a:fld id="{40E42097-861C-4154-9397-5A87DCFB69B4}" type="slidenum">
               <a:t>&lt;#&gt;</a:t>
             </a:fld>
           </a:p>
@@ -1434,7 +1434,7 @@
         <p:txBody>
           <a:bodyPr/>
           <a:p>
-            <a:fld id="{9113548D-469C-43B5-B5A6-82E8C2099A78}" type="slidenum">
+            <a:fld id="{C3C18D64-E239-476C-90F8-FC98FDAB09B3}" type="slidenum">
               <a:t>&lt;#&gt;</a:t>
             </a:fld>
           </a:p>
@@ -1588,7 +1588,7 @@
         <p:txBody>
           <a:bodyPr/>
           <a:p>
-            <a:fld id="{D1950B2B-C32B-4FA6-BA57-D3235EA662DB}" type="slidenum">
+            <a:fld id="{91864DE4-BF7A-45B6-951F-260E707A4AF4}" type="slidenum">
               <a:t>&lt;#&gt;</a:t>
             </a:fld>
           </a:p>
@@ -1776,7 +1776,7 @@
         <p:txBody>
           <a:bodyPr/>
           <a:p>
-            <a:fld id="{144E0282-0602-456F-8CB6-5FACF967A58D}" type="slidenum">
+            <a:fld id="{775268FF-8449-4C74-97A5-BEAF5D6AAC3D}" type="slidenum">
               <a:t>&lt;#&gt;</a:t>
             </a:fld>
           </a:p>
@@ -1896,7 +1896,7 @@
         <p:txBody>
           <a:bodyPr/>
           <a:p>
-            <a:fld id="{08CC4801-3E92-450D-926F-FC189194EE46}" type="slidenum">
+            <a:fld id="{1CF05911-A935-41D1-B0D3-C7E62B0A0E8F}" type="slidenum">
               <a:t>&lt;#&gt;</a:t>
             </a:fld>
           </a:p>
@@ -2016,7 +2016,7 @@
         <p:txBody>
           <a:bodyPr/>
           <a:p>
-            <a:fld id="{52A647E2-36EF-433D-853C-E21F7908A4D7}" type="slidenum">
+            <a:fld id="{5D0D24D3-EBAB-4BED-97E6-28F83B219647}" type="slidenum">
               <a:t>&lt;#&gt;</a:t>
             </a:fld>
           </a:p>
@@ -2238,7 +2238,7 @@
         <p:txBody>
           <a:bodyPr/>
           <a:p>
-            <a:fld id="{D375FCEA-2A87-4679-9F03-15B1E8CA49C6}" type="slidenum">
+            <a:fld id="{7767E9FE-87F3-419F-89AF-9F6B2EB5743C}" type="slidenum">
               <a:t>&lt;#&gt;</a:t>
             </a:fld>
           </a:p>
@@ -2460,7 +2460,7 @@
         <p:txBody>
           <a:bodyPr/>
           <a:p>
-            <a:fld id="{2CC34110-46EE-4176-A58D-8D613F2C33DC}" type="slidenum">
+            <a:fld id="{5CA5EDE5-3423-4E14-8B3D-11960097507B}" type="slidenum">
               <a:t>&lt;#&gt;</a:t>
             </a:fld>
           </a:p>
@@ -2682,7 +2682,7 @@
         <p:txBody>
           <a:bodyPr/>
           <a:p>
-            <a:fld id="{7DE80946-07C7-4FB1-BEB9-2D25042D60B9}" type="slidenum">
+            <a:fld id="{99CA7114-FB6D-49D9-9DBA-C017368D25A1}" type="slidenum">
               <a:t>&lt;#&gt;</a:t>
             </a:fld>
           </a:p>
@@ -2751,7 +2751,7 @@
         <p:spPr>
           <a:xfrm>
             <a:off x="14623920" y="27581760"/>
-            <a:ext cx="13554720" cy="2017080"/>
+            <a:ext cx="13554000" cy="2016360"/>
           </a:xfrm>
           <a:prstGeom prst="rect">
             <a:avLst/>
@@ -2799,7 +2799,7 @@
                 </a:solidFill>
                 <a:latin typeface="Times New Roman"/>
               </a:rPr>
-              <a:t> </a:t>
+              <a:t>&lt;footer&gt;</a:t>
             </a:r>
             <a:endParaRPr b="0" lang="en-US" sz="1400" spc="-1" strike="noStrike">
               <a:latin typeface="Times New Roman"/>
@@ -2820,7 +2820,7 @@
         <p:spPr>
           <a:xfrm>
             <a:off x="30680640" y="27581760"/>
-            <a:ext cx="8915040" cy="2017080"/>
+            <a:ext cx="8914320" cy="2016360"/>
           </a:xfrm>
           <a:prstGeom prst="rect">
             <a:avLst/>
@@ -2861,14 +2861,14 @@
                 <a:tab algn="l" pos="0"/>
               </a:tabLst>
             </a:pPr>
-            <a:fld id="{297EE6D0-34EB-4168-8D93-2423F9538F8F}" type="slidenum">
+            <a:fld id="{B7EDF4EC-22CF-4ACA-8D10-0290E205F430}" type="slidenum">
               <a:rPr b="0" lang="de-DE" sz="6060" spc="-1" strike="noStrike">
                 <a:solidFill>
                   <a:srgbClr val="000000"/>
                 </a:solidFill>
                 <a:latin typeface="Times New Roman"/>
               </a:rPr>
-              <a:t>1</a:t>
+              <a:t>&lt;number&gt;</a:t>
             </a:fld>
             <a:endParaRPr b="0" lang="en-US" sz="6060" spc="-1" strike="noStrike">
               <a:latin typeface="Times New Roman"/>
@@ -2889,7 +2889,7 @@
         <p:spPr>
           <a:xfrm>
             <a:off x="3206880" y="27581760"/>
-            <a:ext cx="8915040" cy="2017080"/>
+            <a:ext cx="8914320" cy="2016360"/>
           </a:xfrm>
           <a:prstGeom prst="rect">
             <a:avLst/>
@@ -2915,7 +2915,7 @@
               <a:rPr b="0" lang="en-US" sz="1400" spc="-1" strike="noStrike">
                 <a:latin typeface="Times New Roman"/>
               </a:rPr>
-              <a:t> </a:t>
+              <a:t>&lt;date/time&gt;</a:t>
             </a:r>
             <a:endParaRPr b="0" lang="en-US" sz="1400" spc="-1" strike="noStrike">
               <a:latin typeface="Times New Roman"/>
@@ -3195,7 +3195,7 @@
         <p:spPr>
           <a:xfrm>
             <a:off x="1281960" y="19046520"/>
-            <a:ext cx="24367320" cy="10215720"/>
+            <a:ext cx="24366600" cy="10215000"/>
           </a:xfrm>
           <a:prstGeom prst="rect">
             <a:avLst/>
@@ -3226,7 +3226,7 @@
         <p:spPr>
           <a:xfrm>
             <a:off x="1281960" y="9413640"/>
-            <a:ext cx="24367320" cy="9292320"/>
+            <a:ext cx="24366600" cy="9291600"/>
           </a:xfrm>
           <a:prstGeom prst="rect">
             <a:avLst/>
@@ -3257,7 +3257,7 @@
         <p:spPr>
           <a:xfrm>
             <a:off x="1323360" y="4030200"/>
-            <a:ext cx="24330600" cy="5109840"/>
+            <a:ext cx="24329880" cy="5109120"/>
           </a:xfrm>
           <a:prstGeom prst="rect">
             <a:avLst/>
@@ -3286,7 +3286,7 @@
         <p:spPr>
           <a:xfrm>
             <a:off x="5715000" y="438840"/>
-            <a:ext cx="32607000" cy="1242000"/>
+            <a:ext cx="32606280" cy="1241280"/>
           </a:xfrm>
           <a:prstGeom prst="rect">
             <a:avLst/>
@@ -3325,11 +3325,12 @@
                   <a:srgbClr val="264796"/>
                 </a:solidFill>
                 <a:latin typeface="Calibri"/>
+                <a:ea typeface="DejaVu Sans"/>
               </a:rPr>
               <a:t>Towards Enzyme-based AD for Tuning the ICON-XPP Model</a:t>
             </a:r>
             <a:endParaRPr b="0" lang="en-US" sz="7600" spc="-1" strike="noStrike">
-              <a:latin typeface="Calibri"/>
+              <a:latin typeface="Arial"/>
             </a:endParaRPr>
           </a:p>
         </p:txBody>
@@ -3343,7 +3344,7 @@
         <p:spPr>
           <a:xfrm>
             <a:off x="8240760" y="2064600"/>
-            <a:ext cx="26426520" cy="631800"/>
+            <a:ext cx="26425800" cy="631800"/>
           </a:xfrm>
           <a:prstGeom prst="rect">
             <a:avLst/>
@@ -3395,7 +3396,7 @@
         <p:spPr>
           <a:xfrm>
             <a:off x="26000280" y="24157440"/>
-            <a:ext cx="15520680" cy="5104440"/>
+            <a:ext cx="15519960" cy="5103720"/>
           </a:xfrm>
           <a:prstGeom prst="rect">
             <a:avLst/>
@@ -3428,7 +3429,7 @@
         <p:spPr>
           <a:xfrm>
             <a:off x="26000280" y="4030200"/>
-            <a:ext cx="15520680" cy="19743480"/>
+            <a:ext cx="15519960" cy="19742760"/>
           </a:xfrm>
           <a:prstGeom prst="rect">
             <a:avLst/>
@@ -3459,7 +3460,7 @@
         <p:spPr>
           <a:xfrm>
             <a:off x="26336880" y="24426720"/>
-            <a:ext cx="14839920" cy="601560"/>
+            <a:ext cx="14839200" cy="601560"/>
           </a:xfrm>
           <a:prstGeom prst="rect">
             <a:avLst/>
@@ -3494,6 +3495,7 @@
                   <a:srgbClr val="ffffff"/>
                 </a:solidFill>
                 <a:latin typeface="Segoe UI"/>
+                <a:ea typeface="DejaVu Sans"/>
               </a:rPr>
               <a:t>References</a:t>
             </a:r>
@@ -3512,7 +3514,7 @@
         <p:spPr>
           <a:xfrm>
             <a:off x="1660320" y="4336560"/>
-            <a:ext cx="23657400" cy="607320"/>
+            <a:ext cx="23656680" cy="607320"/>
           </a:xfrm>
           <a:prstGeom prst="rect">
             <a:avLst/>
@@ -3547,6 +3549,7 @@
                   <a:srgbClr val="ffffff"/>
                 </a:solidFill>
                 <a:latin typeface="Segoe UI"/>
+                <a:ea typeface="DejaVu Sans"/>
               </a:rPr>
               <a:t>Overview</a:t>
             </a:r>
@@ -3565,7 +3568,7 @@
         <p:spPr>
           <a:xfrm>
             <a:off x="1660320" y="9726480"/>
-            <a:ext cx="23657400" cy="607320"/>
+            <a:ext cx="23656680" cy="607320"/>
           </a:xfrm>
           <a:prstGeom prst="rect">
             <a:avLst/>
@@ -3600,6 +3603,7 @@
                   <a:srgbClr val="ffffff"/>
                 </a:solidFill>
                 <a:latin typeface="Segoe UI"/>
+                <a:ea typeface="DejaVu Sans"/>
               </a:rPr>
               <a:t>Approach</a:t>
             </a:r>
@@ -3618,7 +3622,7 @@
         <p:spPr>
           <a:xfrm>
             <a:off x="1660320" y="19274400"/>
-            <a:ext cx="23657400" cy="601560"/>
+            <a:ext cx="23656680" cy="601560"/>
           </a:xfrm>
           <a:prstGeom prst="rect">
             <a:avLst/>
@@ -3653,6 +3657,7 @@
                   <a:srgbClr val="ffffff"/>
                 </a:solidFill>
                 <a:latin typeface="Segoe UI"/>
+                <a:ea typeface="DejaVu Sans"/>
               </a:rPr>
               <a:t>Candidate Schemes and Parameters</a:t>
             </a:r>
@@ -3671,7 +3676,7 @@
         <p:spPr>
           <a:xfrm>
             <a:off x="26336880" y="4343040"/>
-            <a:ext cx="14839920" cy="601560"/>
+            <a:ext cx="14839200" cy="601560"/>
           </a:xfrm>
           <a:prstGeom prst="rect">
             <a:avLst/>
@@ -3706,6 +3711,7 @@
                   <a:srgbClr val="ffffff"/>
                 </a:solidFill>
                 <a:latin typeface="Segoe UI"/>
+                <a:ea typeface="DejaVu Sans"/>
               </a:rPr>
               <a:t>Challenges and Outlook</a:t>
             </a:r>
@@ -3724,7 +3730,7 @@
         <p:spPr>
           <a:xfrm>
             <a:off x="1281240" y="3525120"/>
-            <a:ext cx="40240800" cy="36000"/>
+            <a:ext cx="40240080" cy="35280"/>
           </a:xfrm>
           <a:custGeom>
             <a:avLst/>
@@ -3771,7 +3777,7 @@
         <p:spPr>
           <a:xfrm>
             <a:off x="38322000" y="889200"/>
-            <a:ext cx="3179880" cy="2242800"/>
+            <a:ext cx="3179160" cy="2242080"/>
           </a:xfrm>
           <a:prstGeom prst="rect">
             <a:avLst/>
@@ -3794,7 +3800,7 @@
         <p:spPr>
           <a:xfrm>
             <a:off x="1324800" y="93600"/>
-            <a:ext cx="8282520" cy="3184920"/>
+            <a:ext cx="8281800" cy="3184200"/>
           </a:xfrm>
           <a:prstGeom prst="rect">
             <a:avLst/>
@@ -3813,9 +3819,9 @@
         <p:grpSpPr>
           <a:xfrm>
             <a:off x="26227800" y="5398560"/>
-            <a:ext cx="7086240" cy="7885440"/>
+            <a:ext cx="7085520" cy="7884720"/>
             <a:chOff x="26227800" y="5398560"/>
-            <a:chExt cx="7086240" cy="7885440"/>
+            <a:chExt cx="7085520" cy="7884720"/>
           </a:xfrm>
         </p:grpSpPr>
         <p:grpSp>
@@ -3954,7 +3960,7 @@
           <p:spPr>
             <a:xfrm>
               <a:off x="28303920" y="5398560"/>
-              <a:ext cx="2351520" cy="965520"/>
+              <a:ext cx="2350800" cy="964800"/>
             </a:xfrm>
             <a:prstGeom prst="roundRect">
               <a:avLst>
@@ -3992,6 +3998,7 @@
                     <a:srgbClr val="000000"/>
                   </a:solidFill>
                   <a:latin typeface="Segoe UI"/>
+                  <a:ea typeface="DejaVu Sans"/>
                 </a:rPr>
                 <a:t>ICON-XPP</a:t>
               </a:r>
@@ -4010,7 +4017,7 @@
           <p:spPr>
             <a:xfrm>
               <a:off x="26876160" y="7553160"/>
-              <a:ext cx="2101320" cy="965520"/>
+              <a:ext cx="2100600" cy="964800"/>
             </a:xfrm>
             <a:prstGeom prst="roundRect">
               <a:avLst>
@@ -4048,6 +4055,7 @@
                     <a:srgbClr val="000000"/>
                   </a:solidFill>
                   <a:latin typeface="Segoe UI"/>
+                  <a:ea typeface="DejaVu Sans"/>
                 </a:rPr>
                 <a:t>LLVM IR</a:t>
               </a:r>
@@ -4066,7 +4074,7 @@
           <p:spPr>
             <a:xfrm>
               <a:off x="30070080" y="7553160"/>
-              <a:ext cx="2100960" cy="965520"/>
+              <a:ext cx="2100240" cy="964800"/>
             </a:xfrm>
             <a:prstGeom prst="roundRect">
               <a:avLst>
@@ -4104,6 +4112,7 @@
                     <a:srgbClr val="000000"/>
                   </a:solidFill>
                   <a:latin typeface="Segoe UI"/>
+                  <a:ea typeface="DejaVu Sans"/>
                 </a:rPr>
                 <a:t>LLVM IR</a:t>
               </a:r>
@@ -4206,7 +4215,7 @@
           <p:spPr>
             <a:xfrm>
               <a:off x="26227800" y="6318360"/>
-              <a:ext cx="2285640" cy="1208160"/>
+              <a:ext cx="2284920" cy="1207440"/>
             </a:xfrm>
             <a:prstGeom prst="rect">
               <a:avLst/>
@@ -4239,6 +4248,7 @@
                     <a:srgbClr val="000000"/>
                   </a:solidFill>
                   <a:latin typeface="Segoe UI"/>
+                  <a:ea typeface="DejaVu Sans"/>
                 </a:rPr>
                 <a:t>IFX 2023.x</a:t>
               </a:r>
@@ -4257,7 +4267,7 @@
           <p:spPr>
             <a:xfrm>
               <a:off x="30209400" y="6332400"/>
-              <a:ext cx="1931040" cy="1208160"/>
+              <a:ext cx="1930320" cy="1207440"/>
             </a:xfrm>
             <a:prstGeom prst="rect">
               <a:avLst/>
@@ -4290,6 +4300,7 @@
                     <a:srgbClr val="000000"/>
                   </a:solidFill>
                   <a:latin typeface="Segoe UI"/>
+                  <a:ea typeface="DejaVu Sans"/>
                 </a:rPr>
                 <a:t>Flang</a:t>
               </a:r>
@@ -4307,8 +4318,8 @@
           </p:nvSpPr>
           <p:spPr>
             <a:xfrm rot="10800000">
-              <a:off x="29322360" y="10090800"/>
-              <a:ext cx="321480" cy="321480"/>
+              <a:off x="29323080" y="10091520"/>
+              <a:ext cx="320760" cy="320760"/>
             </a:xfrm>
             <a:prstGeom prst="triangle">
               <a:avLst>
@@ -4368,7 +4379,7 @@
           <p:spPr>
             <a:xfrm>
               <a:off x="29312280" y="9416880"/>
-              <a:ext cx="2401560" cy="1065600"/>
+              <a:ext cx="2400840" cy="1064880"/>
             </a:xfrm>
             <a:prstGeom prst="rect">
               <a:avLst/>
@@ -4401,6 +4412,7 @@
                     <a:srgbClr val="000000"/>
                   </a:solidFill>
                   <a:latin typeface="Segoe UI"/>
+                  <a:ea typeface="DejaVu Sans"/>
                 </a:rPr>
                 <a:t>Enzyme</a:t>
               </a:r>
@@ -4419,7 +4431,7 @@
           <p:spPr>
             <a:xfrm>
               <a:off x="28004760" y="10442880"/>
-              <a:ext cx="2927880" cy="965520"/>
+              <a:ext cx="2927160" cy="964800"/>
             </a:xfrm>
             <a:prstGeom prst="roundRect">
               <a:avLst>
@@ -4457,6 +4469,7 @@
                     <a:srgbClr val="000000"/>
                   </a:solidFill>
                   <a:latin typeface="Segoe UI"/>
+                  <a:ea typeface="DejaVu Sans"/>
                 </a:rPr>
                 <a:t>AD LLVM IR</a:t>
               </a:r>
@@ -4502,8 +4515,8 @@
           </p:nvSpPr>
           <p:spPr>
             <a:xfrm rot="10800000">
-              <a:off x="29322360" y="11966760"/>
-              <a:ext cx="321480" cy="321480"/>
+              <a:off x="29323080" y="11967480"/>
+              <a:ext cx="320760" cy="320760"/>
             </a:xfrm>
             <a:prstGeom prst="triangle">
               <a:avLst>
@@ -4535,7 +4548,7 @@
           <p:spPr>
             <a:xfrm>
               <a:off x="27900000" y="12318480"/>
-              <a:ext cx="3177000" cy="965520"/>
+              <a:ext cx="3176280" cy="964800"/>
             </a:xfrm>
             <a:prstGeom prst="roundRect">
               <a:avLst>
@@ -4573,6 +4586,7 @@
                     <a:srgbClr val="000000"/>
                   </a:solidFill>
                   <a:latin typeface="Segoe UI"/>
+                  <a:ea typeface="DejaVu Sans"/>
                 </a:rPr>
                 <a:t>AD ICON-XPP</a:t>
               </a:r>
@@ -4591,7 +4605,7 @@
           <p:spPr>
             <a:xfrm>
               <a:off x="29312640" y="11545920"/>
-              <a:ext cx="4001400" cy="1065600"/>
+              <a:ext cx="4000680" cy="1064880"/>
             </a:xfrm>
             <a:prstGeom prst="rect">
               <a:avLst/>
@@ -4624,6 +4638,7 @@
                     <a:srgbClr val="000000"/>
                   </a:solidFill>
                   <a:latin typeface="Segoe UI"/>
+                  <a:ea typeface="DejaVu Sans"/>
                 </a:rPr>
                 <a:t>GNU Autotools</a:t>
               </a:r>
@@ -4647,8 +4662,8 @@
         </p:blipFill>
         <p:spPr>
           <a:xfrm>
-            <a:off x="1336320" y="10335600"/>
-            <a:ext cx="6893280" cy="6733080"/>
+            <a:off x="1372320" y="10335600"/>
+            <a:ext cx="6664320" cy="6509520"/>
           </a:xfrm>
           <a:prstGeom prst="rect">
             <a:avLst/>
@@ -4661,13 +4676,13 @@
       <p:sp>
         <p:nvSpPr>
           <p:cNvPr id="85" name=""/>
-          <p:cNvSpPr txBox="1"/>
+          <p:cNvSpPr/>
           <p:nvPr/>
         </p:nvSpPr>
         <p:spPr>
           <a:xfrm>
             <a:off x="26373600" y="25122600"/>
-            <a:ext cx="14630400" cy="3828600"/>
+            <a:ext cx="14629680" cy="3827880"/>
           </a:xfrm>
           <a:prstGeom prst="rect">
             <a:avLst/>
@@ -4677,26 +4692,50 @@
             <a:noFill/>
           </a:ln>
         </p:spPr>
+        <p:style>
+          <a:lnRef idx="0"/>
+          <a:fillRef idx="0"/>
+          <a:effectRef idx="0"/>
+          <a:fontRef idx="minor"/>
+        </p:style>
         <p:txBody>
           <a:bodyPr lIns="90000" rIns="90000" tIns="45000" bIns="45000" anchor="t">
             <a:noAutofit/>
           </a:bodyPr>
           <a:p>
+            <a:pPr>
+              <a:lnSpc>
+                <a:spcPct val="100000"/>
+              </a:lnSpc>
+              <a:buNone/>
+            </a:pPr>
             <a:r>
               <a:rPr b="0" lang="en-US" sz="2400" spc="-1" strike="noStrike">
+                <a:solidFill>
+                  <a:srgbClr val="000000"/>
+                </a:solidFill>
                 <a:latin typeface="Arial"/>
+                <a:ea typeface="DejaVu Sans"/>
               </a:rPr>
               <a:t>1. Müller, W. A. et al.: The ICON-based Earth System Model for climate predictions and projections (ICON XPP v1.0), </a:t>
             </a:r>
             <a:r>
               <a:rPr b="0" i="1" lang="en-US" sz="2400" spc="-1" strike="noStrike">
+                <a:solidFill>
+                  <a:srgbClr val="000000"/>
+                </a:solidFill>
                 <a:latin typeface="Arial"/>
+                <a:ea typeface="DejaVu Sans"/>
               </a:rPr>
               <a:t>Geosci. Model Dev.</a:t>
             </a:r>
             <a:r>
               <a:rPr b="0" lang="en-US" sz="2400" spc="-1" strike="noStrike">
+                <a:solidFill>
+                  <a:srgbClr val="000000"/>
+                </a:solidFill>
                 <a:latin typeface="Arial"/>
+                <a:ea typeface="DejaVu Sans"/>
               </a:rPr>
               <a:t>, 18, 9385–9415, 2025.</a:t>
             </a:r>
@@ -4705,21 +4744,39 @@
             </a:endParaRPr>
           </a:p>
           <a:p>
+            <a:pPr>
+              <a:lnSpc>
+                <a:spcPct val="100000"/>
+              </a:lnSpc>
+              <a:buNone/>
+            </a:pPr>
             <a:r>
               <a:rPr b="0" lang="en-US" sz="2400" spc="-1" strike="noStrike">
+                <a:solidFill>
+                  <a:srgbClr val="000000"/>
+                </a:solidFill>
                 <a:latin typeface="Arial"/>
+                <a:ea typeface="DejaVu Sans"/>
               </a:rPr>
               <a:t>2. Jungclaus JH, et al. The icon Earth System Model Version 1.0. </a:t>
             </a:r>
             <a:r>
               <a:rPr b="0" i="1" lang="en-US" sz="2400" spc="-1" strike="noStrike">
+                <a:solidFill>
+                  <a:srgbClr val="000000"/>
+                </a:solidFill>
                 <a:latin typeface="Arial"/>
+                <a:ea typeface="DejaVu Sans"/>
               </a:rPr>
               <a:t>Journal of Advances in Modeling Earth Systems. </a:t>
             </a:r>
             <a:r>
               <a:rPr b="0" lang="en-US" sz="2400" spc="-1" strike="noStrike">
+                <a:solidFill>
+                  <a:srgbClr val="000000"/>
+                </a:solidFill>
                 <a:latin typeface="Arial"/>
+                <a:ea typeface="DejaVu Sans"/>
               </a:rPr>
               <a:t>14(4), 2022. </a:t>
             </a:r>
@@ -4728,21 +4785,39 @@
             </a:endParaRPr>
           </a:p>
           <a:p>
+            <a:pPr>
+              <a:lnSpc>
+                <a:spcPct val="100000"/>
+              </a:lnSpc>
+              <a:buNone/>
+            </a:pPr>
             <a:r>
               <a:rPr b="0" lang="en-US" sz="2400" spc="-1" strike="noStrike">
+                <a:solidFill>
+                  <a:srgbClr val="000000"/>
+                </a:solidFill>
                 <a:latin typeface="Arial"/>
+                <a:ea typeface="DejaVu Sans"/>
               </a:rPr>
               <a:t>3. Moses WS, et al. DJ4Earth: Differentiable, and performance‐portable Earth System Modeling via program transformations. </a:t>
             </a:r>
             <a:r>
               <a:rPr b="0" i="1" lang="en-US" sz="2400" spc="-1" strike="noStrike">
+                <a:solidFill>
+                  <a:srgbClr val="000000"/>
+                </a:solidFill>
                 <a:latin typeface="Arial"/>
+                <a:ea typeface="DejaVu Sans"/>
               </a:rPr>
               <a:t>Journal of Advances in Modeling Earth Systems.</a:t>
             </a:r>
             <a:r>
               <a:rPr b="0" lang="en-US" sz="2400" spc="-1" strike="noStrike">
+                <a:solidFill>
+                  <a:srgbClr val="000000"/>
+                </a:solidFill>
                 <a:latin typeface="Arial"/>
+                <a:ea typeface="DejaVu Sans"/>
               </a:rPr>
               <a:t> 18(5), 2026.</a:t>
             </a:r>
@@ -4751,9 +4826,19 @@
             </a:endParaRPr>
           </a:p>
           <a:p>
+            <a:pPr>
+              <a:lnSpc>
+                <a:spcPct val="100000"/>
+              </a:lnSpc>
+              <a:buNone/>
+            </a:pPr>
             <a:r>
               <a:rPr b="0" lang="en-US" sz="2400" spc="-1" strike="noStrike">
+                <a:solidFill>
+                  <a:srgbClr val="000000"/>
+                </a:solidFill>
                 <a:latin typeface="Arial"/>
+                <a:ea typeface="DejaVu Sans"/>
               </a:rPr>
               <a:t>4. Moses WS, et al. Scalable automatic differentiation of multiple parallel paradigms through compiler augmentation. In: Proceedings of the International Conference on High Performance Computing, Networking, Storage and Analysis (SC '22). IEEE, 1-18, 2022. </a:t>
             </a:r>
@@ -4762,11 +4847,23 @@
             </a:endParaRPr>
           </a:p>
           <a:p>
+            <a:pPr>
+              <a:lnSpc>
+                <a:spcPct val="100000"/>
+              </a:lnSpc>
+              <a:buNone/>
+            </a:pPr>
             <a:endParaRPr b="0" lang="en-US" sz="2400" spc="-1" strike="noStrike">
               <a:latin typeface="Arial"/>
             </a:endParaRPr>
           </a:p>
           <a:p>
+            <a:pPr>
+              <a:lnSpc>
+                <a:spcPct val="100000"/>
+              </a:lnSpc>
+              <a:buNone/>
+            </a:pPr>
             <a:endParaRPr b="0" lang="en-US" sz="2400" spc="-1" strike="noStrike">
               <a:latin typeface="Arial"/>
             </a:endParaRPr>
@@ -4776,13 +4873,13 @@
       <p:sp>
         <p:nvSpPr>
           <p:cNvPr id="86" name=""/>
-          <p:cNvSpPr txBox="1"/>
+          <p:cNvSpPr/>
           <p:nvPr/>
         </p:nvSpPr>
         <p:spPr>
           <a:xfrm>
             <a:off x="32918400" y="5404680"/>
-            <a:ext cx="8602560" cy="8311320"/>
+            <a:ext cx="8601840" cy="8310600"/>
           </a:xfrm>
           <a:prstGeom prst="rect">
             <a:avLst/>
@@ -4792,12 +4889,21 @@
             <a:noFill/>
           </a:ln>
         </p:spPr>
+        <p:style>
+          <a:lnRef idx="0"/>
+          <a:fillRef idx="0"/>
+          <a:effectRef idx="0"/>
+          <a:fontRef idx="minor"/>
+        </p:style>
         <p:txBody>
           <a:bodyPr lIns="90000" rIns="90000" tIns="45000" bIns="45000" anchor="t">
             <a:noAutofit/>
           </a:bodyPr>
           <a:p>
             <a:pPr marL="216000" indent="-216000">
+              <a:lnSpc>
+                <a:spcPct val="100000"/>
+              </a:lnSpc>
               <a:buClr>
                 <a:srgbClr val="000000"/>
               </a:buClr>
@@ -4807,17 +4913,25 @@
             </a:pPr>
             <a:r>
               <a:rPr b="1" lang="en-US" sz="3200" spc="-1" strike="noStrike">
+                <a:solidFill>
+                  <a:srgbClr val="000000"/>
+                </a:solidFill>
                 <a:latin typeface="Arial"/>
+                <a:ea typeface="DejaVu Sans"/>
               </a:rPr>
               <a:t>Figure 2: </a:t>
             </a:r>
             <a:r>
               <a:rPr b="0" lang="en-US" sz="3200" spc="-1" strike="noStrike">
+                <a:solidFill>
+                  <a:srgbClr val="000000"/>
+                </a:solidFill>
                 <a:latin typeface="Arial"/>
+                <a:ea typeface="DejaVu Sans"/>
               </a:rPr>
               <a:t>IFX is a supported ICON compiler and provides an LLVM-based backend, but its generated IR is not designed as a stable public interface.Flang provides an open LLVM-based Fortran compilation path but does not yet compile the complete ICON software stack. Establishing a robust ICON to LLVM to Enzyme workflow is therefore a major initial challenge. Note, however, there is ongoing work at the German Climate Computing Center (DKRZ) for supporting Flang-based compilation. ICON can be compiled with IFX 2025.3; however, it is not trivial for Enzyme to support optimization of Intel compiler emitted LLVM IR as it is currently an open question since instead the Flang MLIR—known as FIR—may become the sole AD transformation target of Enzyme.</a:t>
             </a:r>
-            <a:endParaRPr b="1" lang="en-US" sz="3200" spc="-1" strike="noStrike">
+            <a:endParaRPr b="0" lang="en-US" sz="3200" spc="-1" strike="noStrike">
               <a:latin typeface="Arial"/>
             </a:endParaRPr>
           </a:p>
@@ -4826,13 +4940,13 @@
       <p:sp>
         <p:nvSpPr>
           <p:cNvPr id="87" name=""/>
-          <p:cNvSpPr txBox="1"/>
+          <p:cNvSpPr/>
           <p:nvPr/>
         </p:nvSpPr>
         <p:spPr>
           <a:xfrm>
             <a:off x="1660320" y="4996080"/>
-            <a:ext cx="23485680" cy="3282120"/>
+            <a:ext cx="23484960" cy="3281400"/>
           </a:xfrm>
           <a:prstGeom prst="rect">
             <a:avLst/>
@@ -4842,12 +4956,21 @@
             <a:noFill/>
           </a:ln>
         </p:spPr>
+        <p:style>
+          <a:lnRef idx="0"/>
+          <a:fillRef idx="0"/>
+          <a:effectRef idx="0"/>
+          <a:fontRef idx="minor"/>
+        </p:style>
         <p:txBody>
           <a:bodyPr lIns="90000" rIns="90000" tIns="45000" bIns="45000" anchor="t">
             <a:noAutofit/>
           </a:bodyPr>
           <a:p>
             <a:pPr marL="216000" indent="-216000">
+              <a:lnSpc>
+                <a:spcPct val="100000"/>
+              </a:lnSpc>
               <a:buClr>
                 <a:srgbClr val="000000"/>
               </a:buClr>
@@ -4857,7 +4980,11 @@
             </a:pPr>
             <a:r>
               <a:rPr b="1" lang="en-US" sz="3200" spc="-1" strike="noStrike">
+                <a:solidFill>
+                  <a:srgbClr val="000000"/>
+                </a:solidFill>
                 <a:latin typeface="Arial"/>
+                <a:ea typeface="DejaVu Sans"/>
               </a:rPr>
               <a:t>Can automatic differentiation help us calibrate the atmosphere from the surface to space?</a:t>
             </a:r>
@@ -4866,13 +4993,11 @@
             </a:endParaRPr>
           </a:p>
           <a:p>
-            <a:pPr marL="216000" indent="-216000">
-              <a:buClr>
-                <a:srgbClr val="000000"/>
-              </a:buClr>
-              <a:buSzPct val="45000"/>
-              <a:buFont typeface="Wingdings" charset="2"/>
-              <a:buChar char=""/>
+            <a:pPr>
+              <a:lnSpc>
+                <a:spcPct val="100000"/>
+              </a:lnSpc>
+              <a:buNone/>
             </a:pPr>
             <a:endParaRPr b="0" lang="en-US" sz="3200" spc="-1" strike="noStrike">
               <a:latin typeface="Arial"/>
@@ -4880,6 +5005,9 @@
           </a:p>
           <a:p>
             <a:pPr marL="216000" indent="-216000">
+              <a:lnSpc>
+                <a:spcPct val="100000"/>
+              </a:lnSpc>
               <a:buClr>
                 <a:srgbClr val="000000"/>
               </a:buClr>
@@ -4889,7 +5017,11 @@
             </a:pPr>
             <a:r>
               <a:rPr b="0" lang="en-US" sz="3200" spc="-1" strike="noStrike">
+                <a:solidFill>
+                  <a:srgbClr val="000000"/>
+                </a:solidFill>
                 <a:latin typeface="Arial"/>
+                <a:ea typeface="DejaVu Sans"/>
               </a:rPr>
               <a:t>ICON-XPP is a state-of-the-art Earth system model for which a subset known as UA-ICON extends the model atmosphere from 75 to 150 km. This creates new physical constraints from the upper atmosphere, whose response to climate forcing can differ dramatically from that of the lower atmosphere. We will use Enzyme-based automatic differentiation to quantify parameter sensitivities and enable efficient, systematic calibration of the coupled model. This provides a foundation not only for improved physical parameterizations, but ultimately for differentiable hybrid ML–physics modelling and online optimization.</a:t>
             </a:r>
@@ -4912,7 +5044,7 @@
         <p:spPr>
           <a:xfrm>
             <a:off x="11721600" y="11070000"/>
-            <a:ext cx="5655600" cy="5655600"/>
+            <a:ext cx="5654880" cy="5654880"/>
           </a:xfrm>
           <a:prstGeom prst="rect">
             <a:avLst/>
@@ -4935,7 +5067,7 @@
         <p:spPr>
           <a:xfrm>
             <a:off x="21364200" y="11803680"/>
-            <a:ext cx="3657600" cy="4198320"/>
+            <a:ext cx="3656880" cy="4197600"/>
           </a:xfrm>
           <a:prstGeom prst="rect">
             <a:avLst/>
@@ -4954,7 +5086,7 @@
         <p:spPr>
           <a:xfrm>
             <a:off x="17634600" y="13716000"/>
-            <a:ext cx="3429000" cy="457200"/>
+            <a:ext cx="3428280" cy="456480"/>
           </a:xfrm>
           <a:custGeom>
             <a:avLst/>
@@ -5013,7 +5145,7 @@
         <p:spPr>
           <a:xfrm>
             <a:off x="8418600" y="13716360"/>
-            <a:ext cx="3429000" cy="457200"/>
+            <a:ext cx="3428280" cy="456480"/>
           </a:xfrm>
           <a:custGeom>
             <a:avLst/>
@@ -5066,13 +5198,13 @@
       <p:sp>
         <p:nvSpPr>
           <p:cNvPr id="92" name=""/>
-          <p:cNvSpPr txBox="1"/>
+          <p:cNvSpPr/>
           <p:nvPr/>
         </p:nvSpPr>
         <p:spPr>
           <a:xfrm>
-            <a:off x="1780200" y="16857000"/>
-            <a:ext cx="23365800" cy="1913400"/>
+            <a:off x="1780200" y="16641000"/>
+            <a:ext cx="23365080" cy="1912680"/>
           </a:xfrm>
           <a:prstGeom prst="rect">
             <a:avLst/>
@@ -5082,20 +5214,40 @@
             <a:noFill/>
           </a:ln>
         </p:spPr>
+        <p:style>
+          <a:lnRef idx="0"/>
+          <a:fillRef idx="0"/>
+          <a:effectRef idx="0"/>
+          <a:fontRef idx="minor"/>
+        </p:style>
         <p:txBody>
           <a:bodyPr lIns="90000" rIns="90000" tIns="45000" bIns="45000" anchor="t">
             <a:noAutofit/>
           </a:bodyPr>
           <a:p>
+            <a:pPr>
+              <a:lnSpc>
+                <a:spcPct val="100000"/>
+              </a:lnSpc>
+              <a:buNone/>
+            </a:pPr>
             <a:r>
               <a:rPr b="1" lang="en-US" sz="3200" spc="-1" strike="noStrike">
+                <a:solidFill>
+                  <a:srgbClr val="000000"/>
+                </a:solidFill>
                 <a:latin typeface="Arial"/>
+                <a:ea typeface="DejaVu Sans"/>
               </a:rPr>
               <a:t>Figure 1:</a:t>
             </a:r>
             <a:r>
               <a:rPr b="0" lang="en-US" sz="3200" spc="-1" strike="noStrike">
+                <a:solidFill>
+                  <a:srgbClr val="000000"/>
+                </a:solidFill>
                 <a:latin typeface="Arial"/>
+                <a:ea typeface="DejaVu Sans"/>
               </a:rPr>
               <a:t> Enzyme operates on the LLVM intermediate representation generated from ICON's Fortran code, providing forward- and reverse-mode derivatives without requiring separately maintained tangent-linear or adjoint source code. We initially target self-contained physics parameterizations and scalar tuning parameters, allowing us to quantify local parameter sensitivities before extending toward larger coupled model components.</a:t>
             </a:r>
@@ -5113,7 +5265,7 @@
         </p:nvGraphicFramePr>
         <p:xfrm>
           <a:off x="1634040" y="20009160"/>
-          <a:ext cx="23511960" cy="4914720"/>
+          <a:ext cx="23511600" cy="3475080"/>
         </p:xfrm>
         <a:graphic>
           <a:graphicData uri="http://schemas.openxmlformats.org/drawingml/2006/table">
@@ -5125,14 +5277,17 @@
                 <a:gridCol w="9687240"/>
                 <a:gridCol w="6351840"/>
               </a:tblGrid>
-              <a:tr h="347400">
+              <a:tr h="579240">
                 <a:tc>
                   <a:txBody>
-                    <a:bodyPr lIns="90000" rIns="90000" tIns="46800" bIns="46800" anchor="t">
+                    <a:bodyPr lIns="90000" rIns="90000" anchor="t">
                       <a:noAutofit/>
                     </a:bodyPr>
                     <a:p>
                       <a:pPr algn="ctr">
+                        <a:lnSpc>
+                          <a:spcPct val="100000"/>
+                        </a:lnSpc>
                         <a:buNone/>
                       </a:pPr>
                       <a:r>
@@ -5141,7 +5296,7 @@
                         </a:rPr>
                         <a:t>Scheme</a:t>
                       </a:r>
-                      <a:endParaRPr b="1" lang="en-US" sz="3200" spc="-1" strike="noStrike">
+                      <a:endParaRPr b="0" lang="en-US" sz="3200" spc="-1" strike="noStrike">
                         <a:latin typeface="Arial"/>
                       </a:endParaRPr>
                     </a:p>
@@ -5174,11 +5329,14 @@
                 </a:tc>
                 <a:tc>
                   <a:txBody>
-                    <a:bodyPr lIns="90000" rIns="90000" tIns="46800" bIns="46800" anchor="t">
+                    <a:bodyPr lIns="90000" rIns="90000" anchor="t">
                       <a:noAutofit/>
                     </a:bodyPr>
                     <a:p>
                       <a:pPr algn="ctr">
+                        <a:lnSpc>
+                          <a:spcPct val="100000"/>
+                        </a:lnSpc>
                         <a:buNone/>
                       </a:pPr>
                       <a:r>
@@ -5187,7 +5345,7 @@
                         </a:rPr>
                         <a:t>Parameter</a:t>
                       </a:r>
-                      <a:endParaRPr b="1" lang="en-US" sz="3200" spc="-1" strike="noStrike">
+                      <a:endParaRPr b="0" lang="en-US" sz="3200" spc="-1" strike="noStrike">
                         <a:latin typeface="Arial"/>
                       </a:endParaRPr>
                     </a:p>
@@ -5220,11 +5378,14 @@
                 </a:tc>
                 <a:tc>
                   <a:txBody>
-                    <a:bodyPr lIns="90000" rIns="90000" tIns="46800" bIns="46800" anchor="t">
+                    <a:bodyPr lIns="90000" rIns="90000" anchor="t">
                       <a:noAutofit/>
                     </a:bodyPr>
                     <a:p>
                       <a:pPr algn="ctr">
+                        <a:lnSpc>
+                          <a:spcPct val="100000"/>
+                        </a:lnSpc>
                         <a:buNone/>
                       </a:pPr>
                       <a:r>
@@ -5233,7 +5394,7 @@
                         </a:rPr>
                         <a:t>Meaning</a:t>
                       </a:r>
-                      <a:endParaRPr b="1" lang="en-US" sz="3200" spc="-1" strike="noStrike">
+                      <a:endParaRPr b="0" lang="en-US" sz="3200" spc="-1" strike="noStrike">
                         <a:latin typeface="Arial"/>
                       </a:endParaRPr>
                     </a:p>
@@ -5266,11 +5427,14 @@
                 </a:tc>
                 <a:tc>
                   <a:txBody>
-                    <a:bodyPr lIns="90000" rIns="90000" tIns="46800" bIns="46800" anchor="t">
+                    <a:bodyPr lIns="90000" rIns="90000" anchor="t">
                       <a:noAutofit/>
                     </a:bodyPr>
                     <a:p>
                       <a:pPr algn="ctr">
+                        <a:lnSpc>
+                          <a:spcPct val="100000"/>
+                        </a:lnSpc>
                         <a:buNone/>
                       </a:pPr>
                       <a:r>
@@ -5279,7 +5443,7 @@
                         </a:rPr>
                         <a:t>Nominal value ± range</a:t>
                       </a:r>
-                      <a:endParaRPr b="1" lang="en-US" sz="3200" spc="-1" strike="noStrike">
+                      <a:endParaRPr b="0" lang="en-US" sz="3200" spc="-1" strike="noStrike">
                         <a:latin typeface="Arial"/>
                       </a:endParaRPr>
                     </a:p>
@@ -5311,14 +5475,17 @@
                   </a:tcPr>
                 </a:tc>
               </a:tr>
-              <a:tr h="0">
+              <a:tr h="579240">
                 <a:tc>
                   <a:txBody>
-                    <a:bodyPr lIns="90000" rIns="90000" tIns="46800" bIns="46800" anchor="t">
+                    <a:bodyPr lIns="90000" rIns="90000" anchor="t">
                       <a:noAutofit/>
                     </a:bodyPr>
                     <a:p>
                       <a:pPr algn="ctr">
+                        <a:lnSpc>
+                          <a:spcPct val="100000"/>
+                        </a:lnSpc>
                         <a:buNone/>
                       </a:pPr>
                       <a:r>
@@ -5327,7 +5494,7 @@
                         </a:rPr>
                         <a:t>GWD</a:t>
                       </a:r>
-                      <a:endParaRPr b="1" lang="en-US" sz="3200" spc="-1" strike="noStrike">
+                      <a:endParaRPr b="0" lang="en-US" sz="3200" spc="-1" strike="noStrike">
                         <a:latin typeface="Arial"/>
                       </a:endParaRPr>
                     </a:p>
@@ -5360,11 +5527,14 @@
                 </a:tc>
                 <a:tc>
                   <a:txBody>
-                    <a:bodyPr lIns="90000" rIns="90000" tIns="46800" bIns="46800" anchor="t">
+                    <a:bodyPr lIns="90000" rIns="90000" anchor="t">
                       <a:noAutofit/>
                     </a:bodyPr>
                     <a:p>
                       <a:pPr algn="ctr">
+                        <a:lnSpc>
+                          <a:spcPct val="100000"/>
+                        </a:lnSpc>
                         <a:buNone/>
                       </a:pPr>
                       <a:r>
@@ -5406,10 +5576,16 @@
                 </a:tc>
                 <a:tc>
                   <a:txBody>
-                    <a:bodyPr lIns="90000" rIns="90000" tIns="46800" bIns="46800" anchor="t">
+                    <a:bodyPr lIns="90000" rIns="90000" anchor="t">
                       <a:noAutofit/>
                     </a:bodyPr>
                     <a:p>
+                      <a:pPr>
+                        <a:lnSpc>
+                          <a:spcPct val="100000"/>
+                        </a:lnSpc>
+                        <a:buNone/>
+                      </a:pPr>
                       <a:r>
                         <a:rPr b="0" lang="en-US" sz="3200" spc="-1" strike="noStrike">
                           <a:latin typeface="Arial"/>
@@ -5449,11 +5625,14 @@
                 </a:tc>
                 <a:tc>
                   <a:txBody>
-                    <a:bodyPr lIns="90000" rIns="90000" tIns="46800" bIns="46800" anchor="t">
+                    <a:bodyPr lIns="90000" rIns="90000" anchor="t">
                       <a:noAutofit/>
                     </a:bodyPr>
                     <a:p>
                       <a:pPr algn="ctr">
+                        <a:lnSpc>
+                          <a:spcPct val="100000"/>
+                        </a:lnSpc>
                         <a:buNone/>
                       </a:pPr>
                       <a:r>
@@ -5494,14 +5673,17 @@
                   </a:tcPr>
                 </a:tc>
               </a:tr>
-              <a:tr h="0">
+              <a:tr h="579240">
                 <a:tc>
                   <a:txBody>
-                    <a:bodyPr lIns="90000" rIns="90000" tIns="46800" bIns="46800" anchor="t">
+                    <a:bodyPr lIns="90000" rIns="90000" anchor="t">
                       <a:noAutofit/>
                     </a:bodyPr>
                     <a:p>
                       <a:pPr algn="ctr">
+                        <a:lnSpc>
+                          <a:spcPct val="100000"/>
+                        </a:lnSpc>
                         <a:buNone/>
                       </a:pPr>
                       <a:r>
@@ -5510,7 +5692,7 @@
                         </a:rPr>
                         <a:t>SSO</a:t>
                       </a:r>
-                      <a:endParaRPr b="1" lang="en-US" sz="3200" spc="-1" strike="noStrike">
+                      <a:endParaRPr b="0" lang="en-US" sz="3200" spc="-1" strike="noStrike">
                         <a:latin typeface="Arial"/>
                       </a:endParaRPr>
                     </a:p>
@@ -5543,11 +5725,14 @@
                 </a:tc>
                 <a:tc>
                   <a:txBody>
-                    <a:bodyPr lIns="90000" rIns="90000" tIns="46800" bIns="46800" anchor="t">
+                    <a:bodyPr lIns="90000" rIns="90000" anchor="t">
                       <a:noAutofit/>
                     </a:bodyPr>
                     <a:p>
                       <a:pPr algn="ctr">
+                        <a:lnSpc>
+                          <a:spcPct val="100000"/>
+                        </a:lnSpc>
                         <a:buNone/>
                       </a:pPr>
                       <a:r>
@@ -5589,10 +5774,16 @@
                 </a:tc>
                 <a:tc>
                   <a:txBody>
-                    <a:bodyPr lIns="90000" rIns="90000" tIns="46800" bIns="46800" anchor="t">
+                    <a:bodyPr lIns="90000" rIns="90000" anchor="t">
                       <a:noAutofit/>
                     </a:bodyPr>
                     <a:p>
+                      <a:pPr>
+                        <a:lnSpc>
+                          <a:spcPct val="100000"/>
+                        </a:lnSpc>
+                        <a:buNone/>
+                      </a:pPr>
                       <a:r>
                         <a:rPr b="0" lang="en-US" sz="3200" spc="-1" strike="noStrike">
                           <a:latin typeface="Arial"/>
@@ -5632,11 +5823,14 @@
                 </a:tc>
                 <a:tc>
                   <a:txBody>
-                    <a:bodyPr lIns="90000" rIns="90000" tIns="46800" bIns="46800" anchor="t">
+                    <a:bodyPr lIns="90000" rIns="90000" anchor="t">
                       <a:noAutofit/>
                     </a:bodyPr>
                     <a:p>
                       <a:pPr algn="ctr">
+                        <a:lnSpc>
+                          <a:spcPct val="100000"/>
+                        </a:lnSpc>
                         <a:buNone/>
                       </a:pPr>
                       <a:r>
@@ -5677,14 +5871,17 @@
                   </a:tcPr>
                 </a:tc>
               </a:tr>
-              <a:tr h="0">
+              <a:tr h="579240">
                 <a:tc>
                   <a:txBody>
-                    <a:bodyPr lIns="90000" rIns="90000" tIns="46800" bIns="46800" anchor="t">
+                    <a:bodyPr lIns="90000" rIns="90000" anchor="t">
                       <a:noAutofit/>
                     </a:bodyPr>
                     <a:p>
                       <a:pPr algn="ctr">
+                        <a:lnSpc>
+                          <a:spcPct val="100000"/>
+                        </a:lnSpc>
                         <a:buNone/>
                       </a:pPr>
                       <a:r>
@@ -5693,7 +5890,7 @@
                         </a:rPr>
                         <a:t>SSO</a:t>
                       </a:r>
-                      <a:endParaRPr b="1" lang="en-US" sz="3200" spc="-1" strike="noStrike">
+                      <a:endParaRPr b="0" lang="en-US" sz="3200" spc="-1" strike="noStrike">
                         <a:latin typeface="Arial"/>
                       </a:endParaRPr>
                     </a:p>
@@ -5726,11 +5923,14 @@
                 </a:tc>
                 <a:tc>
                   <a:txBody>
-                    <a:bodyPr lIns="90000" rIns="90000" tIns="46800" bIns="46800" anchor="t">
+                    <a:bodyPr lIns="90000" rIns="90000" anchor="t">
                       <a:noAutofit/>
                     </a:bodyPr>
                     <a:p>
                       <a:pPr algn="ctr">
+                        <a:lnSpc>
+                          <a:spcPct val="100000"/>
+                        </a:lnSpc>
                         <a:buNone/>
                       </a:pPr>
                       <a:r>
@@ -5772,10 +5972,16 @@
                 </a:tc>
                 <a:tc>
                   <a:txBody>
-                    <a:bodyPr lIns="90000" rIns="90000" tIns="46800" bIns="46800" anchor="t">
+                    <a:bodyPr lIns="90000" rIns="90000" anchor="t">
                       <a:noAutofit/>
                     </a:bodyPr>
                     <a:p>
+                      <a:pPr>
+                        <a:lnSpc>
+                          <a:spcPct val="100000"/>
+                        </a:lnSpc>
+                        <a:buNone/>
+                      </a:pPr>
                       <a:r>
                         <a:rPr b="0" lang="en-US" sz="3200" spc="-1" strike="noStrike">
                           <a:latin typeface="Arial"/>
@@ -5815,11 +6021,14 @@
                 </a:tc>
                 <a:tc>
                   <a:txBody>
-                    <a:bodyPr lIns="90000" rIns="90000" tIns="46800" bIns="46800" anchor="t">
+                    <a:bodyPr lIns="90000" rIns="90000" anchor="t">
                       <a:noAutofit/>
                     </a:bodyPr>
                     <a:p>
                       <a:pPr algn="ctr">
+                        <a:lnSpc>
+                          <a:spcPct val="100000"/>
+                        </a:lnSpc>
                         <a:buNone/>
                       </a:pPr>
                       <a:r>
@@ -5860,14 +6069,17 @@
                   </a:tcPr>
                 </a:tc>
               </a:tr>
-              <a:tr h="0">
+              <a:tr h="579240">
                 <a:tc>
                   <a:txBody>
-                    <a:bodyPr lIns="90000" rIns="90000" tIns="46800" bIns="46800" anchor="t">
+                    <a:bodyPr lIns="90000" rIns="90000" anchor="t">
                       <a:noAutofit/>
                     </a:bodyPr>
                     <a:p>
                       <a:pPr algn="ctr">
+                        <a:lnSpc>
+                          <a:spcPct val="100000"/>
+                        </a:lnSpc>
                         <a:buNone/>
                       </a:pPr>
                       <a:r>
@@ -5876,7 +6088,7 @@
                         </a:rPr>
                         <a:t>Convection</a:t>
                       </a:r>
-                      <a:endParaRPr b="1" lang="en-US" sz="3200" spc="-1" strike="noStrike">
+                      <a:endParaRPr b="0" lang="en-US" sz="3200" spc="-1" strike="noStrike">
                         <a:latin typeface="Arial"/>
                       </a:endParaRPr>
                     </a:p>
@@ -5909,11 +6121,14 @@
                 </a:tc>
                 <a:tc>
                   <a:txBody>
-                    <a:bodyPr lIns="90000" rIns="90000" tIns="46800" bIns="46800" anchor="t">
+                    <a:bodyPr lIns="90000" rIns="90000" anchor="t">
                       <a:noAutofit/>
                     </a:bodyPr>
                     <a:p>
                       <a:pPr algn="ctr">
+                        <a:lnSpc>
+                          <a:spcPct val="100000"/>
+                        </a:lnSpc>
                         <a:buNone/>
                       </a:pPr>
                       <a:r>
@@ -5955,10 +6170,16 @@
                 </a:tc>
                 <a:tc>
                   <a:txBody>
-                    <a:bodyPr lIns="90000" rIns="90000" tIns="46800" bIns="46800" anchor="t">
+                    <a:bodyPr lIns="90000" rIns="90000" anchor="t">
                       <a:noAutofit/>
                     </a:bodyPr>
                     <a:p>
+                      <a:pPr>
+                        <a:lnSpc>
+                          <a:spcPct val="100000"/>
+                        </a:lnSpc>
+                        <a:buNone/>
+                      </a:pPr>
                       <a:r>
                         <a:rPr b="0" lang="en-US" sz="3200" spc="-1" strike="noStrike">
                           <a:latin typeface="Arial"/>
@@ -5998,11 +6219,14 @@
                 </a:tc>
                 <a:tc>
                   <a:txBody>
-                    <a:bodyPr lIns="90000" rIns="90000" tIns="46800" bIns="46800" anchor="t">
+                    <a:bodyPr lIns="90000" rIns="90000" anchor="t">
                       <a:noAutofit/>
                     </a:bodyPr>
                     <a:p>
                       <a:pPr algn="ctr">
+                        <a:lnSpc>
+                          <a:spcPct val="100000"/>
+                        </a:lnSpc>
                         <a:buNone/>
                       </a:pPr>
                       <a:r>
@@ -6043,14 +6267,17 @@
                   </a:tcPr>
                 </a:tc>
               </a:tr>
-              <a:tr h="0">
+              <a:tr h="579240">
                 <a:tc>
                   <a:txBody>
-                    <a:bodyPr lIns="90000" rIns="90000" tIns="46800" bIns="46800" anchor="t">
+                    <a:bodyPr lIns="90000" rIns="90000" anchor="t">
                       <a:noAutofit/>
                     </a:bodyPr>
                     <a:p>
                       <a:pPr algn="ctr">
+                        <a:lnSpc>
+                          <a:spcPct val="100000"/>
+                        </a:lnSpc>
                         <a:buNone/>
                       </a:pPr>
                       <a:r>
@@ -6059,7 +6286,7 @@
                         </a:rPr>
                         <a:t>Convection</a:t>
                       </a:r>
-                      <a:endParaRPr b="1" lang="en-US" sz="3200" spc="-1" strike="noStrike">
+                      <a:endParaRPr b="0" lang="en-US" sz="3200" spc="-1" strike="noStrike">
                         <a:latin typeface="Arial"/>
                       </a:endParaRPr>
                     </a:p>
@@ -6092,11 +6319,14 @@
                 </a:tc>
                 <a:tc>
                   <a:txBody>
-                    <a:bodyPr lIns="90000" rIns="90000" tIns="46800" bIns="46800" anchor="t">
+                    <a:bodyPr lIns="90000" rIns="90000" anchor="t">
                       <a:noAutofit/>
                     </a:bodyPr>
                     <a:p>
                       <a:pPr algn="ctr">
+                        <a:lnSpc>
+                          <a:spcPct val="100000"/>
+                        </a:lnSpc>
                         <a:buNone/>
                       </a:pPr>
                       <a:r>
@@ -6138,10 +6368,16 @@
                 </a:tc>
                 <a:tc>
                   <a:txBody>
-                    <a:bodyPr lIns="90000" rIns="90000" tIns="46800" bIns="46800" anchor="t">
+                    <a:bodyPr lIns="90000" rIns="90000" anchor="t">
                       <a:noAutofit/>
                     </a:bodyPr>
                     <a:p>
+                      <a:pPr>
+                        <a:lnSpc>
+                          <a:spcPct val="100000"/>
+                        </a:lnSpc>
+                        <a:buNone/>
+                      </a:pPr>
                       <a:r>
                         <a:rPr b="0" lang="en-US" sz="3200" spc="-1" strike="noStrike">
                           <a:latin typeface="Arial"/>
@@ -6181,11 +6417,14 @@
                 </a:tc>
                 <a:tc>
                   <a:txBody>
-                    <a:bodyPr lIns="90000" rIns="90000" tIns="46800" bIns="46800" anchor="t">
+                    <a:bodyPr lIns="90000" rIns="90000" anchor="t">
                       <a:noAutofit/>
                     </a:bodyPr>
                     <a:p>
                       <a:pPr algn="ctr">
+                        <a:lnSpc>
+                          <a:spcPct val="100000"/>
+                        </a:lnSpc>
                         <a:buNone/>
                       </a:pPr>
                       <a:r>
@@ -6233,13 +6472,13 @@
       <p:sp>
         <p:nvSpPr>
           <p:cNvPr id="94" name=""/>
-          <p:cNvSpPr txBox="1"/>
+          <p:cNvSpPr/>
           <p:nvPr/>
         </p:nvSpPr>
         <p:spPr>
           <a:xfrm>
-            <a:off x="1780560" y="24957360"/>
-            <a:ext cx="23365800" cy="2369160"/>
+            <a:off x="1780560" y="23877360"/>
+            <a:ext cx="23365080" cy="2368440"/>
           </a:xfrm>
           <a:prstGeom prst="rect">
             <a:avLst/>
@@ -6249,20 +6488,40 @@
             <a:noFill/>
           </a:ln>
         </p:spPr>
+        <p:style>
+          <a:lnRef idx="0"/>
+          <a:fillRef idx="0"/>
+          <a:effectRef idx="0"/>
+          <a:fontRef idx="minor"/>
+        </p:style>
         <p:txBody>
           <a:bodyPr lIns="90000" rIns="90000" tIns="45000" bIns="45000" anchor="t">
             <a:noAutofit/>
           </a:bodyPr>
           <a:p>
+            <a:pPr>
+              <a:lnSpc>
+                <a:spcPct val="100000"/>
+              </a:lnSpc>
+              <a:buNone/>
+            </a:pPr>
             <a:r>
               <a:rPr b="1" lang="en-US" sz="3200" spc="-1" strike="noStrike">
+                <a:solidFill>
+                  <a:srgbClr val="000000"/>
+                </a:solidFill>
                 <a:latin typeface="Arial"/>
+                <a:ea typeface="DejaVu Sans"/>
               </a:rPr>
               <a:t>Table 1:</a:t>
             </a:r>
             <a:r>
               <a:rPr b="0" lang="en-US" sz="3200" spc="-1" strike="noStrike">
+                <a:solidFill>
+                  <a:srgbClr val="000000"/>
+                </a:solidFill>
                 <a:latin typeface="Arial"/>
+                <a:ea typeface="DejaVu Sans"/>
               </a:rPr>
               <a:t> We begin with a single scalar parameter in a single physics scheme (e.g., GWD/gfluxlaun) and quantify its impact on the resulting tendency fields. We then extend to multiple parameters within a scheme and eventually to combinations of parameterizations, enabling analysis of parameter interactions and contributions to model tendencies.</a:t>
             </a:r>
@@ -6271,11 +6530,23 @@
             </a:endParaRPr>
           </a:p>
           <a:p>
+            <a:pPr>
+              <a:lnSpc>
+                <a:spcPct val="100000"/>
+              </a:lnSpc>
+              <a:buNone/>
+            </a:pPr>
             <a:endParaRPr b="0" lang="en-US" sz="3200" spc="-1" strike="noStrike">
               <a:latin typeface="Arial"/>
             </a:endParaRPr>
           </a:p>
           <a:p>
+            <a:pPr>
+              <a:lnSpc>
+                <a:spcPct val="100000"/>
+              </a:lnSpc>
+              <a:buNone/>
+            </a:pPr>
             <a:endParaRPr b="0" lang="en-US" sz="3200" spc="-1" strike="noStrike">
               <a:latin typeface="Arial"/>
             </a:endParaRPr>
@@ -6295,7 +6566,7 @@
         <p:spPr>
           <a:xfrm>
             <a:off x="1816200" y="27552600"/>
-            <a:ext cx="3200400" cy="1506960"/>
+            <a:ext cx="3199680" cy="1506240"/>
           </a:xfrm>
           <a:prstGeom prst="rect">
             <a:avLst/>
@@ -6318,7 +6589,7 @@
         <p:spPr>
           <a:xfrm>
             <a:off x="9354600" y="27531000"/>
-            <a:ext cx="5308560" cy="1551240"/>
+            <a:ext cx="5307840" cy="1550520"/>
           </a:xfrm>
           <a:prstGeom prst="rect">
             <a:avLst/>
@@ -6340,8 +6611,8 @@
         </p:blipFill>
         <p:spPr>
           <a:xfrm>
-            <a:off x="8406000" y="26505360"/>
-            <a:ext cx="12133080" cy="892440"/>
+            <a:off x="8406000" y="26037360"/>
+            <a:ext cx="12132360" cy="891720"/>
           </a:xfrm>
           <a:prstGeom prst="rect">
             <a:avLst/>
@@ -6360,7 +6631,7 @@
         <p:spPr>
           <a:xfrm>
             <a:off x="5464800" y="28117800"/>
-            <a:ext cx="3429000" cy="457200"/>
+            <a:ext cx="3428280" cy="456480"/>
           </a:xfrm>
           <a:custGeom>
             <a:avLst/>
@@ -6423,7 +6694,7 @@
         <p:spPr>
           <a:xfrm>
             <a:off x="18412200" y="27660600"/>
-            <a:ext cx="7093080" cy="1317960"/>
+            <a:ext cx="7092360" cy="1317240"/>
           </a:xfrm>
           <a:prstGeom prst="rect">
             <a:avLst/>
@@ -6442,7 +6713,7 @@
         <p:spPr>
           <a:xfrm>
             <a:off x="14860800" y="28082160"/>
-            <a:ext cx="3429000" cy="457200"/>
+            <a:ext cx="3428280" cy="456480"/>
           </a:xfrm>
           <a:custGeom>
             <a:avLst/>
@@ -6495,13 +6766,13 @@
       <p:sp>
         <p:nvSpPr>
           <p:cNvPr id="101" name=""/>
-          <p:cNvSpPr txBox="1"/>
+          <p:cNvSpPr/>
           <p:nvPr/>
         </p:nvSpPr>
         <p:spPr>
           <a:xfrm>
             <a:off x="26517600" y="14824800"/>
-            <a:ext cx="14859000" cy="8311320"/>
+            <a:ext cx="14858280" cy="8310600"/>
           </a:xfrm>
           <a:prstGeom prst="rect">
             <a:avLst/>
@@ -6511,93 +6782,16 @@
             <a:noFill/>
           </a:ln>
         </p:spPr>
+        <p:style>
+          <a:lnRef idx="0"/>
+          <a:fillRef idx="0"/>
+          <a:effectRef idx="0"/>
+          <a:fontRef idx="minor"/>
+        </p:style>
         <p:txBody>
           <a:bodyPr lIns="90000" rIns="90000" tIns="45000" bIns="45000" anchor="t">
             <a:noAutofit/>
           </a:bodyPr>
-          <a:p>
-            <a:pPr marL="216000" indent="-216000">
-              <a:buClr>
-                <a:srgbClr val="000000"/>
-              </a:buClr>
-              <a:buSzPct val="45000"/>
-              <a:buFont typeface="Wingdings" charset="2"/>
-              <a:buChar char=""/>
-            </a:pPr>
-            <a:r>
-              <a:rPr b="1" lang="en-US" sz="3200" spc="-1" strike="noStrike">
-                <a:latin typeface="Arial"/>
-              </a:rPr>
-              <a:t>More Challenges</a:t>
-            </a:r>
-            <a:endParaRPr b="0" lang="en-US" sz="3200" spc="-1" strike="noStrike">
-              <a:latin typeface="Arial"/>
-            </a:endParaRPr>
-          </a:p>
-          <a:p>
-            <a:pPr marL="216000" indent="-216000">
-              <a:buClr>
-                <a:srgbClr val="000000"/>
-              </a:buClr>
-              <a:buSzPct val="45000"/>
-              <a:buFont typeface="Wingdings" charset="2"/>
-              <a:buChar char=""/>
-            </a:pPr>
-            <a:r>
-              <a:rPr b="0" lang="en-US" sz="3200" spc="-1" strike="noStrike">
-                <a:latin typeface="Arial"/>
-              </a:rPr>
-              <a:t>ICON combines large legacy Fortran code with MPI, OpenMP/OpenACC, external libraries and complex build infrastructure.</a:t>
-            </a:r>
-            <a:endParaRPr b="0" lang="en-US" sz="3200" spc="-1" strike="noStrike">
-              <a:latin typeface="Arial"/>
-            </a:endParaRPr>
-          </a:p>
-          <a:p>
-            <a:pPr marL="216000" indent="-216000">
-              <a:buClr>
-                <a:srgbClr val="000000"/>
-              </a:buClr>
-              <a:buSzPct val="45000"/>
-              <a:buFont typeface="Wingdings" charset="2"/>
-              <a:buChar char=""/>
-            </a:pPr>
-            <a:r>
-              <a:rPr b="0" lang="en-US" sz="3200" spc="-1" strike="noStrike">
-                <a:latin typeface="Arial"/>
-              </a:rPr>
-              <a:t>Enzyme has demonstrated differentiation of parallel constructs, but scaling these capabilities to ICON's Fortran implementation requires validation.</a:t>
-            </a:r>
-            <a:endParaRPr b="0" lang="en-US" sz="3200" spc="-1" strike="noStrike">
-              <a:latin typeface="Arial"/>
-            </a:endParaRPr>
-          </a:p>
-          <a:p>
-            <a:pPr marL="216000" indent="-216000">
-              <a:buClr>
-                <a:srgbClr val="000000"/>
-              </a:buClr>
-              <a:buSzPct val="45000"/>
-              <a:buFont typeface="Wingdings" charset="2"/>
-              <a:buChar char=""/>
-            </a:pPr>
-            <a:endParaRPr b="0" lang="en-US" sz="3200" spc="-1" strike="noStrike">
-              <a:latin typeface="Arial"/>
-            </a:endParaRPr>
-          </a:p>
-          <a:p>
-            <a:pPr marL="216000" indent="-216000">
-              <a:buClr>
-                <a:srgbClr val="000000"/>
-              </a:buClr>
-              <a:buSzPct val="45000"/>
-              <a:buFont typeface="Wingdings" charset="2"/>
-              <a:buChar char=""/>
-            </a:pPr>
-            <a:endParaRPr b="0" lang="en-US" sz="3200" spc="-1" strike="noStrike">
-              <a:latin typeface="Arial"/>
-            </a:endParaRPr>
-          </a:p>
           <a:p>
             <a:pPr marL="216000" indent="-216000">
               <a:lnSpc>
@@ -6612,9 +6806,13 @@
             </a:pPr>
             <a:r>
               <a:rPr b="1" lang="en-US" sz="3200" spc="-1" strike="noStrike">
+                <a:solidFill>
+                  <a:srgbClr val="000000"/>
+                </a:solidFill>
                 <a:latin typeface="Arial"/>
+                <a:ea typeface="DejaVu Sans"/>
               </a:rPr>
-              <a:t>Outlook</a:t>
+              <a:t>More Challenges</a:t>
             </a:r>
             <a:endParaRPr b="0" lang="en-US" sz="3200" spc="-1" strike="noStrike">
               <a:latin typeface="Arial"/>
@@ -6634,9 +6832,13 @@
             </a:pPr>
             <a:r>
               <a:rPr b="0" lang="en-US" sz="3200" spc="-1" strike="noStrike">
+                <a:solidFill>
+                  <a:srgbClr val="000000"/>
+                </a:solidFill>
                 <a:latin typeface="Arial"/>
+                <a:ea typeface="DejaVu Sans"/>
               </a:rPr>
-              <a:t>From ICON to other ESMs: Establish a general workflow for compiler-based AD of large-scale Fortran models.</a:t>
+              <a:t>ICON combines large legacy Fortran code with MPI, OpenMP/OpenACC, external libraries and complex build infrastructure.</a:t>
             </a:r>
             <a:endParaRPr b="0" lang="en-US" sz="3200" spc="-1" strike="noStrike">
               <a:latin typeface="Arial"/>
@@ -6656,9 +6858,61 @@
             </a:pPr>
             <a:r>
               <a:rPr b="0" lang="en-US" sz="3200" spc="-1" strike="noStrike">
+                <a:solidFill>
+                  <a:srgbClr val="000000"/>
+                </a:solidFill>
                 <a:latin typeface="Arial"/>
+                <a:ea typeface="DejaVu Sans"/>
               </a:rPr>
-              <a:t>Transferability: Potential pathway to models such as MITgcm, WRF, and CESM.</a:t>
+              <a:t>Enzyme has demonstrated differentiation of parallel constructs, but scaling these capabilities to ICON's Fortran implementation requires validation.</a:t>
+            </a:r>
+            <a:endParaRPr b="0" lang="en-US" sz="3200" spc="-1" strike="noStrike">
+              <a:latin typeface="Arial"/>
+            </a:endParaRPr>
+          </a:p>
+          <a:p>
+            <a:pPr>
+              <a:lnSpc>
+                <a:spcPct val="100000"/>
+              </a:lnSpc>
+              <a:buNone/>
+            </a:pPr>
+            <a:endParaRPr b="0" lang="en-US" sz="3200" spc="-1" strike="noStrike">
+              <a:latin typeface="Arial"/>
+            </a:endParaRPr>
+          </a:p>
+          <a:p>
+            <a:pPr>
+              <a:lnSpc>
+                <a:spcPct val="100000"/>
+              </a:lnSpc>
+              <a:buNone/>
+            </a:pPr>
+            <a:endParaRPr b="0" lang="en-US" sz="3200" spc="-1" strike="noStrike">
+              <a:latin typeface="Arial"/>
+            </a:endParaRPr>
+          </a:p>
+          <a:p>
+            <a:pPr marL="216000" indent="-216000">
+              <a:lnSpc>
+                <a:spcPct val="100000"/>
+              </a:lnSpc>
+              <a:buClr>
+                <a:srgbClr val="000000"/>
+              </a:buClr>
+              <a:buSzPct val="45000"/>
+              <a:buFont typeface="Wingdings" charset="2"/>
+              <a:buChar char=""/>
+            </a:pPr>
+            <a:r>
+              <a:rPr b="1" lang="en-US" sz="3200" spc="-1" strike="noStrike">
+                <a:solidFill>
+                  <a:srgbClr val="000000"/>
+                </a:solidFill>
+                <a:latin typeface="Arial"/>
+                <a:ea typeface="DejaVu Sans"/>
+              </a:rPr>
+              <a:t>Outlook</a:t>
             </a:r>
             <a:endParaRPr b="0" lang="en-US" sz="3200" spc="-1" strike="noStrike">
               <a:latin typeface="Arial"/>
@@ -6678,9 +6932,13 @@
             </a:pPr>
             <a:r>
               <a:rPr b="0" lang="en-US" sz="3200" spc="-1" strike="noStrike">
+                <a:solidFill>
+                  <a:srgbClr val="000000"/>
+                </a:solidFill>
                 <a:latin typeface="Arial"/>
+                <a:ea typeface="DejaVu Sans"/>
               </a:rPr>
-              <a:t>Scientific calibration: Extend from local parameter sensitivities to systematic model calibration.</a:t>
+              <a:t>From ICON to other ESMs: Establish a general workflow for compiler-based AD of large-scale Fortran models.</a:t>
             </a:r>
             <a:endParaRPr b="0" lang="en-US" sz="3200" spc="-1" strike="noStrike">
               <a:latin typeface="Arial"/>
@@ -6700,9 +6958,13 @@
             </a:pPr>
             <a:r>
               <a:rPr b="0" lang="en-US" sz="3200" spc="-1" strike="noStrike">
+                <a:solidFill>
+                  <a:srgbClr val="000000"/>
+                </a:solidFill>
                 <a:latin typeface="Arial"/>
+                <a:ea typeface="DejaVu Sans"/>
               </a:rPr>
-              <a:t>ML–physics coupling: Enable future online optimization of machine-learning parameterizations within the ESM.</a:t>
+              <a:t>Transferability: Potential pathway to models such as MITgcm, WRF, and CESM.</a:t>
             </a:r>
             <a:endParaRPr b="0" lang="en-US" sz="3200" spc="-1" strike="noStrike">
               <a:latin typeface="Arial"/>
@@ -6722,9 +6984,13 @@
             </a:pPr>
             <a:r>
               <a:rPr b="0" lang="en-US" sz="3200" spc="-1" strike="noStrike">
+                <a:solidFill>
+                  <a:srgbClr val="000000"/>
+                </a:solidFill>
                 <a:latin typeface="Arial"/>
+                <a:ea typeface="DejaVu Sans"/>
               </a:rPr>
-              <a:t>Long-term vision: Differentiable Earth-system modelling from the surface to the upper atmosphere.</a:t>
+              <a:t>Scientific calibration: Extend from local parameter sensitivities to systematic model calibration.</a:t>
             </a:r>
             <a:endParaRPr b="0" lang="en-US" sz="3200" spc="-1" strike="noStrike">
               <a:latin typeface="Arial"/>
@@ -6741,6 +7007,53 @@
               <a:buSzPct val="45000"/>
               <a:buFont typeface="Wingdings" charset="2"/>
               <a:buChar char=""/>
+            </a:pPr>
+            <a:r>
+              <a:rPr b="0" lang="en-US" sz="3200" spc="-1" strike="noStrike">
+                <a:solidFill>
+                  <a:srgbClr val="000000"/>
+                </a:solidFill>
+                <a:latin typeface="Arial"/>
+                <a:ea typeface="DejaVu Sans"/>
+              </a:rPr>
+              <a:t>ML–physics coupling: Enable future online optimization of machine-learning parameterizations within the ESM.</a:t>
+            </a:r>
+            <a:endParaRPr b="0" lang="en-US" sz="3200" spc="-1" strike="noStrike">
+              <a:latin typeface="Arial"/>
+            </a:endParaRPr>
+          </a:p>
+          <a:p>
+            <a:pPr marL="216000" indent="-216000">
+              <a:lnSpc>
+                <a:spcPct val="100000"/>
+              </a:lnSpc>
+              <a:buClr>
+                <a:srgbClr val="000000"/>
+              </a:buClr>
+              <a:buSzPct val="45000"/>
+              <a:buFont typeface="Wingdings" charset="2"/>
+              <a:buChar char=""/>
+            </a:pPr>
+            <a:r>
+              <a:rPr b="0" lang="en-US" sz="3200" spc="-1" strike="noStrike">
+                <a:solidFill>
+                  <a:srgbClr val="000000"/>
+                </a:solidFill>
+                <a:latin typeface="Arial"/>
+                <a:ea typeface="DejaVu Sans"/>
+              </a:rPr>
+              <a:t>Long-term vision: Differentiable Earth-system modelling from the surface to the upper atmosphere.</a:t>
+            </a:r>
+            <a:endParaRPr b="0" lang="en-US" sz="3200" spc="-1" strike="noStrike">
+              <a:latin typeface="Arial"/>
+            </a:endParaRPr>
+          </a:p>
+          <a:p>
+            <a:pPr>
+              <a:lnSpc>
+                <a:spcPct val="100000"/>
+              </a:lnSpc>
+              <a:buNone/>
             </a:pPr>
             <a:endParaRPr b="0" lang="en-US" sz="3200" spc="-1" strike="noStrike">
               <a:latin typeface="Arial"/>

</xml_diff>